<commit_message>
Make workshop closing links clickable
</commit_message>
<xml_diff>
--- a/static/iim-workshop-activepieces/supplier-risk-follow-up-activepieces-workshop.pptx
+++ b/static/iim-workshop-activepieces/supplier-risk-follow-up-activepieces-workshop.pptx
@@ -2,32 +2,32 @@
 <file path=ppt/presentation.xml><?xml version="1.0" encoding="utf-8"?>
 <p:presentation xmlns:p="http://schemas.openxmlformats.org/presentationml/2006/main">
   <p:sldMasterIdLst>
-    <p:sldMasterId xmlns:r="http://schemas.openxmlformats.org/officeDocument/2006/relationships" id="2147483648" r:id="Re39ac4b5ea984513"/>
+    <p:sldMasterId xmlns:r="http://schemas.openxmlformats.org/officeDocument/2006/relationships" id="2147483648" r:id="R10f312c25c114a0d"/>
   </p:sldMasterIdLst>
   <p:notesMasterIdLst>
-    <p:notesMasterId xmlns:r="http://schemas.openxmlformats.org/officeDocument/2006/relationships" r:id="R79ee5420d0aa4057"/>
+    <p:notesMasterId xmlns:r="http://schemas.openxmlformats.org/officeDocument/2006/relationships" r:id="R15f3aa0d67754b2a"/>
   </p:notesMasterIdLst>
   <p:sldIdLst>
-    <p:sldId xmlns:r="http://schemas.openxmlformats.org/officeDocument/2006/relationships" id="256" r:id="R4992968fedc04269"/>
-    <p:sldId xmlns:r="http://schemas.openxmlformats.org/officeDocument/2006/relationships" id="257" r:id="R7b94269c72c94ee5"/>
-    <p:sldId xmlns:r="http://schemas.openxmlformats.org/officeDocument/2006/relationships" id="258" r:id="R39d60f8174b64e41"/>
-    <p:sldId xmlns:r="http://schemas.openxmlformats.org/officeDocument/2006/relationships" id="259" r:id="R33aa154c0c47448e"/>
-    <p:sldId xmlns:r="http://schemas.openxmlformats.org/officeDocument/2006/relationships" id="260" r:id="R13070711641c4670"/>
-    <p:sldId xmlns:r="http://schemas.openxmlformats.org/officeDocument/2006/relationships" id="261" r:id="Raf0a9bb355de4ffc"/>
-    <p:sldId xmlns:r="http://schemas.openxmlformats.org/officeDocument/2006/relationships" id="262" r:id="Rc3d75c8ea72c4a1a"/>
-    <p:sldId xmlns:r="http://schemas.openxmlformats.org/officeDocument/2006/relationships" id="263" r:id="R1e3705083fd24a7e"/>
-    <p:sldId xmlns:r="http://schemas.openxmlformats.org/officeDocument/2006/relationships" id="264" r:id="Ra9dcfe5418404f2f"/>
-    <p:sldId xmlns:r="http://schemas.openxmlformats.org/officeDocument/2006/relationships" id="265" r:id="Rd2873919abfd4327"/>
-    <p:sldId xmlns:r="http://schemas.openxmlformats.org/officeDocument/2006/relationships" id="266" r:id="Ra22eeb7852fb4a9b"/>
-    <p:sldId xmlns:r="http://schemas.openxmlformats.org/officeDocument/2006/relationships" id="267" r:id="R275d695e71c4451e"/>
-    <p:sldId xmlns:r="http://schemas.openxmlformats.org/officeDocument/2006/relationships" id="268" r:id="Rb7957a7a9a9843cf"/>
-    <p:sldId xmlns:r="http://schemas.openxmlformats.org/officeDocument/2006/relationships" id="269" r:id="R9c71cb61db70419a"/>
-    <p:sldId xmlns:r="http://schemas.openxmlformats.org/officeDocument/2006/relationships" id="270" r:id="R35ebc0c5f5b9461a"/>
-    <p:sldId xmlns:r="http://schemas.openxmlformats.org/officeDocument/2006/relationships" id="271" r:id="R00d425f72bcb4559"/>
-    <p:sldId xmlns:r="http://schemas.openxmlformats.org/officeDocument/2006/relationships" id="272" r:id="R177fd0152a494729"/>
-    <p:sldId xmlns:r="http://schemas.openxmlformats.org/officeDocument/2006/relationships" id="273" r:id="Re4bb5cccff534b3e"/>
-    <p:sldId xmlns:r="http://schemas.openxmlformats.org/officeDocument/2006/relationships" id="274" r:id="Rb790a1f118ba410d"/>
-    <p:sldId xmlns:r="http://schemas.openxmlformats.org/officeDocument/2006/relationships" id="275" r:id="Rfad5ad1e40a84614"/>
+    <p:sldId xmlns:r="http://schemas.openxmlformats.org/officeDocument/2006/relationships" id="256" r:id="Re39d368fa84243b8"/>
+    <p:sldId xmlns:r="http://schemas.openxmlformats.org/officeDocument/2006/relationships" id="257" r:id="R2a3cb564c285417c"/>
+    <p:sldId xmlns:r="http://schemas.openxmlformats.org/officeDocument/2006/relationships" id="258" r:id="Rfa65bb38ce754caa"/>
+    <p:sldId xmlns:r="http://schemas.openxmlformats.org/officeDocument/2006/relationships" id="259" r:id="Ra9ba11a8a01c47db"/>
+    <p:sldId xmlns:r="http://schemas.openxmlformats.org/officeDocument/2006/relationships" id="260" r:id="R93904651242c4629"/>
+    <p:sldId xmlns:r="http://schemas.openxmlformats.org/officeDocument/2006/relationships" id="261" r:id="R138095052bd24b34"/>
+    <p:sldId xmlns:r="http://schemas.openxmlformats.org/officeDocument/2006/relationships" id="262" r:id="R3f6611478e154fb2"/>
+    <p:sldId xmlns:r="http://schemas.openxmlformats.org/officeDocument/2006/relationships" id="263" r:id="Rc5984a895f4e45f4"/>
+    <p:sldId xmlns:r="http://schemas.openxmlformats.org/officeDocument/2006/relationships" id="264" r:id="R023d3a40c3db4eef"/>
+    <p:sldId xmlns:r="http://schemas.openxmlformats.org/officeDocument/2006/relationships" id="265" r:id="R91554830d6784a7a"/>
+    <p:sldId xmlns:r="http://schemas.openxmlformats.org/officeDocument/2006/relationships" id="266" r:id="R680c85ea3e1443a3"/>
+    <p:sldId xmlns:r="http://schemas.openxmlformats.org/officeDocument/2006/relationships" id="267" r:id="R51023e3abcec4994"/>
+    <p:sldId xmlns:r="http://schemas.openxmlformats.org/officeDocument/2006/relationships" id="268" r:id="Rd3a4c5e0998c4aae"/>
+    <p:sldId xmlns:r="http://schemas.openxmlformats.org/officeDocument/2006/relationships" id="269" r:id="Rcda2dd0e5b714d2e"/>
+    <p:sldId xmlns:r="http://schemas.openxmlformats.org/officeDocument/2006/relationships" id="270" r:id="R0e524e7aee76496c"/>
+    <p:sldId xmlns:r="http://schemas.openxmlformats.org/officeDocument/2006/relationships" id="271" r:id="R6aeae080040f4a2f"/>
+    <p:sldId xmlns:r="http://schemas.openxmlformats.org/officeDocument/2006/relationships" id="272" r:id="R8f94e4cfd4ee4d11"/>
+    <p:sldId xmlns:r="http://schemas.openxmlformats.org/officeDocument/2006/relationships" id="273" r:id="Rcca0830d6f994518"/>
+    <p:sldId xmlns:r="http://schemas.openxmlformats.org/officeDocument/2006/relationships" id="274" r:id="R1cc6c5c7bcd24a5d"/>
+    <p:sldId xmlns:r="http://schemas.openxmlformats.org/officeDocument/2006/relationships" id="275" r:id="Ra09fa5514fbb40d3"/>
   </p:sldIdLst>
   <p:sldSz cx="12192000" cy="6858000"/>
   <p:notesSz cx="6858000" cy="9144000"/>
@@ -2929,7 +2929,7 @@
   </p:cSld>
   <p:clrMap bg1="lt1" tx1="dk1" bg2="lt2" tx2="dk2" accent1="accent1" accent2="accent2" accent3="accent3" accent4="accent4" accent5="accent5" accent6="accent6" hlink="hlink" folHlink="folHlink"/>
   <p:sldLayoutIdLst>
-    <p:sldLayoutId xmlns:r="http://schemas.openxmlformats.org/officeDocument/2006/relationships" id="2147483649" r:id="R8acf1d2515c64987"/>
+    <p:sldLayoutId xmlns:r="http://schemas.openxmlformats.org/officeDocument/2006/relationships" id="2147483649" r:id="R32ffde589fbb4adf"/>
   </p:sldLayoutIdLst>
   <p:txStyles>
     <p:titleStyle>
@@ -3480,7 +3480,7 @@
           <p:cNvPr id="25" name="">
             <a:extLst xmlns:a="http://schemas.openxmlformats.org/drawingml/2006/main">
               <a:ext uri="{FF2B5EF4-FFF2-40B4-BE49-F238E27FC236}">
-                <a16:creationId xmlns:a16="http://schemas.microsoft.com/office/drawing/2014/main" id="{829FA100-FB23-4326-994F-030925841A11}"/>
+                <a16:creationId xmlns:a16="http://schemas.microsoft.com/office/drawing/2014/main" id="{71CEB87F-0D71-4F16-8DE8-B3B0E9361B8C}"/>
               </a:ext>
             </a:extLst>
           </p:cNvPr>
@@ -3511,7 +3511,7 @@
           <p:cNvPr id="2" name="">
             <a:extLst xmlns:a="http://schemas.openxmlformats.org/drawingml/2006/main">
               <a:ext uri="{FF2B5EF4-FFF2-40B4-BE49-F238E27FC236}">
-                <a16:creationId xmlns:a16="http://schemas.microsoft.com/office/drawing/2014/main" id="{74D86C87-AB04-46AA-8E06-98420C0C2387}"/>
+                <a16:creationId xmlns:a16="http://schemas.microsoft.com/office/drawing/2014/main" id="{7019F2EA-8763-4A94-92C4-C5436E6E1BC6}"/>
               </a:ext>
             </a:extLst>
           </p:cNvPr>
@@ -3542,7 +3542,7 @@
           <p:cNvPr id="3" name="">
             <a:extLst xmlns:a="http://schemas.openxmlformats.org/drawingml/2006/main">
               <a:ext uri="{FF2B5EF4-FFF2-40B4-BE49-F238E27FC236}">
-                <a16:creationId xmlns:a16="http://schemas.microsoft.com/office/drawing/2014/main" id="{AD35E351-9218-47D4-8534-FEB7143E1CF6}"/>
+                <a16:creationId xmlns:a16="http://schemas.microsoft.com/office/drawing/2014/main" id="{F5A0BA2B-1A2B-4B77-8F52-A0794216465C}"/>
               </a:ext>
             </a:extLst>
           </p:cNvPr>
@@ -3599,7 +3599,7 @@
           <p:cNvPr id="4" name="">
             <a:extLst xmlns:a="http://schemas.openxmlformats.org/drawingml/2006/main">
               <a:ext uri="{FF2B5EF4-FFF2-40B4-BE49-F238E27FC236}">
-                <a16:creationId xmlns:a16="http://schemas.microsoft.com/office/drawing/2014/main" id="{7BA8FAA9-84F4-427A-A7DB-741C56C5CB72}"/>
+                <a16:creationId xmlns:a16="http://schemas.microsoft.com/office/drawing/2014/main" id="{DFAF9855-5635-409D-860D-0F7EC668B04A}"/>
               </a:ext>
             </a:extLst>
           </p:cNvPr>
@@ -3656,7 +3656,7 @@
           <p:cNvPr id="5" name="">
             <a:extLst xmlns:a="http://schemas.openxmlformats.org/drawingml/2006/main">
               <a:ext uri="{FF2B5EF4-FFF2-40B4-BE49-F238E27FC236}">
-                <a16:creationId xmlns:a16="http://schemas.microsoft.com/office/drawing/2014/main" id="{F53912EA-63D5-4ABA-A920-81866ACC865F}"/>
+                <a16:creationId xmlns:a16="http://schemas.microsoft.com/office/drawing/2014/main" id="{03E6A94B-52C3-40CB-B742-96FB45EA849B}"/>
               </a:ext>
             </a:extLst>
           </p:cNvPr>
@@ -3713,7 +3713,7 @@
           <p:cNvPr id="6" name="">
             <a:extLst xmlns:a="http://schemas.openxmlformats.org/drawingml/2006/main">
               <a:ext uri="{FF2B5EF4-FFF2-40B4-BE49-F238E27FC236}">
-                <a16:creationId xmlns:a16="http://schemas.microsoft.com/office/drawing/2014/main" id="{50ED85C2-A400-4013-82E2-5DE037B50D00}"/>
+                <a16:creationId xmlns:a16="http://schemas.microsoft.com/office/drawing/2014/main" id="{CCA424B7-DFE9-4518-90D9-022FAE7BF932}"/>
               </a:ext>
             </a:extLst>
           </p:cNvPr>
@@ -3770,7 +3770,7 @@
           <p:cNvPr id="7" name="">
             <a:extLst xmlns:a="http://schemas.openxmlformats.org/drawingml/2006/main">
               <a:ext uri="{FF2B5EF4-FFF2-40B4-BE49-F238E27FC236}">
-                <a16:creationId xmlns:a16="http://schemas.microsoft.com/office/drawing/2014/main" id="{CF3C7CFE-CCBD-4C2E-9242-2A57F8A9CA71}"/>
+                <a16:creationId xmlns:a16="http://schemas.microsoft.com/office/drawing/2014/main" id="{AB334475-ECCE-4AC5-9245-7EFDFFBEBF6A}"/>
               </a:ext>
             </a:extLst>
           </p:cNvPr>
@@ -3801,7 +3801,7 @@
           <p:cNvPr id="8" name="">
             <a:extLst xmlns:a="http://schemas.openxmlformats.org/drawingml/2006/main">
               <a:ext uri="{FF2B5EF4-FFF2-40B4-BE49-F238E27FC236}">
-                <a16:creationId xmlns:a16="http://schemas.microsoft.com/office/drawing/2014/main" id="{F58C155A-E674-4A9A-B383-2052A0CCACC5}"/>
+                <a16:creationId xmlns:a16="http://schemas.microsoft.com/office/drawing/2014/main" id="{B4AB90CD-81AE-4F85-BEA2-AC397112C438}"/>
               </a:ext>
             </a:extLst>
           </p:cNvPr>
@@ -3858,7 +3858,7 @@
           <p:cNvPr id="9" name="">
             <a:extLst xmlns:a="http://schemas.openxmlformats.org/drawingml/2006/main">
               <a:ext uri="{FF2B5EF4-FFF2-40B4-BE49-F238E27FC236}">
-                <a16:creationId xmlns:a16="http://schemas.microsoft.com/office/drawing/2014/main" id="{7F062820-616B-4A76-A7D2-2A0649D9CB7F}"/>
+                <a16:creationId xmlns:a16="http://schemas.microsoft.com/office/drawing/2014/main" id="{873C3CE9-0705-4EBD-BEBE-F4A6C3C05A69}"/>
               </a:ext>
             </a:extLst>
           </p:cNvPr>
@@ -3915,7 +3915,7 @@
           <p:cNvPr id="10" name="">
             <a:extLst xmlns:a="http://schemas.openxmlformats.org/drawingml/2006/main">
               <a:ext uri="{FF2B5EF4-FFF2-40B4-BE49-F238E27FC236}">
-                <a16:creationId xmlns:a16="http://schemas.microsoft.com/office/drawing/2014/main" id="{D39F72EC-ABE6-4C30-9E2E-D8B3EDA60283}"/>
+                <a16:creationId xmlns:a16="http://schemas.microsoft.com/office/drawing/2014/main" id="{9180757E-2E1E-46C1-935D-47A028AC760B}"/>
               </a:ext>
             </a:extLst>
           </p:cNvPr>
@@ -3948,7 +3948,7 @@
           <p:cNvPr id="11" name="">
             <a:extLst xmlns:a="http://schemas.openxmlformats.org/drawingml/2006/main">
               <a:ext uri="{FF2B5EF4-FFF2-40B4-BE49-F238E27FC236}">
-                <a16:creationId xmlns:a16="http://schemas.microsoft.com/office/drawing/2014/main" id="{32DB8728-5531-4F09-9C43-40020463ACD4}"/>
+                <a16:creationId xmlns:a16="http://schemas.microsoft.com/office/drawing/2014/main" id="{8DB1000E-A824-4E58-9DED-2CC660DA7385}"/>
               </a:ext>
             </a:extLst>
           </p:cNvPr>
@@ -3983,7 +3983,7 @@
           <p:cNvPr id="12" name="">
             <a:extLst xmlns:a="http://schemas.openxmlformats.org/drawingml/2006/main">
               <a:ext uri="{FF2B5EF4-FFF2-40B4-BE49-F238E27FC236}">
-                <a16:creationId xmlns:a16="http://schemas.microsoft.com/office/drawing/2014/main" id="{033FA957-3D78-4916-A72E-74876BE24AD4}"/>
+                <a16:creationId xmlns:a16="http://schemas.microsoft.com/office/drawing/2014/main" id="{6E64F7C1-9A74-4F3E-92BB-C24108BF921C}"/>
               </a:ext>
             </a:extLst>
           </p:cNvPr>
@@ -4040,7 +4040,7 @@
           <p:cNvPr id="13" name="">
             <a:extLst xmlns:a="http://schemas.openxmlformats.org/drawingml/2006/main">
               <a:ext uri="{FF2B5EF4-FFF2-40B4-BE49-F238E27FC236}">
-                <a16:creationId xmlns:a16="http://schemas.microsoft.com/office/drawing/2014/main" id="{6CA32968-6F51-4A40-AF10-3D5F576C66A6}"/>
+                <a16:creationId xmlns:a16="http://schemas.microsoft.com/office/drawing/2014/main" id="{BC136410-6BF1-4FA7-8D0E-27CB92E429B3}"/>
               </a:ext>
             </a:extLst>
           </p:cNvPr>
@@ -4097,7 +4097,7 @@
           <p:cNvPr id="14" name="">
             <a:extLst xmlns:a="http://schemas.openxmlformats.org/drawingml/2006/main">
               <a:ext uri="{FF2B5EF4-FFF2-40B4-BE49-F238E27FC236}">
-                <a16:creationId xmlns:a16="http://schemas.microsoft.com/office/drawing/2014/main" id="{B8ACB7A3-061A-43A2-B626-3B7C17FB813B}"/>
+                <a16:creationId xmlns:a16="http://schemas.microsoft.com/office/drawing/2014/main" id="{B1B20A48-ADE4-415B-826A-72ADF05EAFE1}"/>
               </a:ext>
             </a:extLst>
           </p:cNvPr>
@@ -4130,7 +4130,7 @@
           <p:cNvPr id="15" name="">
             <a:extLst xmlns:a="http://schemas.openxmlformats.org/drawingml/2006/main">
               <a:ext uri="{FF2B5EF4-FFF2-40B4-BE49-F238E27FC236}">
-                <a16:creationId xmlns:a16="http://schemas.microsoft.com/office/drawing/2014/main" id="{F67039C4-0323-4155-A4F5-2C8E426F5552}"/>
+                <a16:creationId xmlns:a16="http://schemas.microsoft.com/office/drawing/2014/main" id="{610BA66D-3892-4B3B-955F-C8DD2D163131}"/>
               </a:ext>
             </a:extLst>
           </p:cNvPr>
@@ -4165,7 +4165,7 @@
           <p:cNvPr id="16" name="">
             <a:extLst xmlns:a="http://schemas.openxmlformats.org/drawingml/2006/main">
               <a:ext uri="{FF2B5EF4-FFF2-40B4-BE49-F238E27FC236}">
-                <a16:creationId xmlns:a16="http://schemas.microsoft.com/office/drawing/2014/main" id="{BEDD3068-07B1-4A1B-A571-79143DE65B52}"/>
+                <a16:creationId xmlns:a16="http://schemas.microsoft.com/office/drawing/2014/main" id="{B0A74AE0-BBB4-4E2F-B9D9-A90974D2F251}"/>
               </a:ext>
             </a:extLst>
           </p:cNvPr>
@@ -4222,7 +4222,7 @@
           <p:cNvPr id="17" name="">
             <a:extLst xmlns:a="http://schemas.openxmlformats.org/drawingml/2006/main">
               <a:ext uri="{FF2B5EF4-FFF2-40B4-BE49-F238E27FC236}">
-                <a16:creationId xmlns:a16="http://schemas.microsoft.com/office/drawing/2014/main" id="{92F8207B-9E72-4E2A-B161-0A8839912FD8}"/>
+                <a16:creationId xmlns:a16="http://schemas.microsoft.com/office/drawing/2014/main" id="{EE7BE4AB-2614-4925-9B31-B789005E6FDE}"/>
               </a:ext>
             </a:extLst>
           </p:cNvPr>
@@ -4279,7 +4279,7 @@
           <p:cNvPr id="18" name="">
             <a:extLst xmlns:a="http://schemas.openxmlformats.org/drawingml/2006/main">
               <a:ext uri="{FF2B5EF4-FFF2-40B4-BE49-F238E27FC236}">
-                <a16:creationId xmlns:a16="http://schemas.microsoft.com/office/drawing/2014/main" id="{833E4D30-D383-4DCC-920C-08C8D00A8234}"/>
+                <a16:creationId xmlns:a16="http://schemas.microsoft.com/office/drawing/2014/main" id="{2406102D-3D3C-4498-8BF2-E44879B662EF}"/>
               </a:ext>
             </a:extLst>
           </p:cNvPr>
@@ -4312,7 +4312,7 @@
           <p:cNvPr id="19" name="">
             <a:extLst xmlns:a="http://schemas.openxmlformats.org/drawingml/2006/main">
               <a:ext uri="{FF2B5EF4-FFF2-40B4-BE49-F238E27FC236}">
-                <a16:creationId xmlns:a16="http://schemas.microsoft.com/office/drawing/2014/main" id="{ACEEEBCA-6D4E-4288-80BB-82C8326570E6}"/>
+                <a16:creationId xmlns:a16="http://schemas.microsoft.com/office/drawing/2014/main" id="{0B21E027-9759-43DA-AA84-DB3E59578036}"/>
               </a:ext>
             </a:extLst>
           </p:cNvPr>
@@ -4347,7 +4347,7 @@
           <p:cNvPr id="20" name="">
             <a:extLst xmlns:a="http://schemas.openxmlformats.org/drawingml/2006/main">
               <a:ext uri="{FF2B5EF4-FFF2-40B4-BE49-F238E27FC236}">
-                <a16:creationId xmlns:a16="http://schemas.microsoft.com/office/drawing/2014/main" id="{B8D6C240-D684-4B19-820E-43E1311E705E}"/>
+                <a16:creationId xmlns:a16="http://schemas.microsoft.com/office/drawing/2014/main" id="{D58C3FAF-0207-4ED6-BA4E-F59174EEC54D}"/>
               </a:ext>
             </a:extLst>
           </p:cNvPr>
@@ -4404,7 +4404,7 @@
           <p:cNvPr id="21" name="">
             <a:extLst xmlns:a="http://schemas.openxmlformats.org/drawingml/2006/main">
               <a:ext uri="{FF2B5EF4-FFF2-40B4-BE49-F238E27FC236}">
-                <a16:creationId xmlns:a16="http://schemas.microsoft.com/office/drawing/2014/main" id="{ACA8D690-6714-4C33-B3A5-8E5F99550800}"/>
+                <a16:creationId xmlns:a16="http://schemas.microsoft.com/office/drawing/2014/main" id="{1A9B4C5B-3FB7-4D21-891C-FB3F3598C2D5}"/>
               </a:ext>
             </a:extLst>
           </p:cNvPr>
@@ -4461,7 +4461,7 @@
           <p:cNvPr id="22" name="">
             <a:extLst xmlns:a="http://schemas.openxmlformats.org/drawingml/2006/main">
               <a:ext uri="{FF2B5EF4-FFF2-40B4-BE49-F238E27FC236}">
-                <a16:creationId xmlns:a16="http://schemas.microsoft.com/office/drawing/2014/main" id="{AED81E22-1823-40D2-87D0-D52AEDB978A2}"/>
+                <a16:creationId xmlns:a16="http://schemas.microsoft.com/office/drawing/2014/main" id="{668542C3-0A74-44A8-BD02-C414B1687139}"/>
               </a:ext>
             </a:extLst>
           </p:cNvPr>
@@ -4492,7 +4492,7 @@
           <p:cNvPr id="23" name="">
             <a:extLst xmlns:a="http://schemas.openxmlformats.org/drawingml/2006/main">
               <a:ext uri="{FF2B5EF4-FFF2-40B4-BE49-F238E27FC236}">
-                <a16:creationId xmlns:a16="http://schemas.microsoft.com/office/drawing/2014/main" id="{A73394E6-BCCD-4AE2-9940-732928E5B43F}"/>
+                <a16:creationId xmlns:a16="http://schemas.microsoft.com/office/drawing/2014/main" id="{59111399-DE6C-4F5F-816E-1702221137A7}"/>
               </a:ext>
             </a:extLst>
           </p:cNvPr>
@@ -4523,7 +4523,7 @@
           <p:cNvPr id="24" name="">
             <a:extLst xmlns:a="http://schemas.openxmlformats.org/drawingml/2006/main">
               <a:ext uri="{FF2B5EF4-FFF2-40B4-BE49-F238E27FC236}">
-                <a16:creationId xmlns:a16="http://schemas.microsoft.com/office/drawing/2014/main" id="{BD629C52-0FE9-4736-BE38-670CF39453A9}"/>
+                <a16:creationId xmlns:a16="http://schemas.microsoft.com/office/drawing/2014/main" id="{AEEFAE9F-D11D-494B-BADF-F34B2924F949}"/>
               </a:ext>
             </a:extLst>
           </p:cNvPr>
@@ -4578,7 +4578,7 @@
     </p:spTree>
     <p:extLst>
       <p:ext uri="{BB962C8B-B14F-4D97-AF65-F5344CB8AC3E}">
-        <p14:creationId xmlns:p14="http://schemas.microsoft.com/office/powerpoint/2010/main" val="2042673142"/>
+        <p14:creationId xmlns:p14="http://schemas.microsoft.com/office/powerpoint/2010/main" val="70783029"/>
       </p:ext>
     </p:extLst>
   </p:cSld>
@@ -4609,7 +4609,7 @@
           <p:cNvPr id="18" name="">
             <a:extLst xmlns:a="http://schemas.openxmlformats.org/drawingml/2006/main">
               <a:ext uri="{FF2B5EF4-FFF2-40B4-BE49-F238E27FC236}">
-                <a16:creationId xmlns:a16="http://schemas.microsoft.com/office/drawing/2014/main" id="{0DD9D210-9782-4D12-B779-74AAEC7D7D43}"/>
+                <a16:creationId xmlns:a16="http://schemas.microsoft.com/office/drawing/2014/main" id="{9E1CF171-8338-4A76-872B-0F3F7FCE7FF0}"/>
               </a:ext>
             </a:extLst>
           </p:cNvPr>
@@ -4640,7 +4640,7 @@
           <p:cNvPr id="2" name="">
             <a:extLst xmlns:a="http://schemas.openxmlformats.org/drawingml/2006/main">
               <a:ext uri="{FF2B5EF4-FFF2-40B4-BE49-F238E27FC236}">
-                <a16:creationId xmlns:a16="http://schemas.microsoft.com/office/drawing/2014/main" id="{B3C09419-320C-4062-924B-08BC48A7AE22}"/>
+                <a16:creationId xmlns:a16="http://schemas.microsoft.com/office/drawing/2014/main" id="{57026940-B49A-4E28-879D-4A8500C93BEB}"/>
               </a:ext>
             </a:extLst>
           </p:cNvPr>
@@ -4671,7 +4671,7 @@
           <p:cNvPr id="3" name="">
             <a:extLst xmlns:a="http://schemas.openxmlformats.org/drawingml/2006/main">
               <a:ext uri="{FF2B5EF4-FFF2-40B4-BE49-F238E27FC236}">
-                <a16:creationId xmlns:a16="http://schemas.microsoft.com/office/drawing/2014/main" id="{BBE7B342-0A0B-49BF-977E-D12A8797A32D}"/>
+                <a16:creationId xmlns:a16="http://schemas.microsoft.com/office/drawing/2014/main" id="{5C088E83-9B57-4087-9F9B-F18D025DE4DC}"/>
               </a:ext>
             </a:extLst>
           </p:cNvPr>
@@ -4728,7 +4728,7 @@
           <p:cNvPr id="4" name="">
             <a:extLst xmlns:a="http://schemas.openxmlformats.org/drawingml/2006/main">
               <a:ext uri="{FF2B5EF4-FFF2-40B4-BE49-F238E27FC236}">
-                <a16:creationId xmlns:a16="http://schemas.microsoft.com/office/drawing/2014/main" id="{B7F51705-60CA-4130-9232-E86F44F08D2B}"/>
+                <a16:creationId xmlns:a16="http://schemas.microsoft.com/office/drawing/2014/main" id="{04A47FB6-C6BA-4E70-A5E3-AC65B8EBA5F8}"/>
               </a:ext>
             </a:extLst>
           </p:cNvPr>
@@ -4785,7 +4785,7 @@
           <p:cNvPr id="5" name="">
             <a:extLst xmlns:a="http://schemas.openxmlformats.org/drawingml/2006/main">
               <a:ext uri="{FF2B5EF4-FFF2-40B4-BE49-F238E27FC236}">
-                <a16:creationId xmlns:a16="http://schemas.microsoft.com/office/drawing/2014/main" id="{1FB44700-B7B3-4A84-8C88-AE8CCCC0031C}"/>
+                <a16:creationId xmlns:a16="http://schemas.microsoft.com/office/drawing/2014/main" id="{F8781763-90BB-4A91-A78E-D49AB9E55E31}"/>
               </a:ext>
             </a:extLst>
           </p:cNvPr>
@@ -4818,7 +4818,7 @@
           <p:cNvPr id="6" name="">
             <a:extLst xmlns:a="http://schemas.openxmlformats.org/drawingml/2006/main">
               <a:ext uri="{FF2B5EF4-FFF2-40B4-BE49-F238E27FC236}">
-                <a16:creationId xmlns:a16="http://schemas.microsoft.com/office/drawing/2014/main" id="{23A89725-308A-4511-9598-18DBA55723DE}"/>
+                <a16:creationId xmlns:a16="http://schemas.microsoft.com/office/drawing/2014/main" id="{296BAAD8-CDC1-4E8C-BC6C-0FDEFCED7FB9}"/>
               </a:ext>
             </a:extLst>
           </p:cNvPr>
@@ -4853,7 +4853,7 @@
           <p:cNvPr id="7" name="">
             <a:extLst xmlns:a="http://schemas.openxmlformats.org/drawingml/2006/main">
               <a:ext uri="{FF2B5EF4-FFF2-40B4-BE49-F238E27FC236}">
-                <a16:creationId xmlns:a16="http://schemas.microsoft.com/office/drawing/2014/main" id="{6D1BD54F-5257-4522-B1BD-FA69C9E2BF17}"/>
+                <a16:creationId xmlns:a16="http://schemas.microsoft.com/office/drawing/2014/main" id="{8809007F-1A7D-44EA-BAF0-53AC5B247945}"/>
               </a:ext>
             </a:extLst>
           </p:cNvPr>
@@ -4910,7 +4910,7 @@
           <p:cNvPr id="8" name="">
             <a:extLst xmlns:a="http://schemas.openxmlformats.org/drawingml/2006/main">
               <a:ext uri="{FF2B5EF4-FFF2-40B4-BE49-F238E27FC236}">
-                <a16:creationId xmlns:a16="http://schemas.microsoft.com/office/drawing/2014/main" id="{E511307C-AC71-4796-A75D-18234F4AE457}"/>
+                <a16:creationId xmlns:a16="http://schemas.microsoft.com/office/drawing/2014/main" id="{2205FADF-5661-45F1-A6FC-42BA57AA29CC}"/>
               </a:ext>
             </a:extLst>
           </p:cNvPr>
@@ -4967,7 +4967,7 @@
           <p:cNvPr id="9" name="">
             <a:extLst xmlns:a="http://schemas.openxmlformats.org/drawingml/2006/main">
               <a:ext uri="{FF2B5EF4-FFF2-40B4-BE49-F238E27FC236}">
-                <a16:creationId xmlns:a16="http://schemas.microsoft.com/office/drawing/2014/main" id="{CBECBFD5-2F80-4F47-B664-0877F906B1B9}"/>
+                <a16:creationId xmlns:a16="http://schemas.microsoft.com/office/drawing/2014/main" id="{DCCBB38E-9B91-4804-B693-E5A5DBAD4CD1}"/>
               </a:ext>
             </a:extLst>
           </p:cNvPr>
@@ -5024,7 +5024,7 @@
           <p:cNvPr id="10" name="">
             <a:extLst xmlns:a="http://schemas.openxmlformats.org/drawingml/2006/main">
               <a:ext uri="{FF2B5EF4-FFF2-40B4-BE49-F238E27FC236}">
-                <a16:creationId xmlns:a16="http://schemas.microsoft.com/office/drawing/2014/main" id="{228EF236-3206-4A85-9FBE-E43061E8E0FB}"/>
+                <a16:creationId xmlns:a16="http://schemas.microsoft.com/office/drawing/2014/main" id="{5BCCE19F-438A-47CA-AE31-28A8049B8014}"/>
               </a:ext>
             </a:extLst>
           </p:cNvPr>
@@ -5057,7 +5057,7 @@
           <p:cNvPr id="11" name="">
             <a:extLst xmlns:a="http://schemas.openxmlformats.org/drawingml/2006/main">
               <a:ext uri="{FF2B5EF4-FFF2-40B4-BE49-F238E27FC236}">
-                <a16:creationId xmlns:a16="http://schemas.microsoft.com/office/drawing/2014/main" id="{E7E03619-D951-4DD5-B7E4-E381D0A423FB}"/>
+                <a16:creationId xmlns:a16="http://schemas.microsoft.com/office/drawing/2014/main" id="{7167DED7-E3AD-45B9-B090-9157278AAB73}"/>
               </a:ext>
             </a:extLst>
           </p:cNvPr>
@@ -5092,7 +5092,7 @@
           <p:cNvPr id="12" name="">
             <a:extLst xmlns:a="http://schemas.openxmlformats.org/drawingml/2006/main">
               <a:ext uri="{FF2B5EF4-FFF2-40B4-BE49-F238E27FC236}">
-                <a16:creationId xmlns:a16="http://schemas.microsoft.com/office/drawing/2014/main" id="{3C719AEF-8C61-4FAF-A1D7-F7AB4284C623}"/>
+                <a16:creationId xmlns:a16="http://schemas.microsoft.com/office/drawing/2014/main" id="{0071518D-C05E-4E7D-AAB0-3F5ED43ED5A3}"/>
               </a:ext>
             </a:extLst>
           </p:cNvPr>
@@ -5149,7 +5149,7 @@
           <p:cNvPr id="13" name="">
             <a:extLst xmlns:a="http://schemas.openxmlformats.org/drawingml/2006/main">
               <a:ext uri="{FF2B5EF4-FFF2-40B4-BE49-F238E27FC236}">
-                <a16:creationId xmlns:a16="http://schemas.microsoft.com/office/drawing/2014/main" id="{9E3522A2-C544-4D40-A9DD-802806421C2D}"/>
+                <a16:creationId xmlns:a16="http://schemas.microsoft.com/office/drawing/2014/main" id="{C1001638-925F-490B-B09C-2DE613F80001}"/>
               </a:ext>
             </a:extLst>
           </p:cNvPr>
@@ -5206,7 +5206,7 @@
           <p:cNvPr id="14" name="">
             <a:extLst xmlns:a="http://schemas.openxmlformats.org/drawingml/2006/main">
               <a:ext uri="{FF2B5EF4-FFF2-40B4-BE49-F238E27FC236}">
-                <a16:creationId xmlns:a16="http://schemas.microsoft.com/office/drawing/2014/main" id="{2DD06ACF-C4D4-45ED-91B0-696765F93111}"/>
+                <a16:creationId xmlns:a16="http://schemas.microsoft.com/office/drawing/2014/main" id="{B4CF6B17-D25B-49CB-9BC9-8EB9303C928A}"/>
               </a:ext>
             </a:extLst>
           </p:cNvPr>
@@ -5263,7 +5263,7 @@
           <p:cNvPr id="15" name="">
             <a:extLst xmlns:a="http://schemas.openxmlformats.org/drawingml/2006/main">
               <a:ext uri="{FF2B5EF4-FFF2-40B4-BE49-F238E27FC236}">
-                <a16:creationId xmlns:a16="http://schemas.microsoft.com/office/drawing/2014/main" id="{9797A000-44CF-4517-BAA8-F680F14D711D}"/>
+                <a16:creationId xmlns:a16="http://schemas.microsoft.com/office/drawing/2014/main" id="{A102D378-4B9F-4BEE-9530-9DC6DAC58A99}"/>
               </a:ext>
             </a:extLst>
           </p:cNvPr>
@@ -5320,7 +5320,7 @@
           <p:cNvPr id="16" name="">
             <a:extLst xmlns:a="http://schemas.openxmlformats.org/drawingml/2006/main">
               <a:ext uri="{FF2B5EF4-FFF2-40B4-BE49-F238E27FC236}">
-                <a16:creationId xmlns:a16="http://schemas.microsoft.com/office/drawing/2014/main" id="{E0E13E51-AC94-49C9-B4DD-8F400302CF3C}"/>
+                <a16:creationId xmlns:a16="http://schemas.microsoft.com/office/drawing/2014/main" id="{89BF817C-2BDE-4DCD-8B22-DF1BA1EF4DAE}"/>
               </a:ext>
             </a:extLst>
           </p:cNvPr>
@@ -5377,7 +5377,7 @@
           <p:cNvPr id="17" name="">
             <a:extLst xmlns:a="http://schemas.openxmlformats.org/drawingml/2006/main">
               <a:ext uri="{FF2B5EF4-FFF2-40B4-BE49-F238E27FC236}">
-                <a16:creationId xmlns:a16="http://schemas.microsoft.com/office/drawing/2014/main" id="{1BB7D816-0DB8-4C1F-B3FE-E6398397D044}"/>
+                <a16:creationId xmlns:a16="http://schemas.microsoft.com/office/drawing/2014/main" id="{7F5F7318-CD6C-4D2A-87A5-5FB982E3047E}"/>
               </a:ext>
             </a:extLst>
           </p:cNvPr>
@@ -5432,7 +5432,7 @@
     </p:spTree>
     <p:extLst>
       <p:ext uri="{BB962C8B-B14F-4D97-AF65-F5344CB8AC3E}">
-        <p14:creationId xmlns:p14="http://schemas.microsoft.com/office/powerpoint/2010/main" val="755377159"/>
+        <p14:creationId xmlns:p14="http://schemas.microsoft.com/office/powerpoint/2010/main" val="1329570311"/>
       </p:ext>
     </p:extLst>
   </p:cSld>
@@ -5463,7 +5463,7 @@
           <p:cNvPr id="17" name="">
             <a:extLst xmlns:a="http://schemas.openxmlformats.org/drawingml/2006/main">
               <a:ext uri="{FF2B5EF4-FFF2-40B4-BE49-F238E27FC236}">
-                <a16:creationId xmlns:a16="http://schemas.microsoft.com/office/drawing/2014/main" id="{7A931D54-D510-4012-969F-E346CEC03E26}"/>
+                <a16:creationId xmlns:a16="http://schemas.microsoft.com/office/drawing/2014/main" id="{AF8E60AA-A18D-46DB-B6E9-0E1BCB8CDDFE}"/>
               </a:ext>
             </a:extLst>
           </p:cNvPr>
@@ -5494,7 +5494,7 @@
           <p:cNvPr id="2" name="">
             <a:extLst xmlns:a="http://schemas.openxmlformats.org/drawingml/2006/main">
               <a:ext uri="{FF2B5EF4-FFF2-40B4-BE49-F238E27FC236}">
-                <a16:creationId xmlns:a16="http://schemas.microsoft.com/office/drawing/2014/main" id="{9EE1E0E2-45F2-4BCD-9D4A-5C18D399074E}"/>
+                <a16:creationId xmlns:a16="http://schemas.microsoft.com/office/drawing/2014/main" id="{F29A2B62-2A1B-423F-9433-11D3A837018B}"/>
               </a:ext>
             </a:extLst>
           </p:cNvPr>
@@ -5525,7 +5525,7 @@
           <p:cNvPr id="3" name="">
             <a:extLst xmlns:a="http://schemas.openxmlformats.org/drawingml/2006/main">
               <a:ext uri="{FF2B5EF4-FFF2-40B4-BE49-F238E27FC236}">
-                <a16:creationId xmlns:a16="http://schemas.microsoft.com/office/drawing/2014/main" id="{E482ED90-3D71-4F6C-9504-E6E04C77A929}"/>
+                <a16:creationId xmlns:a16="http://schemas.microsoft.com/office/drawing/2014/main" id="{1BDEFD1C-190D-4B58-B37F-8552AFD455F3}"/>
               </a:ext>
             </a:extLst>
           </p:cNvPr>
@@ -5582,7 +5582,7 @@
           <p:cNvPr id="4" name="">
             <a:extLst xmlns:a="http://schemas.openxmlformats.org/drawingml/2006/main">
               <a:ext uri="{FF2B5EF4-FFF2-40B4-BE49-F238E27FC236}">
-                <a16:creationId xmlns:a16="http://schemas.microsoft.com/office/drawing/2014/main" id="{106A8E2D-23AA-4CA8-A366-F0CE91ED4A7F}"/>
+                <a16:creationId xmlns:a16="http://schemas.microsoft.com/office/drawing/2014/main" id="{A3FB49F7-0AC8-4EB7-80E6-D9F8EDF2439E}"/>
               </a:ext>
             </a:extLst>
           </p:cNvPr>
@@ -5639,7 +5639,7 @@
           <p:cNvPr id="5" name="">
             <a:extLst xmlns:a="http://schemas.openxmlformats.org/drawingml/2006/main">
               <a:ext uri="{FF2B5EF4-FFF2-40B4-BE49-F238E27FC236}">
-                <a16:creationId xmlns:a16="http://schemas.microsoft.com/office/drawing/2014/main" id="{44DFC043-E9DF-4453-9050-9F467EBD1482}"/>
+                <a16:creationId xmlns:a16="http://schemas.microsoft.com/office/drawing/2014/main" id="{FC526B04-F95F-48A4-BA69-327A677B0F94}"/>
               </a:ext>
             </a:extLst>
           </p:cNvPr>
@@ -5672,7 +5672,7 @@
           <p:cNvPr id="6" name="">
             <a:extLst xmlns:a="http://schemas.openxmlformats.org/drawingml/2006/main">
               <a:ext uri="{FF2B5EF4-FFF2-40B4-BE49-F238E27FC236}">
-                <a16:creationId xmlns:a16="http://schemas.microsoft.com/office/drawing/2014/main" id="{62258C49-573A-4173-9EFB-E6AD779FCD9E}"/>
+                <a16:creationId xmlns:a16="http://schemas.microsoft.com/office/drawing/2014/main" id="{D3E15543-16BE-4B9F-9A19-883B7CB8A0C7}"/>
               </a:ext>
             </a:extLst>
           </p:cNvPr>
@@ -5707,7 +5707,7 @@
           <p:cNvPr id="7" name="">
             <a:extLst xmlns:a="http://schemas.openxmlformats.org/drawingml/2006/main">
               <a:ext uri="{FF2B5EF4-FFF2-40B4-BE49-F238E27FC236}">
-                <a16:creationId xmlns:a16="http://schemas.microsoft.com/office/drawing/2014/main" id="{8DF96050-2D68-4CD8-AC67-39092C410845}"/>
+                <a16:creationId xmlns:a16="http://schemas.microsoft.com/office/drawing/2014/main" id="{1F676491-0619-4DEB-BCEC-0B1FAE242D47}"/>
               </a:ext>
             </a:extLst>
           </p:cNvPr>
@@ -5764,7 +5764,7 @@
           <p:cNvPr id="8" name="">
             <a:extLst xmlns:a="http://schemas.openxmlformats.org/drawingml/2006/main">
               <a:ext uri="{FF2B5EF4-FFF2-40B4-BE49-F238E27FC236}">
-                <a16:creationId xmlns:a16="http://schemas.microsoft.com/office/drawing/2014/main" id="{707C73CA-34A3-4BED-BB54-E8971233F071}"/>
+                <a16:creationId xmlns:a16="http://schemas.microsoft.com/office/drawing/2014/main" id="{4024C979-EE51-43EA-A4E1-2E53003663E4}"/>
               </a:ext>
             </a:extLst>
           </p:cNvPr>
@@ -5821,7 +5821,7 @@
           <p:cNvPr id="9" name="">
             <a:extLst xmlns:a="http://schemas.openxmlformats.org/drawingml/2006/main">
               <a:ext uri="{FF2B5EF4-FFF2-40B4-BE49-F238E27FC236}">
-                <a16:creationId xmlns:a16="http://schemas.microsoft.com/office/drawing/2014/main" id="{EEABDD0E-F095-43B7-BDAF-925D17C89238}"/>
+                <a16:creationId xmlns:a16="http://schemas.microsoft.com/office/drawing/2014/main" id="{9ECA042A-D74A-4B5D-AFB3-451358C326CE}"/>
               </a:ext>
             </a:extLst>
           </p:cNvPr>
@@ -5980,7 +5980,7 @@
           <p:cNvPr id="10" name="">
             <a:extLst xmlns:a="http://schemas.openxmlformats.org/drawingml/2006/main">
               <a:ext uri="{FF2B5EF4-FFF2-40B4-BE49-F238E27FC236}">
-                <a16:creationId xmlns:a16="http://schemas.microsoft.com/office/drawing/2014/main" id="{896FFC4D-DA78-43B7-BC76-DD9551284BFA}"/>
+                <a16:creationId xmlns:a16="http://schemas.microsoft.com/office/drawing/2014/main" id="{B7705A79-6704-4850-8AE7-26E1DD4ADE86}"/>
               </a:ext>
             </a:extLst>
           </p:cNvPr>
@@ -6013,7 +6013,7 @@
           <p:cNvPr id="11" name="">
             <a:extLst xmlns:a="http://schemas.openxmlformats.org/drawingml/2006/main">
               <a:ext uri="{FF2B5EF4-FFF2-40B4-BE49-F238E27FC236}">
-                <a16:creationId xmlns:a16="http://schemas.microsoft.com/office/drawing/2014/main" id="{B4890EF5-7C7D-432B-836E-8021FADC6E2C}"/>
+                <a16:creationId xmlns:a16="http://schemas.microsoft.com/office/drawing/2014/main" id="{E63E66D4-A014-4F09-A0E5-F692251D7D32}"/>
               </a:ext>
             </a:extLst>
           </p:cNvPr>
@@ -6048,7 +6048,7 @@
           <p:cNvPr id="12" name="">
             <a:extLst xmlns:a="http://schemas.openxmlformats.org/drawingml/2006/main">
               <a:ext uri="{FF2B5EF4-FFF2-40B4-BE49-F238E27FC236}">
-                <a16:creationId xmlns:a16="http://schemas.microsoft.com/office/drawing/2014/main" id="{7E3EAF38-DE20-4C37-9EA7-720D07D3EE44}"/>
+                <a16:creationId xmlns:a16="http://schemas.microsoft.com/office/drawing/2014/main" id="{68F2F355-3137-4087-AC04-0AA0862E64F2}"/>
               </a:ext>
             </a:extLst>
           </p:cNvPr>
@@ -6105,7 +6105,7 @@
           <p:cNvPr id="13" name="">
             <a:extLst xmlns:a="http://schemas.openxmlformats.org/drawingml/2006/main">
               <a:ext uri="{FF2B5EF4-FFF2-40B4-BE49-F238E27FC236}">
-                <a16:creationId xmlns:a16="http://schemas.microsoft.com/office/drawing/2014/main" id="{4CE845BF-762B-44E2-9694-DFE2F16A3DE1}"/>
+                <a16:creationId xmlns:a16="http://schemas.microsoft.com/office/drawing/2014/main" id="{0E06E973-CA99-4419-9E28-99EF79E1ABCC}"/>
               </a:ext>
             </a:extLst>
           </p:cNvPr>
@@ -6162,7 +6162,7 @@
           <p:cNvPr id="14" name="">
             <a:extLst xmlns:a="http://schemas.openxmlformats.org/drawingml/2006/main">
               <a:ext uri="{FF2B5EF4-FFF2-40B4-BE49-F238E27FC236}">
-                <a16:creationId xmlns:a16="http://schemas.microsoft.com/office/drawing/2014/main" id="{240DD2EC-A061-4AB2-9F06-7334BAFC738C}"/>
+                <a16:creationId xmlns:a16="http://schemas.microsoft.com/office/drawing/2014/main" id="{BFE140FB-F97B-4676-8C13-7354A9EB5C10}"/>
               </a:ext>
             </a:extLst>
           </p:cNvPr>
@@ -6275,7 +6275,7 @@
           <p:cNvPr id="15" name="">
             <a:extLst xmlns:a="http://schemas.openxmlformats.org/drawingml/2006/main">
               <a:ext uri="{FF2B5EF4-FFF2-40B4-BE49-F238E27FC236}">
-                <a16:creationId xmlns:a16="http://schemas.microsoft.com/office/drawing/2014/main" id="{CE12D822-BF58-468F-B5C3-1703BD0F8F0E}"/>
+                <a16:creationId xmlns:a16="http://schemas.microsoft.com/office/drawing/2014/main" id="{27E3AE8C-04C2-4732-B5C6-38B46CE430B7}"/>
               </a:ext>
             </a:extLst>
           </p:cNvPr>
@@ -6332,7 +6332,7 @@
           <p:cNvPr id="16" name="">
             <a:extLst xmlns:a="http://schemas.openxmlformats.org/drawingml/2006/main">
               <a:ext uri="{FF2B5EF4-FFF2-40B4-BE49-F238E27FC236}">
-                <a16:creationId xmlns:a16="http://schemas.microsoft.com/office/drawing/2014/main" id="{D8A1A7EF-ABA2-47B5-BAC9-7C52063CF4E6}"/>
+                <a16:creationId xmlns:a16="http://schemas.microsoft.com/office/drawing/2014/main" id="{72440AEE-DAE9-4818-9E24-95F57037033B}"/>
               </a:ext>
             </a:extLst>
           </p:cNvPr>
@@ -6387,7 +6387,7 @@
     </p:spTree>
     <p:extLst>
       <p:ext uri="{BB962C8B-B14F-4D97-AF65-F5344CB8AC3E}">
-        <p14:creationId xmlns:p14="http://schemas.microsoft.com/office/powerpoint/2010/main" val="391691745"/>
+        <p14:creationId xmlns:p14="http://schemas.microsoft.com/office/powerpoint/2010/main" val="769895613"/>
       </p:ext>
     </p:extLst>
   </p:cSld>
@@ -6418,7 +6418,7 @@
           <p:cNvPr id="18" name="">
             <a:extLst xmlns:a="http://schemas.openxmlformats.org/drawingml/2006/main">
               <a:ext uri="{FF2B5EF4-FFF2-40B4-BE49-F238E27FC236}">
-                <a16:creationId xmlns:a16="http://schemas.microsoft.com/office/drawing/2014/main" id="{410EE90D-7E4D-43CB-891F-8AD714C48483}"/>
+                <a16:creationId xmlns:a16="http://schemas.microsoft.com/office/drawing/2014/main" id="{D6E4A0A6-9FC5-4E27-85CC-5991C35B1AB1}"/>
               </a:ext>
             </a:extLst>
           </p:cNvPr>
@@ -6449,7 +6449,7 @@
           <p:cNvPr id="2" name="">
             <a:extLst xmlns:a="http://schemas.openxmlformats.org/drawingml/2006/main">
               <a:ext uri="{FF2B5EF4-FFF2-40B4-BE49-F238E27FC236}">
-                <a16:creationId xmlns:a16="http://schemas.microsoft.com/office/drawing/2014/main" id="{494409AB-BC19-4173-B784-1FA8DB3622D7}"/>
+                <a16:creationId xmlns:a16="http://schemas.microsoft.com/office/drawing/2014/main" id="{B36E5B65-E620-4D33-81E6-FD81F1ACDCAC}"/>
               </a:ext>
             </a:extLst>
           </p:cNvPr>
@@ -6480,7 +6480,7 @@
           <p:cNvPr id="3" name="">
             <a:extLst xmlns:a="http://schemas.openxmlformats.org/drawingml/2006/main">
               <a:ext uri="{FF2B5EF4-FFF2-40B4-BE49-F238E27FC236}">
-                <a16:creationId xmlns:a16="http://schemas.microsoft.com/office/drawing/2014/main" id="{29B2828E-3CA1-46DC-B779-506D14EEC60F}"/>
+                <a16:creationId xmlns:a16="http://schemas.microsoft.com/office/drawing/2014/main" id="{696D8D1E-39EB-4FFD-ABCF-20A7BFAD2C73}"/>
               </a:ext>
             </a:extLst>
           </p:cNvPr>
@@ -6537,7 +6537,7 @@
           <p:cNvPr id="4" name="">
             <a:extLst xmlns:a="http://schemas.openxmlformats.org/drawingml/2006/main">
               <a:ext uri="{FF2B5EF4-FFF2-40B4-BE49-F238E27FC236}">
-                <a16:creationId xmlns:a16="http://schemas.microsoft.com/office/drawing/2014/main" id="{6F188062-6307-4A69-9ED8-7EFCF92A3088}"/>
+                <a16:creationId xmlns:a16="http://schemas.microsoft.com/office/drawing/2014/main" id="{716854C6-D792-4AED-B481-43EA5199DD85}"/>
               </a:ext>
             </a:extLst>
           </p:cNvPr>
@@ -6594,7 +6594,7 @@
           <p:cNvPr id="5" name="">
             <a:extLst xmlns:a="http://schemas.openxmlformats.org/drawingml/2006/main">
               <a:ext uri="{FF2B5EF4-FFF2-40B4-BE49-F238E27FC236}">
-                <a16:creationId xmlns:a16="http://schemas.microsoft.com/office/drawing/2014/main" id="{ADE47649-1C67-412E-8AD2-B6D17640305C}"/>
+                <a16:creationId xmlns:a16="http://schemas.microsoft.com/office/drawing/2014/main" id="{8D743E66-6999-412C-8A93-EDBCE4A3A778}"/>
               </a:ext>
             </a:extLst>
           </p:cNvPr>
@@ -6627,7 +6627,7 @@
           <p:cNvPr id="6" name="">
             <a:extLst xmlns:a="http://schemas.openxmlformats.org/drawingml/2006/main">
               <a:ext uri="{FF2B5EF4-FFF2-40B4-BE49-F238E27FC236}">
-                <a16:creationId xmlns:a16="http://schemas.microsoft.com/office/drawing/2014/main" id="{66D810F3-D561-46F4-8B2A-D96E990320A3}"/>
+                <a16:creationId xmlns:a16="http://schemas.microsoft.com/office/drawing/2014/main" id="{427CE814-EB79-4EAB-B848-32312A13518B}"/>
               </a:ext>
             </a:extLst>
           </p:cNvPr>
@@ -6662,7 +6662,7 @@
           <p:cNvPr id="7" name="">
             <a:extLst xmlns:a="http://schemas.openxmlformats.org/drawingml/2006/main">
               <a:ext uri="{FF2B5EF4-FFF2-40B4-BE49-F238E27FC236}">
-                <a16:creationId xmlns:a16="http://schemas.microsoft.com/office/drawing/2014/main" id="{4198EA97-BA52-4AD1-B570-22BB07182CD4}"/>
+                <a16:creationId xmlns:a16="http://schemas.microsoft.com/office/drawing/2014/main" id="{88DCB192-1F55-45F6-AD21-DF1326E015A7}"/>
               </a:ext>
             </a:extLst>
           </p:cNvPr>
@@ -6719,7 +6719,7 @@
           <p:cNvPr id="8" name="">
             <a:extLst xmlns:a="http://schemas.openxmlformats.org/drawingml/2006/main">
               <a:ext uri="{FF2B5EF4-FFF2-40B4-BE49-F238E27FC236}">
-                <a16:creationId xmlns:a16="http://schemas.microsoft.com/office/drawing/2014/main" id="{B89A81A2-DA35-4855-B24F-6667033564F5}"/>
+                <a16:creationId xmlns:a16="http://schemas.microsoft.com/office/drawing/2014/main" id="{A9CF7F76-A121-4BF1-8194-F29504580521}"/>
               </a:ext>
             </a:extLst>
           </p:cNvPr>
@@ -6776,7 +6776,7 @@
           <p:cNvPr id="9" name="">
             <a:extLst xmlns:a="http://schemas.openxmlformats.org/drawingml/2006/main">
               <a:ext uri="{FF2B5EF4-FFF2-40B4-BE49-F238E27FC236}">
-                <a16:creationId xmlns:a16="http://schemas.microsoft.com/office/drawing/2014/main" id="{813F5D81-9980-408D-B451-EC76585670B7}"/>
+                <a16:creationId xmlns:a16="http://schemas.microsoft.com/office/drawing/2014/main" id="{F36CE99B-5935-4B2E-841B-975B6C0A98B6}"/>
               </a:ext>
             </a:extLst>
           </p:cNvPr>
@@ -6833,7 +6833,7 @@
           <p:cNvPr id="10" name="">
             <a:extLst xmlns:a="http://schemas.openxmlformats.org/drawingml/2006/main">
               <a:ext uri="{FF2B5EF4-FFF2-40B4-BE49-F238E27FC236}">
-                <a16:creationId xmlns:a16="http://schemas.microsoft.com/office/drawing/2014/main" id="{3334BEBF-814E-444A-BE5B-BBFF23378922}"/>
+                <a16:creationId xmlns:a16="http://schemas.microsoft.com/office/drawing/2014/main" id="{60C6C019-98AA-4455-85D4-E484B56277D1}"/>
               </a:ext>
             </a:extLst>
           </p:cNvPr>
@@ -6866,7 +6866,7 @@
           <p:cNvPr id="11" name="">
             <a:extLst xmlns:a="http://schemas.openxmlformats.org/drawingml/2006/main">
               <a:ext uri="{FF2B5EF4-FFF2-40B4-BE49-F238E27FC236}">
-                <a16:creationId xmlns:a16="http://schemas.microsoft.com/office/drawing/2014/main" id="{5AD37EDB-5A33-4785-9B6B-234552824D7C}"/>
+                <a16:creationId xmlns:a16="http://schemas.microsoft.com/office/drawing/2014/main" id="{70F8F41D-CF85-4182-8F5B-D3DC91DCD705}"/>
               </a:ext>
             </a:extLst>
           </p:cNvPr>
@@ -6901,7 +6901,7 @@
           <p:cNvPr id="12" name="">
             <a:extLst xmlns:a="http://schemas.openxmlformats.org/drawingml/2006/main">
               <a:ext uri="{FF2B5EF4-FFF2-40B4-BE49-F238E27FC236}">
-                <a16:creationId xmlns:a16="http://schemas.microsoft.com/office/drawing/2014/main" id="{312CDE16-3BC4-4B2A-8D42-EC4F31F4F3DF}"/>
+                <a16:creationId xmlns:a16="http://schemas.microsoft.com/office/drawing/2014/main" id="{516E876B-70C5-406A-8150-1D8B3F9787E6}"/>
               </a:ext>
             </a:extLst>
           </p:cNvPr>
@@ -6958,7 +6958,7 @@
           <p:cNvPr id="13" name="">
             <a:extLst xmlns:a="http://schemas.openxmlformats.org/drawingml/2006/main">
               <a:ext uri="{FF2B5EF4-FFF2-40B4-BE49-F238E27FC236}">
-                <a16:creationId xmlns:a16="http://schemas.microsoft.com/office/drawing/2014/main" id="{5FCD1AFB-F09A-4E5E-825B-F94F8F08320C}"/>
+                <a16:creationId xmlns:a16="http://schemas.microsoft.com/office/drawing/2014/main" id="{D85934E2-69D4-41DB-8364-50E92736CA60}"/>
               </a:ext>
             </a:extLst>
           </p:cNvPr>
@@ -7015,7 +7015,7 @@
           <p:cNvPr id="14" name="">
             <a:extLst xmlns:a="http://schemas.openxmlformats.org/drawingml/2006/main">
               <a:ext uri="{FF2B5EF4-FFF2-40B4-BE49-F238E27FC236}">
-                <a16:creationId xmlns:a16="http://schemas.microsoft.com/office/drawing/2014/main" id="{3805E72E-C989-4EBB-B7C7-FE3306CBA4E9}"/>
+                <a16:creationId xmlns:a16="http://schemas.microsoft.com/office/drawing/2014/main" id="{634ECBA3-6403-4C2A-BDD3-61CA93360AD1}"/>
               </a:ext>
             </a:extLst>
           </p:cNvPr>
@@ -7072,7 +7072,7 @@
           <p:cNvPr id="15" name="">
             <a:extLst xmlns:a="http://schemas.openxmlformats.org/drawingml/2006/main">
               <a:ext uri="{FF2B5EF4-FFF2-40B4-BE49-F238E27FC236}">
-                <a16:creationId xmlns:a16="http://schemas.microsoft.com/office/drawing/2014/main" id="{C9A5B7D4-267B-49D7-A12A-2B18BA2210CB}"/>
+                <a16:creationId xmlns:a16="http://schemas.microsoft.com/office/drawing/2014/main" id="{F149099E-0C9D-420C-8929-8465F42C4B08}"/>
               </a:ext>
             </a:extLst>
           </p:cNvPr>
@@ -7129,7 +7129,7 @@
           <p:cNvPr id="16" name="">
             <a:extLst xmlns:a="http://schemas.openxmlformats.org/drawingml/2006/main">
               <a:ext uri="{FF2B5EF4-FFF2-40B4-BE49-F238E27FC236}">
-                <a16:creationId xmlns:a16="http://schemas.microsoft.com/office/drawing/2014/main" id="{AA264828-933C-4E67-A4CA-9F7C9E963067}"/>
+                <a16:creationId xmlns:a16="http://schemas.microsoft.com/office/drawing/2014/main" id="{54E595D9-475F-4CE5-B4B4-8D93325CEEDB}"/>
               </a:ext>
             </a:extLst>
           </p:cNvPr>
@@ -7186,7 +7186,7 @@
           <p:cNvPr id="17" name="">
             <a:extLst xmlns:a="http://schemas.openxmlformats.org/drawingml/2006/main">
               <a:ext uri="{FF2B5EF4-FFF2-40B4-BE49-F238E27FC236}">
-                <a16:creationId xmlns:a16="http://schemas.microsoft.com/office/drawing/2014/main" id="{DB58E223-2425-491D-B6EE-38533A63CD00}"/>
+                <a16:creationId xmlns:a16="http://schemas.microsoft.com/office/drawing/2014/main" id="{3BFE803D-6924-4A39-BA0D-7AA0473D3199}"/>
               </a:ext>
             </a:extLst>
           </p:cNvPr>
@@ -7241,7 +7241,7 @@
     </p:spTree>
     <p:extLst>
       <p:ext uri="{BB962C8B-B14F-4D97-AF65-F5344CB8AC3E}">
-        <p14:creationId xmlns:p14="http://schemas.microsoft.com/office/powerpoint/2010/main" val="807417108"/>
+        <p14:creationId xmlns:p14="http://schemas.microsoft.com/office/powerpoint/2010/main" val="1412641389"/>
       </p:ext>
     </p:extLst>
   </p:cSld>
@@ -7272,7 +7272,7 @@
           <p:cNvPr id="28" name="">
             <a:extLst xmlns:a="http://schemas.openxmlformats.org/drawingml/2006/main">
               <a:ext uri="{FF2B5EF4-FFF2-40B4-BE49-F238E27FC236}">
-                <a16:creationId xmlns:a16="http://schemas.microsoft.com/office/drawing/2014/main" id="{DD96E8F0-BF62-4AD5-A086-1DC8FC77F6D3}"/>
+                <a16:creationId xmlns:a16="http://schemas.microsoft.com/office/drawing/2014/main" id="{3E84A3D3-8178-4364-BAE6-2AFCAE026DF8}"/>
               </a:ext>
             </a:extLst>
           </p:cNvPr>
@@ -7303,7 +7303,7 @@
           <p:cNvPr id="2" name="">
             <a:extLst xmlns:a="http://schemas.openxmlformats.org/drawingml/2006/main">
               <a:ext uri="{FF2B5EF4-FFF2-40B4-BE49-F238E27FC236}">
-                <a16:creationId xmlns:a16="http://schemas.microsoft.com/office/drawing/2014/main" id="{4FCF7047-B20B-44F0-8B2E-2371E64D66DF}"/>
+                <a16:creationId xmlns:a16="http://schemas.microsoft.com/office/drawing/2014/main" id="{D8A159FB-F72D-4F27-9C21-DCF61DB3476A}"/>
               </a:ext>
             </a:extLst>
           </p:cNvPr>
@@ -7334,7 +7334,7 @@
           <p:cNvPr id="3" name="">
             <a:extLst xmlns:a="http://schemas.openxmlformats.org/drawingml/2006/main">
               <a:ext uri="{FF2B5EF4-FFF2-40B4-BE49-F238E27FC236}">
-                <a16:creationId xmlns:a16="http://schemas.microsoft.com/office/drawing/2014/main" id="{FDACCAE6-6FDC-4108-92DA-017B6D68AD8C}"/>
+                <a16:creationId xmlns:a16="http://schemas.microsoft.com/office/drawing/2014/main" id="{06832244-87D1-4383-BD5A-E03B3F2F93D0}"/>
               </a:ext>
             </a:extLst>
           </p:cNvPr>
@@ -7391,7 +7391,7 @@
           <p:cNvPr id="4" name="">
             <a:extLst xmlns:a="http://schemas.openxmlformats.org/drawingml/2006/main">
               <a:ext uri="{FF2B5EF4-FFF2-40B4-BE49-F238E27FC236}">
-                <a16:creationId xmlns:a16="http://schemas.microsoft.com/office/drawing/2014/main" id="{287A45F0-B13D-4572-81BF-9D942C06BC45}"/>
+                <a16:creationId xmlns:a16="http://schemas.microsoft.com/office/drawing/2014/main" id="{C69EB451-1225-429D-8141-C0827A1A4526}"/>
               </a:ext>
             </a:extLst>
           </p:cNvPr>
@@ -7448,7 +7448,7 @@
           <p:cNvPr id="5" name="">
             <a:extLst xmlns:a="http://schemas.openxmlformats.org/drawingml/2006/main">
               <a:ext uri="{FF2B5EF4-FFF2-40B4-BE49-F238E27FC236}">
-                <a16:creationId xmlns:a16="http://schemas.microsoft.com/office/drawing/2014/main" id="{E7AB179C-52C8-4FB7-9513-3FC12260DA92}"/>
+                <a16:creationId xmlns:a16="http://schemas.microsoft.com/office/drawing/2014/main" id="{3327B5B7-4D4C-4E49-9644-1C653006E960}"/>
               </a:ext>
             </a:extLst>
           </p:cNvPr>
@@ -7481,7 +7481,7 @@
           <p:cNvPr id="6" name="">
             <a:extLst xmlns:a="http://schemas.openxmlformats.org/drawingml/2006/main">
               <a:ext uri="{FF2B5EF4-FFF2-40B4-BE49-F238E27FC236}">
-                <a16:creationId xmlns:a16="http://schemas.microsoft.com/office/drawing/2014/main" id="{277468CF-51BD-43A0-A4FB-33E565E0BBD4}"/>
+                <a16:creationId xmlns:a16="http://schemas.microsoft.com/office/drawing/2014/main" id="{EA588EFC-BDF2-443B-A503-A1B5384D9426}"/>
               </a:ext>
             </a:extLst>
           </p:cNvPr>
@@ -7516,7 +7516,7 @@
           <p:cNvPr id="7" name="">
             <a:extLst xmlns:a="http://schemas.openxmlformats.org/drawingml/2006/main">
               <a:ext uri="{FF2B5EF4-FFF2-40B4-BE49-F238E27FC236}">
-                <a16:creationId xmlns:a16="http://schemas.microsoft.com/office/drawing/2014/main" id="{EF4A22FA-AFC6-46A3-818F-DD4F746AF534}"/>
+                <a16:creationId xmlns:a16="http://schemas.microsoft.com/office/drawing/2014/main" id="{2F338398-E847-4826-AAA3-F884918FF3A1}"/>
               </a:ext>
             </a:extLst>
           </p:cNvPr>
@@ -7573,7 +7573,7 @@
           <p:cNvPr id="8" name="">
             <a:extLst xmlns:a="http://schemas.openxmlformats.org/drawingml/2006/main">
               <a:ext uri="{FF2B5EF4-FFF2-40B4-BE49-F238E27FC236}">
-                <a16:creationId xmlns:a16="http://schemas.microsoft.com/office/drawing/2014/main" id="{3B4454ED-AB5B-4E5C-9ABF-201BF7F737FC}"/>
+                <a16:creationId xmlns:a16="http://schemas.microsoft.com/office/drawing/2014/main" id="{965A8982-88F4-4195-B77C-6CD6125AD260}"/>
               </a:ext>
             </a:extLst>
           </p:cNvPr>
@@ -7630,7 +7630,7 @@
           <p:cNvPr id="9" name="">
             <a:extLst xmlns:a="http://schemas.openxmlformats.org/drawingml/2006/main">
               <a:ext uri="{FF2B5EF4-FFF2-40B4-BE49-F238E27FC236}">
-                <a16:creationId xmlns:a16="http://schemas.microsoft.com/office/drawing/2014/main" id="{3A33F494-F9D2-4663-BB6A-B6374B951F3E}"/>
+                <a16:creationId xmlns:a16="http://schemas.microsoft.com/office/drawing/2014/main" id="{08B26832-8C86-418A-8EA8-D8A21F0FCE6D}"/>
               </a:ext>
             </a:extLst>
           </p:cNvPr>
@@ -7687,7 +7687,7 @@
           <p:cNvPr id="10" name="">
             <a:extLst xmlns:a="http://schemas.openxmlformats.org/drawingml/2006/main">
               <a:ext uri="{FF2B5EF4-FFF2-40B4-BE49-F238E27FC236}">
-                <a16:creationId xmlns:a16="http://schemas.microsoft.com/office/drawing/2014/main" id="{AEE28E9F-40F9-4EF0-93F1-3280BC6016FE}"/>
+                <a16:creationId xmlns:a16="http://schemas.microsoft.com/office/drawing/2014/main" id="{B3341275-CC5B-49D5-901B-FA5EA2AA5E64}"/>
               </a:ext>
             </a:extLst>
           </p:cNvPr>
@@ -7720,7 +7720,7 @@
           <p:cNvPr id="11" name="">
             <a:extLst xmlns:a="http://schemas.openxmlformats.org/drawingml/2006/main">
               <a:ext uri="{FF2B5EF4-FFF2-40B4-BE49-F238E27FC236}">
-                <a16:creationId xmlns:a16="http://schemas.microsoft.com/office/drawing/2014/main" id="{3D547FEC-6759-461B-8260-39129E09ADFC}"/>
+                <a16:creationId xmlns:a16="http://schemas.microsoft.com/office/drawing/2014/main" id="{03B5DBEA-9897-47CD-AB1C-AB85AFEAFD6A}"/>
               </a:ext>
             </a:extLst>
           </p:cNvPr>
@@ -7755,7 +7755,7 @@
           <p:cNvPr id="12" name="">
             <a:extLst xmlns:a="http://schemas.openxmlformats.org/drawingml/2006/main">
               <a:ext uri="{FF2B5EF4-FFF2-40B4-BE49-F238E27FC236}">
-                <a16:creationId xmlns:a16="http://schemas.microsoft.com/office/drawing/2014/main" id="{BF0067AE-6EF8-450D-A347-D26A5DBFB261}"/>
+                <a16:creationId xmlns:a16="http://schemas.microsoft.com/office/drawing/2014/main" id="{AE1EBFBD-8558-42C4-B0EF-29C7A909FE71}"/>
               </a:ext>
             </a:extLst>
           </p:cNvPr>
@@ -7812,7 +7812,7 @@
           <p:cNvPr id="13" name="">
             <a:extLst xmlns:a="http://schemas.openxmlformats.org/drawingml/2006/main">
               <a:ext uri="{FF2B5EF4-FFF2-40B4-BE49-F238E27FC236}">
-                <a16:creationId xmlns:a16="http://schemas.microsoft.com/office/drawing/2014/main" id="{98FF3974-67F8-48F2-A42D-39B566612D6A}"/>
+                <a16:creationId xmlns:a16="http://schemas.microsoft.com/office/drawing/2014/main" id="{C1B1D938-457F-41DD-96B1-A5BBDD6671B2}"/>
               </a:ext>
             </a:extLst>
           </p:cNvPr>
@@ -7869,7 +7869,7 @@
           <p:cNvPr id="14" name="">
             <a:extLst xmlns:a="http://schemas.openxmlformats.org/drawingml/2006/main">
               <a:ext uri="{FF2B5EF4-FFF2-40B4-BE49-F238E27FC236}">
-                <a16:creationId xmlns:a16="http://schemas.microsoft.com/office/drawing/2014/main" id="{F457391C-42FC-4127-8953-84E0454D6B90}"/>
+                <a16:creationId xmlns:a16="http://schemas.microsoft.com/office/drawing/2014/main" id="{7A8C46E2-6C4F-4735-BCE9-974790923725}"/>
               </a:ext>
             </a:extLst>
           </p:cNvPr>
@@ -7926,7 +7926,7 @@
           <p:cNvPr id="15" name="">
             <a:extLst xmlns:a="http://schemas.openxmlformats.org/drawingml/2006/main">
               <a:ext uri="{FF2B5EF4-FFF2-40B4-BE49-F238E27FC236}">
-                <a16:creationId xmlns:a16="http://schemas.microsoft.com/office/drawing/2014/main" id="{D379D4E9-C810-43EF-BA9C-7DA01581731E}"/>
+                <a16:creationId xmlns:a16="http://schemas.microsoft.com/office/drawing/2014/main" id="{EDA335DF-21BD-4796-A217-ABDF37B8EABF}"/>
               </a:ext>
             </a:extLst>
           </p:cNvPr>
@@ -7959,7 +7959,7 @@
           <p:cNvPr id="16" name="">
             <a:extLst xmlns:a="http://schemas.openxmlformats.org/drawingml/2006/main">
               <a:ext uri="{FF2B5EF4-FFF2-40B4-BE49-F238E27FC236}">
-                <a16:creationId xmlns:a16="http://schemas.microsoft.com/office/drawing/2014/main" id="{06669BAA-7841-4CF1-84C8-E59E24CBDBBF}"/>
+                <a16:creationId xmlns:a16="http://schemas.microsoft.com/office/drawing/2014/main" id="{83167894-5B68-4CCD-B6D1-F254A0B2254B}"/>
               </a:ext>
             </a:extLst>
           </p:cNvPr>
@@ -7994,7 +7994,7 @@
           <p:cNvPr id="17" name="">
             <a:extLst xmlns:a="http://schemas.openxmlformats.org/drawingml/2006/main">
               <a:ext uri="{FF2B5EF4-FFF2-40B4-BE49-F238E27FC236}">
-                <a16:creationId xmlns:a16="http://schemas.microsoft.com/office/drawing/2014/main" id="{7E3A3614-F97A-4BD8-A4B8-77108D124E21}"/>
+                <a16:creationId xmlns:a16="http://schemas.microsoft.com/office/drawing/2014/main" id="{6DC1FA57-4E24-4FF0-AE42-14A8F8C031BA}"/>
               </a:ext>
             </a:extLst>
           </p:cNvPr>
@@ -8051,7 +8051,7 @@
           <p:cNvPr id="18" name="">
             <a:extLst xmlns:a="http://schemas.openxmlformats.org/drawingml/2006/main">
               <a:ext uri="{FF2B5EF4-FFF2-40B4-BE49-F238E27FC236}">
-                <a16:creationId xmlns:a16="http://schemas.microsoft.com/office/drawing/2014/main" id="{4092AB37-4E66-45BE-89FE-77B9466579CB}"/>
+                <a16:creationId xmlns:a16="http://schemas.microsoft.com/office/drawing/2014/main" id="{F344B021-C67B-4026-87C5-AA76EC076618}"/>
               </a:ext>
             </a:extLst>
           </p:cNvPr>
@@ -8108,7 +8108,7 @@
           <p:cNvPr id="19" name="">
             <a:extLst xmlns:a="http://schemas.openxmlformats.org/drawingml/2006/main">
               <a:ext uri="{FF2B5EF4-FFF2-40B4-BE49-F238E27FC236}">
-                <a16:creationId xmlns:a16="http://schemas.microsoft.com/office/drawing/2014/main" id="{0DA4538C-1698-449B-BB70-658336566036}"/>
+                <a16:creationId xmlns:a16="http://schemas.microsoft.com/office/drawing/2014/main" id="{FA792880-1683-4A61-83B4-D443B6EDE69B}"/>
               </a:ext>
             </a:extLst>
           </p:cNvPr>
@@ -8165,7 +8165,7 @@
           <p:cNvPr id="20" name="">
             <a:extLst xmlns:a="http://schemas.openxmlformats.org/drawingml/2006/main">
               <a:ext uri="{FF2B5EF4-FFF2-40B4-BE49-F238E27FC236}">
-                <a16:creationId xmlns:a16="http://schemas.microsoft.com/office/drawing/2014/main" id="{CA67EF8D-F48F-4BF5-AE67-175EA58CC794}"/>
+                <a16:creationId xmlns:a16="http://schemas.microsoft.com/office/drawing/2014/main" id="{B3095BB5-6DFB-43A7-86C2-C2292F6472FE}"/>
               </a:ext>
             </a:extLst>
           </p:cNvPr>
@@ -8198,7 +8198,7 @@
           <p:cNvPr id="21" name="">
             <a:extLst xmlns:a="http://schemas.openxmlformats.org/drawingml/2006/main">
               <a:ext uri="{FF2B5EF4-FFF2-40B4-BE49-F238E27FC236}">
-                <a16:creationId xmlns:a16="http://schemas.microsoft.com/office/drawing/2014/main" id="{AB4B76F1-BF6A-4EA5-9231-442BE92BBF85}"/>
+                <a16:creationId xmlns:a16="http://schemas.microsoft.com/office/drawing/2014/main" id="{AD258212-A112-4D9B-AB53-3E8FBE876D76}"/>
               </a:ext>
             </a:extLst>
           </p:cNvPr>
@@ -8233,7 +8233,7 @@
           <p:cNvPr id="22" name="">
             <a:extLst xmlns:a="http://schemas.openxmlformats.org/drawingml/2006/main">
               <a:ext uri="{FF2B5EF4-FFF2-40B4-BE49-F238E27FC236}">
-                <a16:creationId xmlns:a16="http://schemas.microsoft.com/office/drawing/2014/main" id="{D3667ABF-1674-4A9C-A883-D75CC24F79B2}"/>
+                <a16:creationId xmlns:a16="http://schemas.microsoft.com/office/drawing/2014/main" id="{DCA5CCC1-EB01-49DA-849C-12CE80EAE921}"/>
               </a:ext>
             </a:extLst>
           </p:cNvPr>
@@ -8290,7 +8290,7 @@
           <p:cNvPr id="23" name="">
             <a:extLst xmlns:a="http://schemas.openxmlformats.org/drawingml/2006/main">
               <a:ext uri="{FF2B5EF4-FFF2-40B4-BE49-F238E27FC236}">
-                <a16:creationId xmlns:a16="http://schemas.microsoft.com/office/drawing/2014/main" id="{1EFF45EE-B208-4008-97DE-ADEF2C069E12}"/>
+                <a16:creationId xmlns:a16="http://schemas.microsoft.com/office/drawing/2014/main" id="{DF95DF0D-801D-4097-9E99-9A5692E9653A}"/>
               </a:ext>
             </a:extLst>
           </p:cNvPr>
@@ -8347,7 +8347,7 @@
           <p:cNvPr id="24" name="">
             <a:extLst xmlns:a="http://schemas.openxmlformats.org/drawingml/2006/main">
               <a:ext uri="{FF2B5EF4-FFF2-40B4-BE49-F238E27FC236}">
-                <a16:creationId xmlns:a16="http://schemas.microsoft.com/office/drawing/2014/main" id="{F8A56D0E-BE6E-4A2E-92E7-4B750140CACB}"/>
+                <a16:creationId xmlns:a16="http://schemas.microsoft.com/office/drawing/2014/main" id="{DC3132AB-C110-425C-886F-D5791486C172}"/>
               </a:ext>
             </a:extLst>
           </p:cNvPr>
@@ -8404,7 +8404,7 @@
           <p:cNvPr id="25" name="">
             <a:extLst xmlns:a="http://schemas.openxmlformats.org/drawingml/2006/main">
               <a:ext uri="{FF2B5EF4-FFF2-40B4-BE49-F238E27FC236}">
-                <a16:creationId xmlns:a16="http://schemas.microsoft.com/office/drawing/2014/main" id="{8CBABE82-F320-468C-A282-61375E4E5FDA}"/>
+                <a16:creationId xmlns:a16="http://schemas.microsoft.com/office/drawing/2014/main" id="{5006DEBB-72CF-451E-96A5-30A3D45681EC}"/>
               </a:ext>
             </a:extLst>
           </p:cNvPr>
@@ -8437,7 +8437,7 @@
           <p:cNvPr id="26" name="">
             <a:extLst xmlns:a="http://schemas.openxmlformats.org/drawingml/2006/main">
               <a:ext uri="{FF2B5EF4-FFF2-40B4-BE49-F238E27FC236}">
-                <a16:creationId xmlns:a16="http://schemas.microsoft.com/office/drawing/2014/main" id="{779102EA-0B31-4F05-9057-FE26C2368D82}"/>
+                <a16:creationId xmlns:a16="http://schemas.microsoft.com/office/drawing/2014/main" id="{8CB8934A-DAF9-4DFC-9C1B-E24C07841BFB}"/>
               </a:ext>
             </a:extLst>
           </p:cNvPr>
@@ -8494,7 +8494,7 @@
           <p:cNvPr id="27" name="">
             <a:extLst xmlns:a="http://schemas.openxmlformats.org/drawingml/2006/main">
               <a:ext uri="{FF2B5EF4-FFF2-40B4-BE49-F238E27FC236}">
-                <a16:creationId xmlns:a16="http://schemas.microsoft.com/office/drawing/2014/main" id="{D2F251D9-843E-49F2-8D8E-AE1C64C70E15}"/>
+                <a16:creationId xmlns:a16="http://schemas.microsoft.com/office/drawing/2014/main" id="{41CC9B44-E2FE-404A-AD8D-8FF6F7B9C6D9}"/>
               </a:ext>
             </a:extLst>
           </p:cNvPr>
@@ -8549,7 +8549,7 @@
     </p:spTree>
     <p:extLst>
       <p:ext uri="{BB962C8B-B14F-4D97-AF65-F5344CB8AC3E}">
-        <p14:creationId xmlns:p14="http://schemas.microsoft.com/office/powerpoint/2010/main" val="954972990"/>
+        <p14:creationId xmlns:p14="http://schemas.microsoft.com/office/powerpoint/2010/main" val="1872090155"/>
       </p:ext>
     </p:extLst>
   </p:cSld>
@@ -8580,7 +8580,7 @@
           <p:cNvPr id="11" name="">
             <a:extLst xmlns:a="http://schemas.openxmlformats.org/drawingml/2006/main">
               <a:ext uri="{FF2B5EF4-FFF2-40B4-BE49-F238E27FC236}">
-                <a16:creationId xmlns:a16="http://schemas.microsoft.com/office/drawing/2014/main" id="{8F39A42F-6C22-415F-A73F-B0E3F7760805}"/>
+                <a16:creationId xmlns:a16="http://schemas.microsoft.com/office/drawing/2014/main" id="{D916497F-D418-4476-9F31-92132311B40B}"/>
               </a:ext>
             </a:extLst>
           </p:cNvPr>
@@ -8611,7 +8611,7 @@
           <p:cNvPr id="2" name="">
             <a:extLst xmlns:a="http://schemas.openxmlformats.org/drawingml/2006/main">
               <a:ext uri="{FF2B5EF4-FFF2-40B4-BE49-F238E27FC236}">
-                <a16:creationId xmlns:a16="http://schemas.microsoft.com/office/drawing/2014/main" id="{50AE9990-1543-49B4-9912-070CAE9A7FEB}"/>
+                <a16:creationId xmlns:a16="http://schemas.microsoft.com/office/drawing/2014/main" id="{FECD6DD5-4B7D-4624-BD8D-90011AFD944B}"/>
               </a:ext>
             </a:extLst>
           </p:cNvPr>
@@ -8642,7 +8642,7 @@
           <p:cNvPr id="3" name="">
             <a:extLst xmlns:a="http://schemas.openxmlformats.org/drawingml/2006/main">
               <a:ext uri="{FF2B5EF4-FFF2-40B4-BE49-F238E27FC236}">
-                <a16:creationId xmlns:a16="http://schemas.microsoft.com/office/drawing/2014/main" id="{A44C37A4-C0E0-4F7B-BFAA-55B24D2AD045}"/>
+                <a16:creationId xmlns:a16="http://schemas.microsoft.com/office/drawing/2014/main" id="{5A0E4B50-DAC4-454A-BEEA-5C9733F95FD8}"/>
               </a:ext>
             </a:extLst>
           </p:cNvPr>
@@ -8699,7 +8699,7 @@
           <p:cNvPr id="4" name="">
             <a:extLst xmlns:a="http://schemas.openxmlformats.org/drawingml/2006/main">
               <a:ext uri="{FF2B5EF4-FFF2-40B4-BE49-F238E27FC236}">
-                <a16:creationId xmlns:a16="http://schemas.microsoft.com/office/drawing/2014/main" id="{D848876B-C8ED-449D-8487-7BED93A98E1F}"/>
+                <a16:creationId xmlns:a16="http://schemas.microsoft.com/office/drawing/2014/main" id="{732B6CF3-F4CC-42C2-AFD0-47CD072DC139}"/>
               </a:ext>
             </a:extLst>
           </p:cNvPr>
@@ -8756,7 +8756,7 @@
           <p:cNvPr id="5" name="">
             <a:extLst xmlns:a="http://schemas.openxmlformats.org/drawingml/2006/main">
               <a:ext uri="{FF2B5EF4-FFF2-40B4-BE49-F238E27FC236}">
-                <a16:creationId xmlns:a16="http://schemas.microsoft.com/office/drawing/2014/main" id="{1F2ABD9A-6452-473C-9EAD-66604DF112C9}"/>
+                <a16:creationId xmlns:a16="http://schemas.microsoft.com/office/drawing/2014/main" id="{90753048-777B-406A-93A6-8EBAF6C1BCCA}"/>
               </a:ext>
             </a:extLst>
           </p:cNvPr>
@@ -8789,7 +8789,7 @@
           <p:cNvPr id="6" name="">
             <a:extLst xmlns:a="http://schemas.openxmlformats.org/drawingml/2006/main">
               <a:ext uri="{FF2B5EF4-FFF2-40B4-BE49-F238E27FC236}">
-                <a16:creationId xmlns:a16="http://schemas.microsoft.com/office/drawing/2014/main" id="{084881CE-ADB6-485D-922F-BA22F014737F}"/>
+                <a16:creationId xmlns:a16="http://schemas.microsoft.com/office/drawing/2014/main" id="{C8F259AC-BE35-47DA-8456-8B87E766AB5B}"/>
               </a:ext>
             </a:extLst>
           </p:cNvPr>
@@ -8824,7 +8824,7 @@
           <p:cNvPr id="7" name="">
             <a:extLst xmlns:a="http://schemas.openxmlformats.org/drawingml/2006/main">
               <a:ext uri="{FF2B5EF4-FFF2-40B4-BE49-F238E27FC236}">
-                <a16:creationId xmlns:a16="http://schemas.microsoft.com/office/drawing/2014/main" id="{750605B0-CCB6-44F7-A968-1531E2899353}"/>
+                <a16:creationId xmlns:a16="http://schemas.microsoft.com/office/drawing/2014/main" id="{69755ED4-2231-4206-B618-509E321880DF}"/>
               </a:ext>
             </a:extLst>
           </p:cNvPr>
@@ -8881,7 +8881,7 @@
           <p:cNvPr id="8" name="">
             <a:extLst xmlns:a="http://schemas.openxmlformats.org/drawingml/2006/main">
               <a:ext uri="{FF2B5EF4-FFF2-40B4-BE49-F238E27FC236}">
-                <a16:creationId xmlns:a16="http://schemas.microsoft.com/office/drawing/2014/main" id="{DCFF5885-2615-4AA5-BC32-AA3D37FBF77A}"/>
+                <a16:creationId xmlns:a16="http://schemas.microsoft.com/office/drawing/2014/main" id="{FCDCC5B6-719F-45DB-BA54-DA0820AB6949}"/>
               </a:ext>
             </a:extLst>
           </p:cNvPr>
@@ -8938,7 +8938,7 @@
           <p:cNvPr id="9" name="">
             <a:extLst xmlns:a="http://schemas.openxmlformats.org/drawingml/2006/main">
               <a:ext uri="{FF2B5EF4-FFF2-40B4-BE49-F238E27FC236}">
-                <a16:creationId xmlns:a16="http://schemas.microsoft.com/office/drawing/2014/main" id="{8B98277F-6661-4FFB-B231-A9A55A837DC5}"/>
+                <a16:creationId xmlns:a16="http://schemas.microsoft.com/office/drawing/2014/main" id="{D4F00635-6CAF-4B05-BE48-CC603F8D6753}"/>
               </a:ext>
             </a:extLst>
           </p:cNvPr>
@@ -9107,7 +9107,7 @@
           <p:cNvPr id="10" name="">
             <a:extLst xmlns:a="http://schemas.openxmlformats.org/drawingml/2006/main">
               <a:ext uri="{FF2B5EF4-FFF2-40B4-BE49-F238E27FC236}">
-                <a16:creationId xmlns:a16="http://schemas.microsoft.com/office/drawing/2014/main" id="{BE70C9F8-95E1-4E3A-A2D1-BE1C80CE77B5}"/>
+                <a16:creationId xmlns:a16="http://schemas.microsoft.com/office/drawing/2014/main" id="{B62A7F1D-C42E-454A-9B66-FFBB69BAB9D6}"/>
               </a:ext>
             </a:extLst>
           </p:cNvPr>
@@ -9162,7 +9162,7 @@
     </p:spTree>
     <p:extLst>
       <p:ext uri="{BB962C8B-B14F-4D97-AF65-F5344CB8AC3E}">
-        <p14:creationId xmlns:p14="http://schemas.microsoft.com/office/powerpoint/2010/main" val="1318509708"/>
+        <p14:creationId xmlns:p14="http://schemas.microsoft.com/office/powerpoint/2010/main" val="1572649163"/>
       </p:ext>
     </p:extLst>
   </p:cSld>
@@ -9193,7 +9193,7 @@
           <p:cNvPr id="29" name="">
             <a:extLst xmlns:a="http://schemas.openxmlformats.org/drawingml/2006/main">
               <a:ext uri="{FF2B5EF4-FFF2-40B4-BE49-F238E27FC236}">
-                <a16:creationId xmlns:a16="http://schemas.microsoft.com/office/drawing/2014/main" id="{97504A7F-27C6-4068-8034-626D08ED7CE1}"/>
+                <a16:creationId xmlns:a16="http://schemas.microsoft.com/office/drawing/2014/main" id="{79F1AAF5-DD33-4E31-A148-091AD8255702}"/>
               </a:ext>
             </a:extLst>
           </p:cNvPr>
@@ -9224,7 +9224,7 @@
           <p:cNvPr id="2" name="">
             <a:extLst xmlns:a="http://schemas.openxmlformats.org/drawingml/2006/main">
               <a:ext uri="{FF2B5EF4-FFF2-40B4-BE49-F238E27FC236}">
-                <a16:creationId xmlns:a16="http://schemas.microsoft.com/office/drawing/2014/main" id="{54F9A04B-85FB-4376-BFF4-11B32011B2DD}"/>
+                <a16:creationId xmlns:a16="http://schemas.microsoft.com/office/drawing/2014/main" id="{9F160B4D-4A5F-4511-8AD7-80B159740D48}"/>
               </a:ext>
             </a:extLst>
           </p:cNvPr>
@@ -9255,7 +9255,7 @@
           <p:cNvPr id="3" name="">
             <a:extLst xmlns:a="http://schemas.openxmlformats.org/drawingml/2006/main">
               <a:ext uri="{FF2B5EF4-FFF2-40B4-BE49-F238E27FC236}">
-                <a16:creationId xmlns:a16="http://schemas.microsoft.com/office/drawing/2014/main" id="{DBE3BACF-A6CF-4D49-8528-4BC7EE5577AE}"/>
+                <a16:creationId xmlns:a16="http://schemas.microsoft.com/office/drawing/2014/main" id="{15B19237-BE47-4192-A74D-A4CFEA29799F}"/>
               </a:ext>
             </a:extLst>
           </p:cNvPr>
@@ -9312,7 +9312,7 @@
           <p:cNvPr id="4" name="">
             <a:extLst xmlns:a="http://schemas.openxmlformats.org/drawingml/2006/main">
               <a:ext uri="{FF2B5EF4-FFF2-40B4-BE49-F238E27FC236}">
-                <a16:creationId xmlns:a16="http://schemas.microsoft.com/office/drawing/2014/main" id="{7DC7F7A5-3DDA-43FE-B0F0-60D1DC70968B}"/>
+                <a16:creationId xmlns:a16="http://schemas.microsoft.com/office/drawing/2014/main" id="{6349C7B9-2AC7-4FEA-9346-31D170D7F6C9}"/>
               </a:ext>
             </a:extLst>
           </p:cNvPr>
@@ -9369,7 +9369,7 @@
           <p:cNvPr id="5" name="">
             <a:extLst xmlns:a="http://schemas.openxmlformats.org/drawingml/2006/main">
               <a:ext uri="{FF2B5EF4-FFF2-40B4-BE49-F238E27FC236}">
-                <a16:creationId xmlns:a16="http://schemas.microsoft.com/office/drawing/2014/main" id="{13A7FE9C-B236-4ADF-9533-09B6EA57334B}"/>
+                <a16:creationId xmlns:a16="http://schemas.microsoft.com/office/drawing/2014/main" id="{011B230C-8FEE-421C-BD62-824DD262FD1E}"/>
               </a:ext>
             </a:extLst>
           </p:cNvPr>
@@ -9402,7 +9402,7 @@
           <p:cNvPr id="6" name="">
             <a:extLst xmlns:a="http://schemas.openxmlformats.org/drawingml/2006/main">
               <a:ext uri="{FF2B5EF4-FFF2-40B4-BE49-F238E27FC236}">
-                <a16:creationId xmlns:a16="http://schemas.microsoft.com/office/drawing/2014/main" id="{0BD91CD7-3982-4A27-8601-94F7DCDF522D}"/>
+                <a16:creationId xmlns:a16="http://schemas.microsoft.com/office/drawing/2014/main" id="{58CAE59A-AA0E-4E15-B918-CE3E05EB71FF}"/>
               </a:ext>
             </a:extLst>
           </p:cNvPr>
@@ -9437,7 +9437,7 @@
           <p:cNvPr id="7" name="">
             <a:extLst xmlns:a="http://schemas.openxmlformats.org/drawingml/2006/main">
               <a:ext uri="{FF2B5EF4-FFF2-40B4-BE49-F238E27FC236}">
-                <a16:creationId xmlns:a16="http://schemas.microsoft.com/office/drawing/2014/main" id="{2C06975C-44CC-4EA3-9658-72765A9C4A91}"/>
+                <a16:creationId xmlns:a16="http://schemas.microsoft.com/office/drawing/2014/main" id="{1CEAAD74-2CF6-47BA-A7C2-D05AB165BCC8}"/>
               </a:ext>
             </a:extLst>
           </p:cNvPr>
@@ -9494,7 +9494,7 @@
           <p:cNvPr id="8" name="">
             <a:extLst xmlns:a="http://schemas.openxmlformats.org/drawingml/2006/main">
               <a:ext uri="{FF2B5EF4-FFF2-40B4-BE49-F238E27FC236}">
-                <a16:creationId xmlns:a16="http://schemas.microsoft.com/office/drawing/2014/main" id="{5B358CDA-10B3-45B5-8D1F-6DC5D108541D}"/>
+                <a16:creationId xmlns:a16="http://schemas.microsoft.com/office/drawing/2014/main" id="{E4A7DC46-F254-4410-AA4A-B35E1A19D7BA}"/>
               </a:ext>
             </a:extLst>
           </p:cNvPr>
@@ -9551,7 +9551,7 @@
           <p:cNvPr id="9" name="">
             <a:extLst xmlns:a="http://schemas.openxmlformats.org/drawingml/2006/main">
               <a:ext uri="{FF2B5EF4-FFF2-40B4-BE49-F238E27FC236}">
-                <a16:creationId xmlns:a16="http://schemas.microsoft.com/office/drawing/2014/main" id="{C728968A-3E40-4AC5-ABFB-9C2FBE534C04}"/>
+                <a16:creationId xmlns:a16="http://schemas.microsoft.com/office/drawing/2014/main" id="{7CE3617A-0DDB-4698-AE10-79998BB8599A}"/>
               </a:ext>
             </a:extLst>
           </p:cNvPr>
@@ -9584,7 +9584,7 @@
           <p:cNvPr id="10" name="">
             <a:extLst xmlns:a="http://schemas.openxmlformats.org/drawingml/2006/main">
               <a:ext uri="{FF2B5EF4-FFF2-40B4-BE49-F238E27FC236}">
-                <a16:creationId xmlns:a16="http://schemas.microsoft.com/office/drawing/2014/main" id="{82D6D3ED-8C76-475D-A108-D1EEC4AF581A}"/>
+                <a16:creationId xmlns:a16="http://schemas.microsoft.com/office/drawing/2014/main" id="{F6EB6EC6-9AAB-467A-93DA-C388D3515A87}"/>
               </a:ext>
             </a:extLst>
           </p:cNvPr>
@@ -9619,7 +9619,7 @@
           <p:cNvPr id="11" name="">
             <a:extLst xmlns:a="http://schemas.openxmlformats.org/drawingml/2006/main">
               <a:ext uri="{FF2B5EF4-FFF2-40B4-BE49-F238E27FC236}">
-                <a16:creationId xmlns:a16="http://schemas.microsoft.com/office/drawing/2014/main" id="{7D1E3BAB-67B6-4353-9248-CF3F5055B633}"/>
+                <a16:creationId xmlns:a16="http://schemas.microsoft.com/office/drawing/2014/main" id="{55B9CD7F-D38A-45E8-885A-9A9BEAF55B8E}"/>
               </a:ext>
             </a:extLst>
           </p:cNvPr>
@@ -9676,7 +9676,7 @@
           <p:cNvPr id="12" name="">
             <a:extLst xmlns:a="http://schemas.openxmlformats.org/drawingml/2006/main">
               <a:ext uri="{FF2B5EF4-FFF2-40B4-BE49-F238E27FC236}">
-                <a16:creationId xmlns:a16="http://schemas.microsoft.com/office/drawing/2014/main" id="{F42CF5B2-849F-4446-A8D4-CABFA1D8AF2E}"/>
+                <a16:creationId xmlns:a16="http://schemas.microsoft.com/office/drawing/2014/main" id="{8ED16728-11BF-47D0-96D0-78F9092087C3}"/>
               </a:ext>
             </a:extLst>
           </p:cNvPr>
@@ -9733,7 +9733,7 @@
           <p:cNvPr id="13" name="">
             <a:extLst xmlns:a="http://schemas.openxmlformats.org/drawingml/2006/main">
               <a:ext uri="{FF2B5EF4-FFF2-40B4-BE49-F238E27FC236}">
-                <a16:creationId xmlns:a16="http://schemas.microsoft.com/office/drawing/2014/main" id="{53CCEA3E-8C53-43AC-B4AB-EBEB8FEB9F4B}"/>
+                <a16:creationId xmlns:a16="http://schemas.microsoft.com/office/drawing/2014/main" id="{F6F6D50F-8347-4CF6-AC78-F5B95CF31566}"/>
               </a:ext>
             </a:extLst>
           </p:cNvPr>
@@ -9766,7 +9766,7 @@
           <p:cNvPr id="14" name="">
             <a:extLst xmlns:a="http://schemas.openxmlformats.org/drawingml/2006/main">
               <a:ext uri="{FF2B5EF4-FFF2-40B4-BE49-F238E27FC236}">
-                <a16:creationId xmlns:a16="http://schemas.microsoft.com/office/drawing/2014/main" id="{65DD8AD1-B8CF-46E7-876E-3ABD14F12DFC}"/>
+                <a16:creationId xmlns:a16="http://schemas.microsoft.com/office/drawing/2014/main" id="{15D05AC2-E148-4CAF-8F13-AA4A0953A46A}"/>
               </a:ext>
             </a:extLst>
           </p:cNvPr>
@@ -9801,7 +9801,7 @@
           <p:cNvPr id="15" name="">
             <a:extLst xmlns:a="http://schemas.openxmlformats.org/drawingml/2006/main">
               <a:ext uri="{FF2B5EF4-FFF2-40B4-BE49-F238E27FC236}">
-                <a16:creationId xmlns:a16="http://schemas.microsoft.com/office/drawing/2014/main" id="{A38AA26F-4788-4A8C-B2E9-787E6FF3D0E8}"/>
+                <a16:creationId xmlns:a16="http://schemas.microsoft.com/office/drawing/2014/main" id="{92BCEB43-4524-4B9B-BD6D-CF781DF7E265}"/>
               </a:ext>
             </a:extLst>
           </p:cNvPr>
@@ -9858,7 +9858,7 @@
           <p:cNvPr id="16" name="">
             <a:extLst xmlns:a="http://schemas.openxmlformats.org/drawingml/2006/main">
               <a:ext uri="{FF2B5EF4-FFF2-40B4-BE49-F238E27FC236}">
-                <a16:creationId xmlns:a16="http://schemas.microsoft.com/office/drawing/2014/main" id="{C4CB4D03-4313-4CF5-AFD1-DAD19629255D}"/>
+                <a16:creationId xmlns:a16="http://schemas.microsoft.com/office/drawing/2014/main" id="{BF089281-9B16-4721-8B3A-4989F4D74C4D}"/>
               </a:ext>
             </a:extLst>
           </p:cNvPr>
@@ -9915,7 +9915,7 @@
           <p:cNvPr id="17" name="">
             <a:extLst xmlns:a="http://schemas.openxmlformats.org/drawingml/2006/main">
               <a:ext uri="{FF2B5EF4-FFF2-40B4-BE49-F238E27FC236}">
-                <a16:creationId xmlns:a16="http://schemas.microsoft.com/office/drawing/2014/main" id="{AC4601AE-D4D2-448B-9E7B-1E333A076743}"/>
+                <a16:creationId xmlns:a16="http://schemas.microsoft.com/office/drawing/2014/main" id="{F029DE79-7C48-4713-8A61-B713C4541727}"/>
               </a:ext>
             </a:extLst>
           </p:cNvPr>
@@ -9946,7 +9946,7 @@
           <p:cNvPr id="18" name="">
             <a:extLst xmlns:a="http://schemas.openxmlformats.org/drawingml/2006/main">
               <a:ext uri="{FF2B5EF4-FFF2-40B4-BE49-F238E27FC236}">
-                <a16:creationId xmlns:a16="http://schemas.microsoft.com/office/drawing/2014/main" id="{D8EEB277-9A32-47C4-BDED-D310D49F9809}"/>
+                <a16:creationId xmlns:a16="http://schemas.microsoft.com/office/drawing/2014/main" id="{EC62D3E4-9278-4477-BF1F-C86F175FFB7B}"/>
               </a:ext>
             </a:extLst>
           </p:cNvPr>
@@ -9977,7 +9977,7 @@
           <p:cNvPr id="19" name="">
             <a:extLst xmlns:a="http://schemas.openxmlformats.org/drawingml/2006/main">
               <a:ext uri="{FF2B5EF4-FFF2-40B4-BE49-F238E27FC236}">
-                <a16:creationId xmlns:a16="http://schemas.microsoft.com/office/drawing/2014/main" id="{A4C58375-76A6-4787-8EC4-F85B664324C9}"/>
+                <a16:creationId xmlns:a16="http://schemas.microsoft.com/office/drawing/2014/main" id="{9C2E585C-DCCD-4B6E-8090-033E38DDB48F}"/>
               </a:ext>
             </a:extLst>
           </p:cNvPr>
@@ -10009,7 +10009,7 @@
           <p:cNvPr id="20" name="">
             <a:extLst xmlns:a="http://schemas.openxmlformats.org/drawingml/2006/main">
               <a:ext uri="{FF2B5EF4-FFF2-40B4-BE49-F238E27FC236}">
-                <a16:creationId xmlns:a16="http://schemas.microsoft.com/office/drawing/2014/main" id="{DC39934C-2E80-4EE0-87C1-E4D849E7FFBF}"/>
+                <a16:creationId xmlns:a16="http://schemas.microsoft.com/office/drawing/2014/main" id="{71112855-36F4-4462-AF59-86A06A39A2E6}"/>
               </a:ext>
             </a:extLst>
           </p:cNvPr>
@@ -10040,7 +10040,7 @@
           <p:cNvPr id="21" name="">
             <a:extLst xmlns:a="http://schemas.openxmlformats.org/drawingml/2006/main">
               <a:ext uri="{FF2B5EF4-FFF2-40B4-BE49-F238E27FC236}">
-                <a16:creationId xmlns:a16="http://schemas.microsoft.com/office/drawing/2014/main" id="{B1617856-645E-4C6B-819A-C8585532D0DB}"/>
+                <a16:creationId xmlns:a16="http://schemas.microsoft.com/office/drawing/2014/main" id="{35D283AA-1D02-4E25-86BB-95AE3D932145}"/>
               </a:ext>
             </a:extLst>
           </p:cNvPr>
@@ -10071,7 +10071,7 @@
           <p:cNvPr id="22" name="">
             <a:extLst xmlns:a="http://schemas.openxmlformats.org/drawingml/2006/main">
               <a:ext uri="{FF2B5EF4-FFF2-40B4-BE49-F238E27FC236}">
-                <a16:creationId xmlns:a16="http://schemas.microsoft.com/office/drawing/2014/main" id="{A58410CF-CC33-4CCE-826E-38A3094A02E9}"/>
+                <a16:creationId xmlns:a16="http://schemas.microsoft.com/office/drawing/2014/main" id="{763C023F-A068-407E-B0FE-6B3603DF7E45}"/>
               </a:ext>
             </a:extLst>
           </p:cNvPr>
@@ -10103,7 +10103,7 @@
           <p:cNvPr id="23" name="">
             <a:extLst xmlns:a="http://schemas.openxmlformats.org/drawingml/2006/main">
               <a:ext uri="{FF2B5EF4-FFF2-40B4-BE49-F238E27FC236}">
-                <a16:creationId xmlns:a16="http://schemas.microsoft.com/office/drawing/2014/main" id="{CE35B250-A6B7-4603-BBFF-D7277EFC5DBF}"/>
+                <a16:creationId xmlns:a16="http://schemas.microsoft.com/office/drawing/2014/main" id="{69E3DD63-093C-47BA-8ECB-57A034299A1C}"/>
               </a:ext>
             </a:extLst>
           </p:cNvPr>
@@ -10136,7 +10136,7 @@
           <p:cNvPr id="24" name="">
             <a:extLst xmlns:a="http://schemas.openxmlformats.org/drawingml/2006/main">
               <a:ext uri="{FF2B5EF4-FFF2-40B4-BE49-F238E27FC236}">
-                <a16:creationId xmlns:a16="http://schemas.microsoft.com/office/drawing/2014/main" id="{65C78301-E227-4C80-81A0-CA9D31346303}"/>
+                <a16:creationId xmlns:a16="http://schemas.microsoft.com/office/drawing/2014/main" id="{9E38156C-5F3E-4983-83E9-2EA6E9EF5874}"/>
               </a:ext>
             </a:extLst>
           </p:cNvPr>
@@ -10171,7 +10171,7 @@
           <p:cNvPr id="25" name="">
             <a:extLst xmlns:a="http://schemas.openxmlformats.org/drawingml/2006/main">
               <a:ext uri="{FF2B5EF4-FFF2-40B4-BE49-F238E27FC236}">
-                <a16:creationId xmlns:a16="http://schemas.microsoft.com/office/drawing/2014/main" id="{FA07494A-7345-4CDE-A513-19F63C5D0595}"/>
+                <a16:creationId xmlns:a16="http://schemas.microsoft.com/office/drawing/2014/main" id="{F1C64790-B9FD-4C73-B5AB-C62379C3A717}"/>
               </a:ext>
             </a:extLst>
           </p:cNvPr>
@@ -10228,7 +10228,7 @@
           <p:cNvPr id="26" name="">
             <a:extLst xmlns:a="http://schemas.openxmlformats.org/drawingml/2006/main">
               <a:ext uri="{FF2B5EF4-FFF2-40B4-BE49-F238E27FC236}">
-                <a16:creationId xmlns:a16="http://schemas.microsoft.com/office/drawing/2014/main" id="{1774D2ED-F2D7-4DFA-BE12-F768840DA6B4}"/>
+                <a16:creationId xmlns:a16="http://schemas.microsoft.com/office/drawing/2014/main" id="{547CAA12-1F9B-429B-8083-118A35275300}"/>
               </a:ext>
             </a:extLst>
           </p:cNvPr>
@@ -10285,7 +10285,7 @@
           <p:cNvPr id="27" name="">
             <a:extLst xmlns:a="http://schemas.openxmlformats.org/drawingml/2006/main">
               <a:ext uri="{FF2B5EF4-FFF2-40B4-BE49-F238E27FC236}">
-                <a16:creationId xmlns:a16="http://schemas.microsoft.com/office/drawing/2014/main" id="{65DEAB37-DBCA-4F31-9DC4-4EB9FAB11AF4}"/>
+                <a16:creationId xmlns:a16="http://schemas.microsoft.com/office/drawing/2014/main" id="{094F6CF3-D2EA-4555-882B-0CC4E1ACBB43}"/>
               </a:ext>
             </a:extLst>
           </p:cNvPr>
@@ -10342,7 +10342,7 @@
           <p:cNvPr id="28" name="">
             <a:extLst xmlns:a="http://schemas.openxmlformats.org/drawingml/2006/main">
               <a:ext uri="{FF2B5EF4-FFF2-40B4-BE49-F238E27FC236}">
-                <a16:creationId xmlns:a16="http://schemas.microsoft.com/office/drawing/2014/main" id="{EAA08238-67B3-4F8D-8BF5-BD34D9684F4D}"/>
+                <a16:creationId xmlns:a16="http://schemas.microsoft.com/office/drawing/2014/main" id="{C344B6AB-8E34-4D0B-B7BB-82538A01EF71}"/>
               </a:ext>
             </a:extLst>
           </p:cNvPr>
@@ -10397,7 +10397,7 @@
     </p:spTree>
     <p:extLst>
       <p:ext uri="{BB962C8B-B14F-4D97-AF65-F5344CB8AC3E}">
-        <p14:creationId xmlns:p14="http://schemas.microsoft.com/office/powerpoint/2010/main" val="2013574684"/>
+        <p14:creationId xmlns:p14="http://schemas.microsoft.com/office/powerpoint/2010/main" val="4026212"/>
       </p:ext>
     </p:extLst>
   </p:cSld>
@@ -10428,7 +10428,7 @@
           <p:cNvPr id="18" name="">
             <a:extLst xmlns:a="http://schemas.openxmlformats.org/drawingml/2006/main">
               <a:ext uri="{FF2B5EF4-FFF2-40B4-BE49-F238E27FC236}">
-                <a16:creationId xmlns:a16="http://schemas.microsoft.com/office/drawing/2014/main" id="{D5590CE0-4365-4C35-980A-B24D93F778C9}"/>
+                <a16:creationId xmlns:a16="http://schemas.microsoft.com/office/drawing/2014/main" id="{58236E3A-F443-4E4D-8B4E-08087F8990CD}"/>
               </a:ext>
             </a:extLst>
           </p:cNvPr>
@@ -10459,7 +10459,7 @@
           <p:cNvPr id="2" name="">
             <a:extLst xmlns:a="http://schemas.openxmlformats.org/drawingml/2006/main">
               <a:ext uri="{FF2B5EF4-FFF2-40B4-BE49-F238E27FC236}">
-                <a16:creationId xmlns:a16="http://schemas.microsoft.com/office/drawing/2014/main" id="{CE4C3FB9-8E03-4FF7-9D6D-0C927F8C1C4A}"/>
+                <a16:creationId xmlns:a16="http://schemas.microsoft.com/office/drawing/2014/main" id="{A0D3E1F2-DDE4-4AC1-869E-5550BC4246DB}"/>
               </a:ext>
             </a:extLst>
           </p:cNvPr>
@@ -10490,7 +10490,7 @@
           <p:cNvPr id="3" name="">
             <a:extLst xmlns:a="http://schemas.openxmlformats.org/drawingml/2006/main">
               <a:ext uri="{FF2B5EF4-FFF2-40B4-BE49-F238E27FC236}">
-                <a16:creationId xmlns:a16="http://schemas.microsoft.com/office/drawing/2014/main" id="{2E542BF4-B54E-43FE-AC56-62EBAF60C9EA}"/>
+                <a16:creationId xmlns:a16="http://schemas.microsoft.com/office/drawing/2014/main" id="{E7AFF34A-43A8-4C2E-90A5-8A1EE5D71E19}"/>
               </a:ext>
             </a:extLst>
           </p:cNvPr>
@@ -10547,7 +10547,7 @@
           <p:cNvPr id="4" name="">
             <a:extLst xmlns:a="http://schemas.openxmlformats.org/drawingml/2006/main">
               <a:ext uri="{FF2B5EF4-FFF2-40B4-BE49-F238E27FC236}">
-                <a16:creationId xmlns:a16="http://schemas.microsoft.com/office/drawing/2014/main" id="{1BC84246-B79D-484D-94A6-E1F74663273A}"/>
+                <a16:creationId xmlns:a16="http://schemas.microsoft.com/office/drawing/2014/main" id="{CB243218-AD05-441D-A4B0-DE20F7CB640E}"/>
               </a:ext>
             </a:extLst>
           </p:cNvPr>
@@ -10604,7 +10604,7 @@
           <p:cNvPr id="5" name="">
             <a:extLst xmlns:a="http://schemas.openxmlformats.org/drawingml/2006/main">
               <a:ext uri="{FF2B5EF4-FFF2-40B4-BE49-F238E27FC236}">
-                <a16:creationId xmlns:a16="http://schemas.microsoft.com/office/drawing/2014/main" id="{5176F9F8-B8AF-4761-A62C-F197A1F5F966}"/>
+                <a16:creationId xmlns:a16="http://schemas.microsoft.com/office/drawing/2014/main" id="{C7E47AE4-C237-4E72-AEEC-560A5F5124EA}"/>
               </a:ext>
             </a:extLst>
           </p:cNvPr>
@@ -10637,7 +10637,7 @@
           <p:cNvPr id="6" name="">
             <a:extLst xmlns:a="http://schemas.openxmlformats.org/drawingml/2006/main">
               <a:ext uri="{FF2B5EF4-FFF2-40B4-BE49-F238E27FC236}">
-                <a16:creationId xmlns:a16="http://schemas.microsoft.com/office/drawing/2014/main" id="{3855E2EF-8D6B-4EDF-90F6-0D7D80FFD832}"/>
+                <a16:creationId xmlns:a16="http://schemas.microsoft.com/office/drawing/2014/main" id="{F6F23184-DDF6-4DFF-98AB-94222058E3B9}"/>
               </a:ext>
             </a:extLst>
           </p:cNvPr>
@@ -10672,7 +10672,7 @@
           <p:cNvPr id="7" name="">
             <a:extLst xmlns:a="http://schemas.openxmlformats.org/drawingml/2006/main">
               <a:ext uri="{FF2B5EF4-FFF2-40B4-BE49-F238E27FC236}">
-                <a16:creationId xmlns:a16="http://schemas.microsoft.com/office/drawing/2014/main" id="{406CCDD4-B508-41FC-BAE5-AF4833076077}"/>
+                <a16:creationId xmlns:a16="http://schemas.microsoft.com/office/drawing/2014/main" id="{20A76B82-ECFE-499F-883E-18A728F761BD}"/>
               </a:ext>
             </a:extLst>
           </p:cNvPr>
@@ -10729,7 +10729,7 @@
           <p:cNvPr id="8" name="">
             <a:extLst xmlns:a="http://schemas.openxmlformats.org/drawingml/2006/main">
               <a:ext uri="{FF2B5EF4-FFF2-40B4-BE49-F238E27FC236}">
-                <a16:creationId xmlns:a16="http://schemas.microsoft.com/office/drawing/2014/main" id="{666851FB-44AB-49EE-A643-266418ED71AE}"/>
+                <a16:creationId xmlns:a16="http://schemas.microsoft.com/office/drawing/2014/main" id="{08CDA91F-002B-4144-B0D0-D1AE5C8DE540}"/>
               </a:ext>
             </a:extLst>
           </p:cNvPr>
@@ -10786,7 +10786,7 @@
           <p:cNvPr id="9" name="">
             <a:extLst xmlns:a="http://schemas.openxmlformats.org/drawingml/2006/main">
               <a:ext uri="{FF2B5EF4-FFF2-40B4-BE49-F238E27FC236}">
-                <a16:creationId xmlns:a16="http://schemas.microsoft.com/office/drawing/2014/main" id="{86F1337D-8B99-4EF0-8B9A-ABBF6116E207}"/>
+                <a16:creationId xmlns:a16="http://schemas.microsoft.com/office/drawing/2014/main" id="{79BCAD0C-D505-4508-9B11-A14ABDFD5D05}"/>
               </a:ext>
             </a:extLst>
           </p:cNvPr>
@@ -10866,7 +10866,7 @@
           <p:cNvPr id="10" name="">
             <a:extLst xmlns:a="http://schemas.openxmlformats.org/drawingml/2006/main">
               <a:ext uri="{FF2B5EF4-FFF2-40B4-BE49-F238E27FC236}">
-                <a16:creationId xmlns:a16="http://schemas.microsoft.com/office/drawing/2014/main" id="{08D22DF9-8083-46AB-86CA-2E39C41E35D9}"/>
+                <a16:creationId xmlns:a16="http://schemas.microsoft.com/office/drawing/2014/main" id="{ED04F2F8-3747-411B-A775-A43565400EC0}"/>
               </a:ext>
             </a:extLst>
           </p:cNvPr>
@@ -10923,7 +10923,7 @@
           <p:cNvPr id="11" name="">
             <a:extLst xmlns:a="http://schemas.openxmlformats.org/drawingml/2006/main">
               <a:ext uri="{FF2B5EF4-FFF2-40B4-BE49-F238E27FC236}">
-                <a16:creationId xmlns:a16="http://schemas.microsoft.com/office/drawing/2014/main" id="{DAACD416-AD07-484E-A35F-527015B6E58A}"/>
+                <a16:creationId xmlns:a16="http://schemas.microsoft.com/office/drawing/2014/main" id="{94B28B4B-5EA4-4A29-82D5-8C59ACB93800}"/>
               </a:ext>
             </a:extLst>
           </p:cNvPr>
@@ -10956,7 +10956,7 @@
           <p:cNvPr id="12" name="">
             <a:extLst xmlns:a="http://schemas.openxmlformats.org/drawingml/2006/main">
               <a:ext uri="{FF2B5EF4-FFF2-40B4-BE49-F238E27FC236}">
-                <a16:creationId xmlns:a16="http://schemas.microsoft.com/office/drawing/2014/main" id="{5BA9B9E9-4FF3-4A75-936C-C81396A625EF}"/>
+                <a16:creationId xmlns:a16="http://schemas.microsoft.com/office/drawing/2014/main" id="{DC2B25C0-AE3B-417A-8DD5-9476F791C877}"/>
               </a:ext>
             </a:extLst>
           </p:cNvPr>
@@ -10991,7 +10991,7 @@
           <p:cNvPr id="13" name="">
             <a:extLst xmlns:a="http://schemas.openxmlformats.org/drawingml/2006/main">
               <a:ext uri="{FF2B5EF4-FFF2-40B4-BE49-F238E27FC236}">
-                <a16:creationId xmlns:a16="http://schemas.microsoft.com/office/drawing/2014/main" id="{F275FF8A-CA92-44D4-A9C5-B0C14C5A7A3F}"/>
+                <a16:creationId xmlns:a16="http://schemas.microsoft.com/office/drawing/2014/main" id="{46FB88AB-4995-4331-B084-5540A781CF5E}"/>
               </a:ext>
             </a:extLst>
           </p:cNvPr>
@@ -11048,7 +11048,7 @@
           <p:cNvPr id="14" name="">
             <a:extLst xmlns:a="http://schemas.openxmlformats.org/drawingml/2006/main">
               <a:ext uri="{FF2B5EF4-FFF2-40B4-BE49-F238E27FC236}">
-                <a16:creationId xmlns:a16="http://schemas.microsoft.com/office/drawing/2014/main" id="{9B2478DC-1359-45A5-8EBA-731AE1CC22E5}"/>
+                <a16:creationId xmlns:a16="http://schemas.microsoft.com/office/drawing/2014/main" id="{85469F84-F373-42FB-8DC8-872EF0192E1E}"/>
               </a:ext>
             </a:extLst>
           </p:cNvPr>
@@ -11105,7 +11105,7 @@
           <p:cNvPr id="15" name="">
             <a:extLst xmlns:a="http://schemas.openxmlformats.org/drawingml/2006/main">
               <a:ext uri="{FF2B5EF4-FFF2-40B4-BE49-F238E27FC236}">
-                <a16:creationId xmlns:a16="http://schemas.microsoft.com/office/drawing/2014/main" id="{EC737A4B-8107-4587-8016-CF6999B13B43}"/>
+                <a16:creationId xmlns:a16="http://schemas.microsoft.com/office/drawing/2014/main" id="{708FF333-4A3A-4F8F-A5BE-134713074CB0}"/>
               </a:ext>
             </a:extLst>
           </p:cNvPr>
@@ -11208,7 +11208,7 @@
           <p:cNvPr id="16" name="">
             <a:extLst xmlns:a="http://schemas.openxmlformats.org/drawingml/2006/main">
               <a:ext uri="{FF2B5EF4-FFF2-40B4-BE49-F238E27FC236}">
-                <a16:creationId xmlns:a16="http://schemas.microsoft.com/office/drawing/2014/main" id="{D3790E11-5342-4FAF-BE76-8E96C8D97681}"/>
+                <a16:creationId xmlns:a16="http://schemas.microsoft.com/office/drawing/2014/main" id="{D58919E9-1A6A-4CB2-B2E2-FE1030E5EC1B}"/>
               </a:ext>
             </a:extLst>
           </p:cNvPr>
@@ -11239,7 +11239,7 @@
           <p:cNvPr id="17" name="">
             <a:extLst xmlns:a="http://schemas.openxmlformats.org/drawingml/2006/main">
               <a:ext uri="{FF2B5EF4-FFF2-40B4-BE49-F238E27FC236}">
-                <a16:creationId xmlns:a16="http://schemas.microsoft.com/office/drawing/2014/main" id="{7B3A48CE-FA24-40A1-AA94-A205314D2BB4}"/>
+                <a16:creationId xmlns:a16="http://schemas.microsoft.com/office/drawing/2014/main" id="{30401C89-0640-48CA-9F8D-8CD42FC5DBED}"/>
               </a:ext>
             </a:extLst>
           </p:cNvPr>
@@ -11294,7 +11294,7 @@
     </p:spTree>
     <p:extLst>
       <p:ext uri="{BB962C8B-B14F-4D97-AF65-F5344CB8AC3E}">
-        <p14:creationId xmlns:p14="http://schemas.microsoft.com/office/powerpoint/2010/main" val="1323708151"/>
+        <p14:creationId xmlns:p14="http://schemas.microsoft.com/office/powerpoint/2010/main" val="1202241286"/>
       </p:ext>
     </p:extLst>
   </p:cSld>
@@ -11325,7 +11325,7 @@
           <p:cNvPr id="35" name="">
             <a:extLst xmlns:a="http://schemas.openxmlformats.org/drawingml/2006/main">
               <a:ext uri="{FF2B5EF4-FFF2-40B4-BE49-F238E27FC236}">
-                <a16:creationId xmlns:a16="http://schemas.microsoft.com/office/drawing/2014/main" id="{B5833998-74E2-4A39-B5E3-248485AEBF3E}"/>
+                <a16:creationId xmlns:a16="http://schemas.microsoft.com/office/drawing/2014/main" id="{60F1EF17-9283-407C-A707-9F2059EC5725}"/>
               </a:ext>
             </a:extLst>
           </p:cNvPr>
@@ -11356,7 +11356,7 @@
           <p:cNvPr id="2" name="">
             <a:extLst xmlns:a="http://schemas.openxmlformats.org/drawingml/2006/main">
               <a:ext uri="{FF2B5EF4-FFF2-40B4-BE49-F238E27FC236}">
-                <a16:creationId xmlns:a16="http://schemas.microsoft.com/office/drawing/2014/main" id="{DA356C34-DAF4-4E2E-923F-922C849326AD}"/>
+                <a16:creationId xmlns:a16="http://schemas.microsoft.com/office/drawing/2014/main" id="{F948AC81-D1E1-432D-916C-FFB14788A814}"/>
               </a:ext>
             </a:extLst>
           </p:cNvPr>
@@ -11387,7 +11387,7 @@
           <p:cNvPr id="3" name="">
             <a:extLst xmlns:a="http://schemas.openxmlformats.org/drawingml/2006/main">
               <a:ext uri="{FF2B5EF4-FFF2-40B4-BE49-F238E27FC236}">
-                <a16:creationId xmlns:a16="http://schemas.microsoft.com/office/drawing/2014/main" id="{0E6B608F-6E4B-40AC-87DA-250D74A53F64}"/>
+                <a16:creationId xmlns:a16="http://schemas.microsoft.com/office/drawing/2014/main" id="{F182945B-A718-4117-B137-F0301832B570}"/>
               </a:ext>
             </a:extLst>
           </p:cNvPr>
@@ -11444,7 +11444,7 @@
           <p:cNvPr id="4" name="">
             <a:extLst xmlns:a="http://schemas.openxmlformats.org/drawingml/2006/main">
               <a:ext uri="{FF2B5EF4-FFF2-40B4-BE49-F238E27FC236}">
-                <a16:creationId xmlns:a16="http://schemas.microsoft.com/office/drawing/2014/main" id="{516A2875-726C-4A5C-B62D-26B8A96E3126}"/>
+                <a16:creationId xmlns:a16="http://schemas.microsoft.com/office/drawing/2014/main" id="{FE444239-8507-432A-9BAD-E4BDA06BF504}"/>
               </a:ext>
             </a:extLst>
           </p:cNvPr>
@@ -11501,7 +11501,7 @@
           <p:cNvPr id="5" name="">
             <a:extLst xmlns:a="http://schemas.openxmlformats.org/drawingml/2006/main">
               <a:ext uri="{FF2B5EF4-FFF2-40B4-BE49-F238E27FC236}">
-                <a16:creationId xmlns:a16="http://schemas.microsoft.com/office/drawing/2014/main" id="{B4A24A9C-2711-4B37-B3DB-8CC3C5FE450A}"/>
+                <a16:creationId xmlns:a16="http://schemas.microsoft.com/office/drawing/2014/main" id="{131354C1-25B9-434B-9E01-067CE6AAAE79}"/>
               </a:ext>
             </a:extLst>
           </p:cNvPr>
@@ -11534,7 +11534,7 @@
           <p:cNvPr id="6" name="">
             <a:extLst xmlns:a="http://schemas.openxmlformats.org/drawingml/2006/main">
               <a:ext uri="{FF2B5EF4-FFF2-40B4-BE49-F238E27FC236}">
-                <a16:creationId xmlns:a16="http://schemas.microsoft.com/office/drawing/2014/main" id="{67AE346C-C19D-483E-BAE8-210F0029F445}"/>
+                <a16:creationId xmlns:a16="http://schemas.microsoft.com/office/drawing/2014/main" id="{A3553B28-F099-4F89-8ADB-466573874085}"/>
               </a:ext>
             </a:extLst>
           </p:cNvPr>
@@ -11569,7 +11569,7 @@
           <p:cNvPr id="7" name="">
             <a:extLst xmlns:a="http://schemas.openxmlformats.org/drawingml/2006/main">
               <a:ext uri="{FF2B5EF4-FFF2-40B4-BE49-F238E27FC236}">
-                <a16:creationId xmlns:a16="http://schemas.microsoft.com/office/drawing/2014/main" id="{F11E9A1C-9655-41F1-9D44-C45D12ABE41A}"/>
+                <a16:creationId xmlns:a16="http://schemas.microsoft.com/office/drawing/2014/main" id="{83AB1F6B-1C92-451E-81E2-F02365C4E19F}"/>
               </a:ext>
             </a:extLst>
           </p:cNvPr>
@@ -11626,7 +11626,7 @@
           <p:cNvPr id="8" name="">
             <a:extLst xmlns:a="http://schemas.openxmlformats.org/drawingml/2006/main">
               <a:ext uri="{FF2B5EF4-FFF2-40B4-BE49-F238E27FC236}">
-                <a16:creationId xmlns:a16="http://schemas.microsoft.com/office/drawing/2014/main" id="{AED0BFAB-810D-40FB-B4F7-B04149A94277}"/>
+                <a16:creationId xmlns:a16="http://schemas.microsoft.com/office/drawing/2014/main" id="{2183CFD3-849A-4E31-B11E-609528412085}"/>
               </a:ext>
             </a:extLst>
           </p:cNvPr>
@@ -11683,7 +11683,7 @@
           <p:cNvPr id="9" name="">
             <a:extLst xmlns:a="http://schemas.openxmlformats.org/drawingml/2006/main">
               <a:ext uri="{FF2B5EF4-FFF2-40B4-BE49-F238E27FC236}">
-                <a16:creationId xmlns:a16="http://schemas.microsoft.com/office/drawing/2014/main" id="{70C5227D-DE38-411D-AD18-5A40A0A1043C}"/>
+                <a16:creationId xmlns:a16="http://schemas.microsoft.com/office/drawing/2014/main" id="{44FDC5D2-C5D6-4466-B24F-45BD17B5B27A}"/>
               </a:ext>
             </a:extLst>
           </p:cNvPr>
@@ -11716,7 +11716,7 @@
           <p:cNvPr id="10" name="">
             <a:extLst xmlns:a="http://schemas.openxmlformats.org/drawingml/2006/main">
               <a:ext uri="{FF2B5EF4-FFF2-40B4-BE49-F238E27FC236}">
-                <a16:creationId xmlns:a16="http://schemas.microsoft.com/office/drawing/2014/main" id="{9C82E149-669C-47B9-A541-77029813891F}"/>
+                <a16:creationId xmlns:a16="http://schemas.microsoft.com/office/drawing/2014/main" id="{39735D01-ACC3-49E5-BE58-68F491816BB5}"/>
               </a:ext>
             </a:extLst>
           </p:cNvPr>
@@ -11751,7 +11751,7 @@
           <p:cNvPr id="11" name="">
             <a:extLst xmlns:a="http://schemas.openxmlformats.org/drawingml/2006/main">
               <a:ext uri="{FF2B5EF4-FFF2-40B4-BE49-F238E27FC236}">
-                <a16:creationId xmlns:a16="http://schemas.microsoft.com/office/drawing/2014/main" id="{7F13629F-B1DC-4935-84C4-62FBE957022F}"/>
+                <a16:creationId xmlns:a16="http://schemas.microsoft.com/office/drawing/2014/main" id="{44C84906-B669-4838-B8F4-082F7F5FE988}"/>
               </a:ext>
             </a:extLst>
           </p:cNvPr>
@@ -11808,7 +11808,7 @@
           <p:cNvPr id="12" name="">
             <a:extLst xmlns:a="http://schemas.openxmlformats.org/drawingml/2006/main">
               <a:ext uri="{FF2B5EF4-FFF2-40B4-BE49-F238E27FC236}">
-                <a16:creationId xmlns:a16="http://schemas.microsoft.com/office/drawing/2014/main" id="{0812FE60-3CBC-43B9-A3E5-0268CAFA3766}"/>
+                <a16:creationId xmlns:a16="http://schemas.microsoft.com/office/drawing/2014/main" id="{18161B53-F992-46E5-BADE-0A83AAA21A35}"/>
               </a:ext>
             </a:extLst>
           </p:cNvPr>
@@ -11865,7 +11865,7 @@
           <p:cNvPr id="13" name="">
             <a:extLst xmlns:a="http://schemas.openxmlformats.org/drawingml/2006/main">
               <a:ext uri="{FF2B5EF4-FFF2-40B4-BE49-F238E27FC236}">
-                <a16:creationId xmlns:a16="http://schemas.microsoft.com/office/drawing/2014/main" id="{F6FD7307-D9DA-4FF6-8153-5FBB55998486}"/>
+                <a16:creationId xmlns:a16="http://schemas.microsoft.com/office/drawing/2014/main" id="{29762B34-932E-4D0E-A47A-D85E7C2DF1B1}"/>
               </a:ext>
             </a:extLst>
           </p:cNvPr>
@@ -11898,7 +11898,7 @@
           <p:cNvPr id="14" name="">
             <a:extLst xmlns:a="http://schemas.openxmlformats.org/drawingml/2006/main">
               <a:ext uri="{FF2B5EF4-FFF2-40B4-BE49-F238E27FC236}">
-                <a16:creationId xmlns:a16="http://schemas.microsoft.com/office/drawing/2014/main" id="{2FC6E551-DE12-4937-9A84-7DFE5C19E23A}"/>
+                <a16:creationId xmlns:a16="http://schemas.microsoft.com/office/drawing/2014/main" id="{E9E0B66F-8194-45F7-ABA2-BA66DE278468}"/>
               </a:ext>
             </a:extLst>
           </p:cNvPr>
@@ -11933,7 +11933,7 @@
           <p:cNvPr id="15" name="">
             <a:extLst xmlns:a="http://schemas.openxmlformats.org/drawingml/2006/main">
               <a:ext uri="{FF2B5EF4-FFF2-40B4-BE49-F238E27FC236}">
-                <a16:creationId xmlns:a16="http://schemas.microsoft.com/office/drawing/2014/main" id="{EE4A2752-4274-47EE-A6D1-764DD9E465DB}"/>
+                <a16:creationId xmlns:a16="http://schemas.microsoft.com/office/drawing/2014/main" id="{EDCBBD17-A52C-4E98-A030-63356422693A}"/>
               </a:ext>
             </a:extLst>
           </p:cNvPr>
@@ -11990,7 +11990,7 @@
           <p:cNvPr id="16" name="">
             <a:extLst xmlns:a="http://schemas.openxmlformats.org/drawingml/2006/main">
               <a:ext uri="{FF2B5EF4-FFF2-40B4-BE49-F238E27FC236}">
-                <a16:creationId xmlns:a16="http://schemas.microsoft.com/office/drawing/2014/main" id="{50226062-29F6-4970-9E87-E56E02BEEE0E}"/>
+                <a16:creationId xmlns:a16="http://schemas.microsoft.com/office/drawing/2014/main" id="{33F613F0-6111-478E-894E-D2CA6F7111DF}"/>
               </a:ext>
             </a:extLst>
           </p:cNvPr>
@@ -12047,7 +12047,7 @@
           <p:cNvPr id="17" name="">
             <a:extLst xmlns:a="http://schemas.openxmlformats.org/drawingml/2006/main">
               <a:ext uri="{FF2B5EF4-FFF2-40B4-BE49-F238E27FC236}">
-                <a16:creationId xmlns:a16="http://schemas.microsoft.com/office/drawing/2014/main" id="{50175B28-758C-42FA-9212-A06468792305}"/>
+                <a16:creationId xmlns:a16="http://schemas.microsoft.com/office/drawing/2014/main" id="{C5424F65-7FFF-4573-A321-B67C4C9D55FC}"/>
               </a:ext>
             </a:extLst>
           </p:cNvPr>
@@ -12080,7 +12080,7 @@
           <p:cNvPr id="18" name="">
             <a:extLst xmlns:a="http://schemas.openxmlformats.org/drawingml/2006/main">
               <a:ext uri="{FF2B5EF4-FFF2-40B4-BE49-F238E27FC236}">
-                <a16:creationId xmlns:a16="http://schemas.microsoft.com/office/drawing/2014/main" id="{5F3B27C3-3ED8-43E6-AC5D-320BE600563C}"/>
+                <a16:creationId xmlns:a16="http://schemas.microsoft.com/office/drawing/2014/main" id="{97609E0F-D533-4B50-9E61-81D640E6AD56}"/>
               </a:ext>
             </a:extLst>
           </p:cNvPr>
@@ -12115,7 +12115,7 @@
           <p:cNvPr id="19" name="">
             <a:extLst xmlns:a="http://schemas.openxmlformats.org/drawingml/2006/main">
               <a:ext uri="{FF2B5EF4-FFF2-40B4-BE49-F238E27FC236}">
-                <a16:creationId xmlns:a16="http://schemas.microsoft.com/office/drawing/2014/main" id="{2B5B6226-5C06-400A-9FA9-38B83E9585CB}"/>
+                <a16:creationId xmlns:a16="http://schemas.microsoft.com/office/drawing/2014/main" id="{56FDBA00-D7A9-498D-B7D0-54E354ADA07B}"/>
               </a:ext>
             </a:extLst>
           </p:cNvPr>
@@ -12172,7 +12172,7 @@
           <p:cNvPr id="20" name="">
             <a:extLst xmlns:a="http://schemas.openxmlformats.org/drawingml/2006/main">
               <a:ext uri="{FF2B5EF4-FFF2-40B4-BE49-F238E27FC236}">
-                <a16:creationId xmlns:a16="http://schemas.microsoft.com/office/drawing/2014/main" id="{B8229F65-BE3E-43DE-A2C8-3CB5FC530015}"/>
+                <a16:creationId xmlns:a16="http://schemas.microsoft.com/office/drawing/2014/main" id="{1F117318-E68E-41C3-92BE-B5A5F1B65876}"/>
               </a:ext>
             </a:extLst>
           </p:cNvPr>
@@ -12229,7 +12229,7 @@
           <p:cNvPr id="21" name="">
             <a:extLst xmlns:a="http://schemas.openxmlformats.org/drawingml/2006/main">
               <a:ext uri="{FF2B5EF4-FFF2-40B4-BE49-F238E27FC236}">
-                <a16:creationId xmlns:a16="http://schemas.microsoft.com/office/drawing/2014/main" id="{B69B7A84-8F38-4306-BDE8-9B95C5D49821}"/>
+                <a16:creationId xmlns:a16="http://schemas.microsoft.com/office/drawing/2014/main" id="{B509F4DE-8578-4ACC-8853-6BBE06FF7012}"/>
               </a:ext>
             </a:extLst>
           </p:cNvPr>
@@ -12260,7 +12260,7 @@
           <p:cNvPr id="22" name="">
             <a:extLst xmlns:a="http://schemas.openxmlformats.org/drawingml/2006/main">
               <a:ext uri="{FF2B5EF4-FFF2-40B4-BE49-F238E27FC236}">
-                <a16:creationId xmlns:a16="http://schemas.microsoft.com/office/drawing/2014/main" id="{999F5F08-940F-4B93-86F8-1CD8B14F27C8}"/>
+                <a16:creationId xmlns:a16="http://schemas.microsoft.com/office/drawing/2014/main" id="{00DC7EC2-9707-4BCE-B4AF-52E8AF86CB40}"/>
               </a:ext>
             </a:extLst>
           </p:cNvPr>
@@ -12291,7 +12291,7 @@
           <p:cNvPr id="23" name="">
             <a:extLst xmlns:a="http://schemas.openxmlformats.org/drawingml/2006/main">
               <a:ext uri="{FF2B5EF4-FFF2-40B4-BE49-F238E27FC236}">
-                <a16:creationId xmlns:a16="http://schemas.microsoft.com/office/drawing/2014/main" id="{A5899E09-CA59-40C8-BDD8-C42F9DCC9C37}"/>
+                <a16:creationId xmlns:a16="http://schemas.microsoft.com/office/drawing/2014/main" id="{A3A0E9B1-4ACE-489B-99FE-91DF9FEA6068}"/>
               </a:ext>
             </a:extLst>
           </p:cNvPr>
@@ -12323,7 +12323,7 @@
           <p:cNvPr id="24" name="">
             <a:extLst xmlns:a="http://schemas.openxmlformats.org/drawingml/2006/main">
               <a:ext uri="{FF2B5EF4-FFF2-40B4-BE49-F238E27FC236}">
-                <a16:creationId xmlns:a16="http://schemas.microsoft.com/office/drawing/2014/main" id="{761C420E-58C0-4221-803C-AB55EFB41EB0}"/>
+                <a16:creationId xmlns:a16="http://schemas.microsoft.com/office/drawing/2014/main" id="{12C9D60E-4907-435D-8C7B-435012AE1B44}"/>
               </a:ext>
             </a:extLst>
           </p:cNvPr>
@@ -12354,7 +12354,7 @@
           <p:cNvPr id="25" name="">
             <a:extLst xmlns:a="http://schemas.openxmlformats.org/drawingml/2006/main">
               <a:ext uri="{FF2B5EF4-FFF2-40B4-BE49-F238E27FC236}">
-                <a16:creationId xmlns:a16="http://schemas.microsoft.com/office/drawing/2014/main" id="{83F66823-D003-4D40-9A88-04AA1BFE11E4}"/>
+                <a16:creationId xmlns:a16="http://schemas.microsoft.com/office/drawing/2014/main" id="{71E366D4-C5AA-48E4-AA77-C48D1D325554}"/>
               </a:ext>
             </a:extLst>
           </p:cNvPr>
@@ -12385,7 +12385,7 @@
           <p:cNvPr id="26" name="">
             <a:extLst xmlns:a="http://schemas.openxmlformats.org/drawingml/2006/main">
               <a:ext uri="{FF2B5EF4-FFF2-40B4-BE49-F238E27FC236}">
-                <a16:creationId xmlns:a16="http://schemas.microsoft.com/office/drawing/2014/main" id="{ED09358D-D43E-4047-9D50-F51F03781684}"/>
+                <a16:creationId xmlns:a16="http://schemas.microsoft.com/office/drawing/2014/main" id="{65762C86-DA9C-478A-9EAC-95AC00930BB2}"/>
               </a:ext>
             </a:extLst>
           </p:cNvPr>
@@ -12416,7 +12416,7 @@
           <p:cNvPr id="27" name="">
             <a:extLst xmlns:a="http://schemas.openxmlformats.org/drawingml/2006/main">
               <a:ext uri="{FF2B5EF4-FFF2-40B4-BE49-F238E27FC236}">
-                <a16:creationId xmlns:a16="http://schemas.microsoft.com/office/drawing/2014/main" id="{53AA7CB1-6C58-4301-B5D6-490F013EB211}"/>
+                <a16:creationId xmlns:a16="http://schemas.microsoft.com/office/drawing/2014/main" id="{19FAC469-49DE-4496-B3DD-9E9584E9B4DB}"/>
               </a:ext>
             </a:extLst>
           </p:cNvPr>
@@ -12448,7 +12448,7 @@
           <p:cNvPr id="28" name="">
             <a:extLst xmlns:a="http://schemas.openxmlformats.org/drawingml/2006/main">
               <a:ext uri="{FF2B5EF4-FFF2-40B4-BE49-F238E27FC236}">
-                <a16:creationId xmlns:a16="http://schemas.microsoft.com/office/drawing/2014/main" id="{DFAE1E7C-5094-4086-96A8-F515187DF1A3}"/>
+                <a16:creationId xmlns:a16="http://schemas.microsoft.com/office/drawing/2014/main" id="{1F5375CC-0227-43B0-9198-9044E343FB30}"/>
               </a:ext>
             </a:extLst>
           </p:cNvPr>
@@ -12479,7 +12479,7 @@
           <p:cNvPr id="29" name="">
             <a:extLst xmlns:a="http://schemas.openxmlformats.org/drawingml/2006/main">
               <a:ext uri="{FF2B5EF4-FFF2-40B4-BE49-F238E27FC236}">
-                <a16:creationId xmlns:a16="http://schemas.microsoft.com/office/drawing/2014/main" id="{FC3C880A-287B-4DF7-9A19-976CE0493323}"/>
+                <a16:creationId xmlns:a16="http://schemas.microsoft.com/office/drawing/2014/main" id="{F5293AEB-516E-4504-A74C-EEDDF05DF336}"/>
               </a:ext>
             </a:extLst>
           </p:cNvPr>
@@ -12510,7 +12510,7 @@
           <p:cNvPr id="30" name="">
             <a:extLst xmlns:a="http://schemas.openxmlformats.org/drawingml/2006/main">
               <a:ext uri="{FF2B5EF4-FFF2-40B4-BE49-F238E27FC236}">
-                <a16:creationId xmlns:a16="http://schemas.microsoft.com/office/drawing/2014/main" id="{AF466D5B-56FA-4187-82EA-4BD0CF294690}"/>
+                <a16:creationId xmlns:a16="http://schemas.microsoft.com/office/drawing/2014/main" id="{44010568-AE22-4708-B99E-5D6788B0CE82}"/>
               </a:ext>
             </a:extLst>
           </p:cNvPr>
@@ -12541,7 +12541,7 @@
           <p:cNvPr id="31" name="">
             <a:extLst xmlns:a="http://schemas.openxmlformats.org/drawingml/2006/main">
               <a:ext uri="{FF2B5EF4-FFF2-40B4-BE49-F238E27FC236}">
-                <a16:creationId xmlns:a16="http://schemas.microsoft.com/office/drawing/2014/main" id="{908A88AA-D6BC-4464-8EE4-A5CE6A126D9B}"/>
+                <a16:creationId xmlns:a16="http://schemas.microsoft.com/office/drawing/2014/main" id="{4237C19D-79D9-482F-8F67-CFCA411CA517}"/>
               </a:ext>
             </a:extLst>
           </p:cNvPr>
@@ -12573,7 +12573,7 @@
           <p:cNvPr id="32" name="">
             <a:extLst xmlns:a="http://schemas.openxmlformats.org/drawingml/2006/main">
               <a:ext uri="{FF2B5EF4-FFF2-40B4-BE49-F238E27FC236}">
-                <a16:creationId xmlns:a16="http://schemas.microsoft.com/office/drawing/2014/main" id="{B46394F5-2A81-4F8E-805B-D0500F6D495F}"/>
+                <a16:creationId xmlns:a16="http://schemas.microsoft.com/office/drawing/2014/main" id="{C6037BE6-255F-4BEE-B6D5-AE98F00F9130}"/>
               </a:ext>
             </a:extLst>
           </p:cNvPr>
@@ -12630,7 +12630,7 @@
           <p:cNvPr id="33" name="">
             <a:extLst xmlns:a="http://schemas.openxmlformats.org/drawingml/2006/main">
               <a:ext uri="{FF2B5EF4-FFF2-40B4-BE49-F238E27FC236}">
-                <a16:creationId xmlns:a16="http://schemas.microsoft.com/office/drawing/2014/main" id="{98EEA013-5097-4491-AE0E-423DAC488D23}"/>
+                <a16:creationId xmlns:a16="http://schemas.microsoft.com/office/drawing/2014/main" id="{8408CDB2-C4BE-4F23-A983-24414E9E17D2}"/>
               </a:ext>
             </a:extLst>
           </p:cNvPr>
@@ -12687,7 +12687,7 @@
           <p:cNvPr id="34" name="">
             <a:extLst xmlns:a="http://schemas.openxmlformats.org/drawingml/2006/main">
               <a:ext uri="{FF2B5EF4-FFF2-40B4-BE49-F238E27FC236}">
-                <a16:creationId xmlns:a16="http://schemas.microsoft.com/office/drawing/2014/main" id="{021DB452-28C0-45AC-9F66-85096B45B1D8}"/>
+                <a16:creationId xmlns:a16="http://schemas.microsoft.com/office/drawing/2014/main" id="{3DEFB6FE-8112-4D45-89C6-4392EA978A66}"/>
               </a:ext>
             </a:extLst>
           </p:cNvPr>
@@ -12742,7 +12742,7 @@
     </p:spTree>
     <p:extLst>
       <p:ext uri="{BB962C8B-B14F-4D97-AF65-F5344CB8AC3E}">
-        <p14:creationId xmlns:p14="http://schemas.microsoft.com/office/powerpoint/2010/main" val="919218409"/>
+        <p14:creationId xmlns:p14="http://schemas.microsoft.com/office/powerpoint/2010/main" val="1642269509"/>
       </p:ext>
     </p:extLst>
   </p:cSld>
@@ -12773,7 +12773,7 @@
           <p:cNvPr id="7" name="">
             <a:extLst xmlns:a="http://schemas.openxmlformats.org/drawingml/2006/main">
               <a:ext uri="{FF2B5EF4-FFF2-40B4-BE49-F238E27FC236}">
-                <a16:creationId xmlns:a16="http://schemas.microsoft.com/office/drawing/2014/main" id="{C73BB8DA-E626-4D33-8730-DA65C1F90BDE}"/>
+                <a16:creationId xmlns:a16="http://schemas.microsoft.com/office/drawing/2014/main" id="{78904317-B23F-4E72-8B7D-467506776893}"/>
               </a:ext>
             </a:extLst>
           </p:cNvPr>
@@ -12804,7 +12804,7 @@
           <p:cNvPr id="2" name="">
             <a:extLst xmlns:a="http://schemas.openxmlformats.org/drawingml/2006/main">
               <a:ext uri="{FF2B5EF4-FFF2-40B4-BE49-F238E27FC236}">
-                <a16:creationId xmlns:a16="http://schemas.microsoft.com/office/drawing/2014/main" id="{E176468A-F97C-422C-A87D-6DE86AE2C722}"/>
+                <a16:creationId xmlns:a16="http://schemas.microsoft.com/office/drawing/2014/main" id="{D298A91F-312F-4698-853B-2A5FD3E2BC4F}"/>
               </a:ext>
             </a:extLst>
           </p:cNvPr>
@@ -12835,7 +12835,7 @@
           <p:cNvPr id="3" name="">
             <a:extLst xmlns:a="http://schemas.openxmlformats.org/drawingml/2006/main">
               <a:ext uri="{FF2B5EF4-FFF2-40B4-BE49-F238E27FC236}">
-                <a16:creationId xmlns:a16="http://schemas.microsoft.com/office/drawing/2014/main" id="{B4A49348-61C5-4B12-B191-9750CAA674BA}"/>
+                <a16:creationId xmlns:a16="http://schemas.microsoft.com/office/drawing/2014/main" id="{43A0B123-C57C-448A-A0F6-D3271BDF1563}"/>
               </a:ext>
             </a:extLst>
           </p:cNvPr>
@@ -12892,7 +12892,7 @@
           <p:cNvPr id="4" name="">
             <a:extLst xmlns:a="http://schemas.openxmlformats.org/drawingml/2006/main">
               <a:ext uri="{FF2B5EF4-FFF2-40B4-BE49-F238E27FC236}">
-                <a16:creationId xmlns:a16="http://schemas.microsoft.com/office/drawing/2014/main" id="{9E69EEB6-012F-4BAB-B892-9F849A1AE2B5}"/>
+                <a16:creationId xmlns:a16="http://schemas.microsoft.com/office/drawing/2014/main" id="{57A631E9-AF34-4898-BE0F-4CBDAFB9E4C0}"/>
               </a:ext>
             </a:extLst>
           </p:cNvPr>
@@ -13513,7 +13513,7 @@
           <p:cNvPr id="6" name="">
             <a:extLst xmlns:a="http://schemas.openxmlformats.org/drawingml/2006/main">
               <a:ext uri="{FF2B5EF4-FFF2-40B4-BE49-F238E27FC236}">
-                <a16:creationId xmlns:a16="http://schemas.microsoft.com/office/drawing/2014/main" id="{B62B4D6F-0F1C-4E2F-BB1B-C5FDB7EC1B30}"/>
+                <a16:creationId xmlns:a16="http://schemas.microsoft.com/office/drawing/2014/main" id="{A6F1FDC6-94E0-4FC4-9A52-E6F6EC672FDE}"/>
               </a:ext>
             </a:extLst>
           </p:cNvPr>
@@ -13568,7 +13568,7 @@
     </p:spTree>
     <p:extLst>
       <p:ext uri="{BB962C8B-B14F-4D97-AF65-F5344CB8AC3E}">
-        <p14:creationId xmlns:p14="http://schemas.microsoft.com/office/powerpoint/2010/main" val="858162069"/>
+        <p14:creationId xmlns:p14="http://schemas.microsoft.com/office/powerpoint/2010/main" val="983245625"/>
       </p:ext>
     </p:extLst>
   </p:cSld>
@@ -13599,7 +13599,7 @@
           <p:cNvPr id="28" name="">
             <a:extLst xmlns:a="http://schemas.openxmlformats.org/drawingml/2006/main">
               <a:ext uri="{FF2B5EF4-FFF2-40B4-BE49-F238E27FC236}">
-                <a16:creationId xmlns:a16="http://schemas.microsoft.com/office/drawing/2014/main" id="{3AB4970A-348E-4316-BB35-AA49EDB1E8A1}"/>
+                <a16:creationId xmlns:a16="http://schemas.microsoft.com/office/drawing/2014/main" id="{2260F285-3AD5-4D35-8419-39AED7580B41}"/>
               </a:ext>
             </a:extLst>
           </p:cNvPr>
@@ -13630,7 +13630,7 @@
           <p:cNvPr id="2" name="">
             <a:extLst xmlns:a="http://schemas.openxmlformats.org/drawingml/2006/main">
               <a:ext uri="{FF2B5EF4-FFF2-40B4-BE49-F238E27FC236}">
-                <a16:creationId xmlns:a16="http://schemas.microsoft.com/office/drawing/2014/main" id="{0369E424-A5DB-48D5-A41B-D32521F3A3A4}"/>
+                <a16:creationId xmlns:a16="http://schemas.microsoft.com/office/drawing/2014/main" id="{EB7E4BCE-93FD-4E57-997D-F2DEB5EFF2E2}"/>
               </a:ext>
             </a:extLst>
           </p:cNvPr>
@@ -13661,7 +13661,7 @@
           <p:cNvPr id="3" name="">
             <a:extLst xmlns:a="http://schemas.openxmlformats.org/drawingml/2006/main">
               <a:ext uri="{FF2B5EF4-FFF2-40B4-BE49-F238E27FC236}">
-                <a16:creationId xmlns:a16="http://schemas.microsoft.com/office/drawing/2014/main" id="{B24EAE72-F24A-451C-8E62-8F2015E40EEA}"/>
+                <a16:creationId xmlns:a16="http://schemas.microsoft.com/office/drawing/2014/main" id="{9DDF6B2E-057B-4BAD-A981-7C0E9D5DB8FA}"/>
               </a:ext>
             </a:extLst>
           </p:cNvPr>
@@ -13718,7 +13718,7 @@
           <p:cNvPr id="4" name="">
             <a:extLst xmlns:a="http://schemas.openxmlformats.org/drawingml/2006/main">
               <a:ext uri="{FF2B5EF4-FFF2-40B4-BE49-F238E27FC236}">
-                <a16:creationId xmlns:a16="http://schemas.microsoft.com/office/drawing/2014/main" id="{F15FDC52-F22B-4FDE-B078-F7657768A997}"/>
+                <a16:creationId xmlns:a16="http://schemas.microsoft.com/office/drawing/2014/main" id="{D2CF989A-1D55-4563-AF3C-9345D9F3A965}"/>
               </a:ext>
             </a:extLst>
           </p:cNvPr>
@@ -13775,7 +13775,7 @@
           <p:cNvPr id="5" name="">
             <a:extLst xmlns:a="http://schemas.openxmlformats.org/drawingml/2006/main">
               <a:ext uri="{FF2B5EF4-FFF2-40B4-BE49-F238E27FC236}">
-                <a16:creationId xmlns:a16="http://schemas.microsoft.com/office/drawing/2014/main" id="{99F3627F-EBA0-42A2-9D07-D03F2043F911}"/>
+                <a16:creationId xmlns:a16="http://schemas.microsoft.com/office/drawing/2014/main" id="{7133CF8D-D7CF-4109-9DBF-8AD05120890D}"/>
               </a:ext>
             </a:extLst>
           </p:cNvPr>
@@ -13808,7 +13808,7 @@
           <p:cNvPr id="6" name="">
             <a:extLst xmlns:a="http://schemas.openxmlformats.org/drawingml/2006/main">
               <a:ext uri="{FF2B5EF4-FFF2-40B4-BE49-F238E27FC236}">
-                <a16:creationId xmlns:a16="http://schemas.microsoft.com/office/drawing/2014/main" id="{8B811493-FCAD-478C-9B2A-1261F98A0C39}"/>
+                <a16:creationId xmlns:a16="http://schemas.microsoft.com/office/drawing/2014/main" id="{4D0B1FA3-EB43-467E-BAC4-78F35D1D9845}"/>
               </a:ext>
             </a:extLst>
           </p:cNvPr>
@@ -13843,7 +13843,7 @@
           <p:cNvPr id="7" name="">
             <a:extLst xmlns:a="http://schemas.openxmlformats.org/drawingml/2006/main">
               <a:ext uri="{FF2B5EF4-FFF2-40B4-BE49-F238E27FC236}">
-                <a16:creationId xmlns:a16="http://schemas.microsoft.com/office/drawing/2014/main" id="{1404E116-A505-4F43-AEA5-6FE9E2EB5332}"/>
+                <a16:creationId xmlns:a16="http://schemas.microsoft.com/office/drawing/2014/main" id="{98432331-EB71-45FD-82DE-D6692573C81E}"/>
               </a:ext>
             </a:extLst>
           </p:cNvPr>
@@ -13900,7 +13900,7 @@
           <p:cNvPr id="8" name="">
             <a:extLst xmlns:a="http://schemas.openxmlformats.org/drawingml/2006/main">
               <a:ext uri="{FF2B5EF4-FFF2-40B4-BE49-F238E27FC236}">
-                <a16:creationId xmlns:a16="http://schemas.microsoft.com/office/drawing/2014/main" id="{BEA8E446-139B-4048-8104-0AF9338E3970}"/>
+                <a16:creationId xmlns:a16="http://schemas.microsoft.com/office/drawing/2014/main" id="{C515A8B5-C562-40DD-B1E9-B92BB9C3A713}"/>
               </a:ext>
             </a:extLst>
           </p:cNvPr>
@@ -13957,7 +13957,7 @@
           <p:cNvPr id="9" name="">
             <a:extLst xmlns:a="http://schemas.openxmlformats.org/drawingml/2006/main">
               <a:ext uri="{FF2B5EF4-FFF2-40B4-BE49-F238E27FC236}">
-                <a16:creationId xmlns:a16="http://schemas.microsoft.com/office/drawing/2014/main" id="{E2505846-5B92-43AD-AF0A-8BF89FCD9D76}"/>
+                <a16:creationId xmlns:a16="http://schemas.microsoft.com/office/drawing/2014/main" id="{71151A1D-16C3-47E4-80DF-A48782CD64C6}"/>
               </a:ext>
             </a:extLst>
           </p:cNvPr>
@@ -14014,7 +14014,7 @@
           <p:cNvPr id="10" name="">
             <a:extLst xmlns:a="http://schemas.openxmlformats.org/drawingml/2006/main">
               <a:ext uri="{FF2B5EF4-FFF2-40B4-BE49-F238E27FC236}">
-                <a16:creationId xmlns:a16="http://schemas.microsoft.com/office/drawing/2014/main" id="{308BC0F1-B63C-47BA-8642-36C720E8326C}"/>
+                <a16:creationId xmlns:a16="http://schemas.microsoft.com/office/drawing/2014/main" id="{352A228C-527C-4F04-8D49-939DA716982B}"/>
               </a:ext>
             </a:extLst>
           </p:cNvPr>
@@ -14047,7 +14047,7 @@
           <p:cNvPr id="11" name="">
             <a:extLst xmlns:a="http://schemas.openxmlformats.org/drawingml/2006/main">
               <a:ext uri="{FF2B5EF4-FFF2-40B4-BE49-F238E27FC236}">
-                <a16:creationId xmlns:a16="http://schemas.microsoft.com/office/drawing/2014/main" id="{42D4A57C-63EE-4858-A6C4-9A6F78A555F5}"/>
+                <a16:creationId xmlns:a16="http://schemas.microsoft.com/office/drawing/2014/main" id="{D9AFBF93-9E80-45F2-9246-CB3424540833}"/>
               </a:ext>
             </a:extLst>
           </p:cNvPr>
@@ -14082,7 +14082,7 @@
           <p:cNvPr id="12" name="">
             <a:extLst xmlns:a="http://schemas.openxmlformats.org/drawingml/2006/main">
               <a:ext uri="{FF2B5EF4-FFF2-40B4-BE49-F238E27FC236}">
-                <a16:creationId xmlns:a16="http://schemas.microsoft.com/office/drawing/2014/main" id="{3535CDB7-2718-4132-B5F6-27C3769506CD}"/>
+                <a16:creationId xmlns:a16="http://schemas.microsoft.com/office/drawing/2014/main" id="{75E7A0C9-4ACE-458A-B6FC-39FCA393BE3D}"/>
               </a:ext>
             </a:extLst>
           </p:cNvPr>
@@ -14139,7 +14139,7 @@
           <p:cNvPr id="13" name="">
             <a:extLst xmlns:a="http://schemas.openxmlformats.org/drawingml/2006/main">
               <a:ext uri="{FF2B5EF4-FFF2-40B4-BE49-F238E27FC236}">
-                <a16:creationId xmlns:a16="http://schemas.microsoft.com/office/drawing/2014/main" id="{72E304A3-5FCC-4AFF-9C44-F7DD56A2CEBF}"/>
+                <a16:creationId xmlns:a16="http://schemas.microsoft.com/office/drawing/2014/main" id="{C8807565-7421-4BFE-9A8F-5DAC28199B7C}"/>
               </a:ext>
             </a:extLst>
           </p:cNvPr>
@@ -14196,7 +14196,7 @@
           <p:cNvPr id="14" name="">
             <a:extLst xmlns:a="http://schemas.openxmlformats.org/drawingml/2006/main">
               <a:ext uri="{FF2B5EF4-FFF2-40B4-BE49-F238E27FC236}">
-                <a16:creationId xmlns:a16="http://schemas.microsoft.com/office/drawing/2014/main" id="{CCC60568-26EE-4062-A50B-66B180E724CF}"/>
+                <a16:creationId xmlns:a16="http://schemas.microsoft.com/office/drawing/2014/main" id="{D95B2026-FAE5-4B5B-A71A-551F6FDEAA0D}"/>
               </a:ext>
             </a:extLst>
           </p:cNvPr>
@@ -14253,7 +14253,7 @@
           <p:cNvPr id="15" name="">
             <a:extLst xmlns:a="http://schemas.openxmlformats.org/drawingml/2006/main">
               <a:ext uri="{FF2B5EF4-FFF2-40B4-BE49-F238E27FC236}">
-                <a16:creationId xmlns:a16="http://schemas.microsoft.com/office/drawing/2014/main" id="{516DEC02-BD8B-4CA4-8C81-CEDBCCC41E3A}"/>
+                <a16:creationId xmlns:a16="http://schemas.microsoft.com/office/drawing/2014/main" id="{055284B5-AE3A-4F5C-9D66-292EADFF72CD}"/>
               </a:ext>
             </a:extLst>
           </p:cNvPr>
@@ -14286,7 +14286,7 @@
           <p:cNvPr id="16" name="">
             <a:extLst xmlns:a="http://schemas.openxmlformats.org/drawingml/2006/main">
               <a:ext uri="{FF2B5EF4-FFF2-40B4-BE49-F238E27FC236}">
-                <a16:creationId xmlns:a16="http://schemas.microsoft.com/office/drawing/2014/main" id="{EE071F00-18B3-4543-AB4B-8EEFC84B2EA0}"/>
+                <a16:creationId xmlns:a16="http://schemas.microsoft.com/office/drawing/2014/main" id="{94A19D9F-45E9-4494-98C6-B2D40A8F59D6}"/>
               </a:ext>
             </a:extLst>
           </p:cNvPr>
@@ -14321,7 +14321,7 @@
           <p:cNvPr id="17" name="">
             <a:extLst xmlns:a="http://schemas.openxmlformats.org/drawingml/2006/main">
               <a:ext uri="{FF2B5EF4-FFF2-40B4-BE49-F238E27FC236}">
-                <a16:creationId xmlns:a16="http://schemas.microsoft.com/office/drawing/2014/main" id="{73BC4A23-F473-4354-B61B-E9DCF58DF6FD}"/>
+                <a16:creationId xmlns:a16="http://schemas.microsoft.com/office/drawing/2014/main" id="{B6127807-C15C-499C-A493-CEA1275946FC}"/>
               </a:ext>
             </a:extLst>
           </p:cNvPr>
@@ -14378,7 +14378,7 @@
           <p:cNvPr id="18" name="">
             <a:extLst xmlns:a="http://schemas.openxmlformats.org/drawingml/2006/main">
               <a:ext uri="{FF2B5EF4-FFF2-40B4-BE49-F238E27FC236}">
-                <a16:creationId xmlns:a16="http://schemas.microsoft.com/office/drawing/2014/main" id="{D3ADB205-A187-4899-BDBF-BB88561C8813}"/>
+                <a16:creationId xmlns:a16="http://schemas.microsoft.com/office/drawing/2014/main" id="{46EF459E-43F9-4BFE-8967-241198DCAAC6}"/>
               </a:ext>
             </a:extLst>
           </p:cNvPr>
@@ -14435,7 +14435,7 @@
           <p:cNvPr id="19" name="">
             <a:extLst xmlns:a="http://schemas.openxmlformats.org/drawingml/2006/main">
               <a:ext uri="{FF2B5EF4-FFF2-40B4-BE49-F238E27FC236}">
-                <a16:creationId xmlns:a16="http://schemas.microsoft.com/office/drawing/2014/main" id="{816E88BC-B0A6-418A-8122-544267EC038A}"/>
+                <a16:creationId xmlns:a16="http://schemas.microsoft.com/office/drawing/2014/main" id="{F8C16A43-0EC9-4AD4-BC6B-3AB6820710B1}"/>
               </a:ext>
             </a:extLst>
           </p:cNvPr>
@@ -14492,7 +14492,7 @@
           <p:cNvPr id="20" name="">
             <a:extLst xmlns:a="http://schemas.openxmlformats.org/drawingml/2006/main">
               <a:ext uri="{FF2B5EF4-FFF2-40B4-BE49-F238E27FC236}">
-                <a16:creationId xmlns:a16="http://schemas.microsoft.com/office/drawing/2014/main" id="{C1B0F6EF-7D6D-47C7-AF61-D59EA3E53BFB}"/>
+                <a16:creationId xmlns:a16="http://schemas.microsoft.com/office/drawing/2014/main" id="{351369B3-B2FE-481A-B335-45C6D500210F}"/>
               </a:ext>
             </a:extLst>
           </p:cNvPr>
@@ -14525,7 +14525,7 @@
           <p:cNvPr id="21" name="">
             <a:extLst xmlns:a="http://schemas.openxmlformats.org/drawingml/2006/main">
               <a:ext uri="{FF2B5EF4-FFF2-40B4-BE49-F238E27FC236}">
-                <a16:creationId xmlns:a16="http://schemas.microsoft.com/office/drawing/2014/main" id="{603850C0-0133-4210-B8A2-9410C95B3C40}"/>
+                <a16:creationId xmlns:a16="http://schemas.microsoft.com/office/drawing/2014/main" id="{E21B8BC7-944C-4B5A-9492-E9C8B29F331D}"/>
               </a:ext>
             </a:extLst>
           </p:cNvPr>
@@ -14560,7 +14560,7 @@
           <p:cNvPr id="22" name="">
             <a:extLst xmlns:a="http://schemas.openxmlformats.org/drawingml/2006/main">
               <a:ext uri="{FF2B5EF4-FFF2-40B4-BE49-F238E27FC236}">
-                <a16:creationId xmlns:a16="http://schemas.microsoft.com/office/drawing/2014/main" id="{D111F7B8-E075-4572-B78D-B80C9B454EEF}"/>
+                <a16:creationId xmlns:a16="http://schemas.microsoft.com/office/drawing/2014/main" id="{855FEC8D-1121-465E-B590-9C48AA5049B0}"/>
               </a:ext>
             </a:extLst>
           </p:cNvPr>
@@ -14617,7 +14617,7 @@
           <p:cNvPr id="23" name="">
             <a:extLst xmlns:a="http://schemas.openxmlformats.org/drawingml/2006/main">
               <a:ext uri="{FF2B5EF4-FFF2-40B4-BE49-F238E27FC236}">
-                <a16:creationId xmlns:a16="http://schemas.microsoft.com/office/drawing/2014/main" id="{3D7C6FD6-5A75-4F82-B104-4283542CA0EB}"/>
+                <a16:creationId xmlns:a16="http://schemas.microsoft.com/office/drawing/2014/main" id="{A9368946-ADFA-4FF8-AA3B-8DD6167ECDFD}"/>
               </a:ext>
             </a:extLst>
           </p:cNvPr>
@@ -14674,7 +14674,7 @@
           <p:cNvPr id="24" name="">
             <a:extLst xmlns:a="http://schemas.openxmlformats.org/drawingml/2006/main">
               <a:ext uri="{FF2B5EF4-FFF2-40B4-BE49-F238E27FC236}">
-                <a16:creationId xmlns:a16="http://schemas.microsoft.com/office/drawing/2014/main" id="{C1418F6E-EB84-40DE-A780-FEE820F758AA}"/>
+                <a16:creationId xmlns:a16="http://schemas.microsoft.com/office/drawing/2014/main" id="{765D881C-4EF4-4EA7-A49F-678C2B5F588F}"/>
               </a:ext>
             </a:extLst>
           </p:cNvPr>
@@ -14731,7 +14731,7 @@
           <p:cNvPr id="25" name="">
             <a:extLst xmlns:a="http://schemas.openxmlformats.org/drawingml/2006/main">
               <a:ext uri="{FF2B5EF4-FFF2-40B4-BE49-F238E27FC236}">
-                <a16:creationId xmlns:a16="http://schemas.microsoft.com/office/drawing/2014/main" id="{39996976-C4F6-4988-AD81-629466FFC13E}"/>
+                <a16:creationId xmlns:a16="http://schemas.microsoft.com/office/drawing/2014/main" id="{84AD71A7-AA5E-4F36-8AF0-EC4F17AFCC62}"/>
               </a:ext>
             </a:extLst>
           </p:cNvPr>
@@ -14764,7 +14764,7 @@
           <p:cNvPr id="26" name="">
             <a:extLst xmlns:a="http://schemas.openxmlformats.org/drawingml/2006/main">
               <a:ext uri="{FF2B5EF4-FFF2-40B4-BE49-F238E27FC236}">
-                <a16:creationId xmlns:a16="http://schemas.microsoft.com/office/drawing/2014/main" id="{12A1E029-DEC0-4262-BD4F-3798A4EEDA17}"/>
+                <a16:creationId xmlns:a16="http://schemas.microsoft.com/office/drawing/2014/main" id="{960E5754-4512-4F7A-8425-FD24234779F2}"/>
               </a:ext>
             </a:extLst>
           </p:cNvPr>
@@ -14821,7 +14821,7 @@
           <p:cNvPr id="27" name="">
             <a:extLst xmlns:a="http://schemas.openxmlformats.org/drawingml/2006/main">
               <a:ext uri="{FF2B5EF4-FFF2-40B4-BE49-F238E27FC236}">
-                <a16:creationId xmlns:a16="http://schemas.microsoft.com/office/drawing/2014/main" id="{D2105FFE-CA5E-443E-B48E-176FD978D7FF}"/>
+                <a16:creationId xmlns:a16="http://schemas.microsoft.com/office/drawing/2014/main" id="{328CF900-DCDB-4C8D-AFC1-6917895431F6}"/>
               </a:ext>
             </a:extLst>
           </p:cNvPr>
@@ -14876,7 +14876,7 @@
     </p:spTree>
     <p:extLst>
       <p:ext uri="{BB962C8B-B14F-4D97-AF65-F5344CB8AC3E}">
-        <p14:creationId xmlns:p14="http://schemas.microsoft.com/office/powerpoint/2010/main" val="2002510308"/>
+        <p14:creationId xmlns:p14="http://schemas.microsoft.com/office/powerpoint/2010/main" val="1144632637"/>
       </p:ext>
     </p:extLst>
   </p:cSld>
@@ -14907,7 +14907,7 @@
           <p:cNvPr id="40" name="">
             <a:extLst xmlns:a="http://schemas.openxmlformats.org/drawingml/2006/main">
               <a:ext uri="{FF2B5EF4-FFF2-40B4-BE49-F238E27FC236}">
-                <a16:creationId xmlns:a16="http://schemas.microsoft.com/office/drawing/2014/main" id="{7D32B445-FE66-426C-9344-57AB938B15AD}"/>
+                <a16:creationId xmlns:a16="http://schemas.microsoft.com/office/drawing/2014/main" id="{0271B394-EF43-4D43-B312-9E8B9DFF804F}"/>
               </a:ext>
             </a:extLst>
           </p:cNvPr>
@@ -14938,7 +14938,7 @@
           <p:cNvPr id="2" name="">
             <a:extLst xmlns:a="http://schemas.openxmlformats.org/drawingml/2006/main">
               <a:ext uri="{FF2B5EF4-FFF2-40B4-BE49-F238E27FC236}">
-                <a16:creationId xmlns:a16="http://schemas.microsoft.com/office/drawing/2014/main" id="{70C9F4BA-DFA3-466D-A5AD-61C0AF665FBF}"/>
+                <a16:creationId xmlns:a16="http://schemas.microsoft.com/office/drawing/2014/main" id="{932EE8E9-7505-462D-B2B0-2CCA858743C3}"/>
               </a:ext>
             </a:extLst>
           </p:cNvPr>
@@ -14969,7 +14969,7 @@
           <p:cNvPr id="3" name="">
             <a:extLst xmlns:a="http://schemas.openxmlformats.org/drawingml/2006/main">
               <a:ext uri="{FF2B5EF4-FFF2-40B4-BE49-F238E27FC236}">
-                <a16:creationId xmlns:a16="http://schemas.microsoft.com/office/drawing/2014/main" id="{4D659EB0-1346-4201-B885-892E2056C25F}"/>
+                <a16:creationId xmlns:a16="http://schemas.microsoft.com/office/drawing/2014/main" id="{520111BF-238B-462E-B379-6BA01B7B564F}"/>
               </a:ext>
             </a:extLst>
           </p:cNvPr>
@@ -15026,7 +15026,7 @@
           <p:cNvPr id="4" name="">
             <a:extLst xmlns:a="http://schemas.openxmlformats.org/drawingml/2006/main">
               <a:ext uri="{FF2B5EF4-FFF2-40B4-BE49-F238E27FC236}">
-                <a16:creationId xmlns:a16="http://schemas.microsoft.com/office/drawing/2014/main" id="{C6D3E489-3F61-40FE-AB04-4F643F0AE78B}"/>
+                <a16:creationId xmlns:a16="http://schemas.microsoft.com/office/drawing/2014/main" id="{A2199607-4C64-4895-9A33-9342A3E4ED5F}"/>
               </a:ext>
             </a:extLst>
           </p:cNvPr>
@@ -15083,7 +15083,7 @@
           <p:cNvPr id="5" name="">
             <a:extLst xmlns:a="http://schemas.openxmlformats.org/drawingml/2006/main">
               <a:ext uri="{FF2B5EF4-FFF2-40B4-BE49-F238E27FC236}">
-                <a16:creationId xmlns:a16="http://schemas.microsoft.com/office/drawing/2014/main" id="{5423CC57-D68E-4E51-9BA9-E875EADD9B0F}"/>
+                <a16:creationId xmlns:a16="http://schemas.microsoft.com/office/drawing/2014/main" id="{EECE8848-4D0E-4418-A230-533E0BAF0BED}"/>
               </a:ext>
             </a:extLst>
           </p:cNvPr>
@@ -15116,7 +15116,7 @@
           <p:cNvPr id="6" name="">
             <a:extLst xmlns:a="http://schemas.openxmlformats.org/drawingml/2006/main">
               <a:ext uri="{FF2B5EF4-FFF2-40B4-BE49-F238E27FC236}">
-                <a16:creationId xmlns:a16="http://schemas.microsoft.com/office/drawing/2014/main" id="{91C29239-BF7D-40CB-A858-B6F63F26CF95}"/>
+                <a16:creationId xmlns:a16="http://schemas.microsoft.com/office/drawing/2014/main" id="{6626338D-3121-4AF6-81D0-69D388E39242}"/>
               </a:ext>
             </a:extLst>
           </p:cNvPr>
@@ -15151,7 +15151,7 @@
           <p:cNvPr id="7" name="">
             <a:extLst xmlns:a="http://schemas.openxmlformats.org/drawingml/2006/main">
               <a:ext uri="{FF2B5EF4-FFF2-40B4-BE49-F238E27FC236}">
-                <a16:creationId xmlns:a16="http://schemas.microsoft.com/office/drawing/2014/main" id="{AAE0D715-A926-431B-B2D8-ABEF51354EAF}"/>
+                <a16:creationId xmlns:a16="http://schemas.microsoft.com/office/drawing/2014/main" id="{8182702F-CB9D-430A-8416-2C141FA68B2B}"/>
               </a:ext>
             </a:extLst>
           </p:cNvPr>
@@ -15208,7 +15208,7 @@
           <p:cNvPr id="8" name="">
             <a:extLst xmlns:a="http://schemas.openxmlformats.org/drawingml/2006/main">
               <a:ext uri="{FF2B5EF4-FFF2-40B4-BE49-F238E27FC236}">
-                <a16:creationId xmlns:a16="http://schemas.microsoft.com/office/drawing/2014/main" id="{618C88E4-A449-404B-9D01-5602A3661C68}"/>
+                <a16:creationId xmlns:a16="http://schemas.microsoft.com/office/drawing/2014/main" id="{06698755-52EE-4D0B-8580-DFD30EB5150B}"/>
               </a:ext>
             </a:extLst>
           </p:cNvPr>
@@ -15265,7 +15265,7 @@
           <p:cNvPr id="9" name="">
             <a:extLst xmlns:a="http://schemas.openxmlformats.org/drawingml/2006/main">
               <a:ext uri="{FF2B5EF4-FFF2-40B4-BE49-F238E27FC236}">
-                <a16:creationId xmlns:a16="http://schemas.microsoft.com/office/drawing/2014/main" id="{3F3870DD-1BEB-40C7-B8D9-77DFCD9AC9BA}"/>
+                <a16:creationId xmlns:a16="http://schemas.microsoft.com/office/drawing/2014/main" id="{3C2E284F-E3E0-4D1F-B9AC-E530A6C77B79}"/>
               </a:ext>
             </a:extLst>
           </p:cNvPr>
@@ -15298,7 +15298,7 @@
           <p:cNvPr id="10" name="">
             <a:extLst xmlns:a="http://schemas.openxmlformats.org/drawingml/2006/main">
               <a:ext uri="{FF2B5EF4-FFF2-40B4-BE49-F238E27FC236}">
-                <a16:creationId xmlns:a16="http://schemas.microsoft.com/office/drawing/2014/main" id="{746DF715-DB01-4AFB-85AE-465C3482156E}"/>
+                <a16:creationId xmlns:a16="http://schemas.microsoft.com/office/drawing/2014/main" id="{C316FDD7-365A-4079-8879-1488AE9C28FE}"/>
               </a:ext>
             </a:extLst>
           </p:cNvPr>
@@ -15333,7 +15333,7 @@
           <p:cNvPr id="11" name="">
             <a:extLst xmlns:a="http://schemas.openxmlformats.org/drawingml/2006/main">
               <a:ext uri="{FF2B5EF4-FFF2-40B4-BE49-F238E27FC236}">
-                <a16:creationId xmlns:a16="http://schemas.microsoft.com/office/drawing/2014/main" id="{09F82B32-99A4-4A7B-9370-49607779C3D1}"/>
+                <a16:creationId xmlns:a16="http://schemas.microsoft.com/office/drawing/2014/main" id="{43CEE906-7415-41EA-80D3-35103CF4E581}"/>
               </a:ext>
             </a:extLst>
           </p:cNvPr>
@@ -15390,7 +15390,7 @@
           <p:cNvPr id="12" name="">
             <a:extLst xmlns:a="http://schemas.openxmlformats.org/drawingml/2006/main">
               <a:ext uri="{FF2B5EF4-FFF2-40B4-BE49-F238E27FC236}">
-                <a16:creationId xmlns:a16="http://schemas.microsoft.com/office/drawing/2014/main" id="{14031167-768F-4B23-876F-0817EE323BE7}"/>
+                <a16:creationId xmlns:a16="http://schemas.microsoft.com/office/drawing/2014/main" id="{09E1CAC7-718F-49CF-BB9E-D99F0B9EF3B7}"/>
               </a:ext>
             </a:extLst>
           </p:cNvPr>
@@ -15447,7 +15447,7 @@
           <p:cNvPr id="13" name="">
             <a:extLst xmlns:a="http://schemas.openxmlformats.org/drawingml/2006/main">
               <a:ext uri="{FF2B5EF4-FFF2-40B4-BE49-F238E27FC236}">
-                <a16:creationId xmlns:a16="http://schemas.microsoft.com/office/drawing/2014/main" id="{48C77F5C-B973-4AB2-BF82-BF5734ED7FAE}"/>
+                <a16:creationId xmlns:a16="http://schemas.microsoft.com/office/drawing/2014/main" id="{05C37A1F-3115-4D11-8B3D-E15BE1269684}"/>
               </a:ext>
             </a:extLst>
           </p:cNvPr>
@@ -15480,7 +15480,7 @@
           <p:cNvPr id="14" name="">
             <a:extLst xmlns:a="http://schemas.openxmlformats.org/drawingml/2006/main">
               <a:ext uri="{FF2B5EF4-FFF2-40B4-BE49-F238E27FC236}">
-                <a16:creationId xmlns:a16="http://schemas.microsoft.com/office/drawing/2014/main" id="{78023793-C721-478A-87A3-958D2DC5479F}"/>
+                <a16:creationId xmlns:a16="http://schemas.microsoft.com/office/drawing/2014/main" id="{1C5116AA-B978-4E8E-BEBD-A573BA885E87}"/>
               </a:ext>
             </a:extLst>
           </p:cNvPr>
@@ -15515,7 +15515,7 @@
           <p:cNvPr id="15" name="">
             <a:extLst xmlns:a="http://schemas.openxmlformats.org/drawingml/2006/main">
               <a:ext uri="{FF2B5EF4-FFF2-40B4-BE49-F238E27FC236}">
-                <a16:creationId xmlns:a16="http://schemas.microsoft.com/office/drawing/2014/main" id="{3D143A43-61A4-4847-92F9-A237509EBC9A}"/>
+                <a16:creationId xmlns:a16="http://schemas.microsoft.com/office/drawing/2014/main" id="{4CE0A47C-AA9B-4B95-93CA-79B5BEC2EA30}"/>
               </a:ext>
             </a:extLst>
           </p:cNvPr>
@@ -15572,7 +15572,7 @@
           <p:cNvPr id="16" name="">
             <a:extLst xmlns:a="http://schemas.openxmlformats.org/drawingml/2006/main">
               <a:ext uri="{FF2B5EF4-FFF2-40B4-BE49-F238E27FC236}">
-                <a16:creationId xmlns:a16="http://schemas.microsoft.com/office/drawing/2014/main" id="{34E78AE3-4FF3-425A-A427-0A66E13AABB0}"/>
+                <a16:creationId xmlns:a16="http://schemas.microsoft.com/office/drawing/2014/main" id="{756963D0-9897-4263-9701-5B723042608F}"/>
               </a:ext>
             </a:extLst>
           </p:cNvPr>
@@ -15629,7 +15629,7 @@
           <p:cNvPr id="17" name="">
             <a:extLst xmlns:a="http://schemas.openxmlformats.org/drawingml/2006/main">
               <a:ext uri="{FF2B5EF4-FFF2-40B4-BE49-F238E27FC236}">
-                <a16:creationId xmlns:a16="http://schemas.microsoft.com/office/drawing/2014/main" id="{72F53C42-0530-45F9-9906-584E3CFE7383}"/>
+                <a16:creationId xmlns:a16="http://schemas.microsoft.com/office/drawing/2014/main" id="{26E1FB1A-B39C-47B3-895B-0C0D14F69D64}"/>
               </a:ext>
             </a:extLst>
           </p:cNvPr>
@@ -15662,7 +15662,7 @@
           <p:cNvPr id="18" name="">
             <a:extLst xmlns:a="http://schemas.openxmlformats.org/drawingml/2006/main">
               <a:ext uri="{FF2B5EF4-FFF2-40B4-BE49-F238E27FC236}">
-                <a16:creationId xmlns:a16="http://schemas.microsoft.com/office/drawing/2014/main" id="{6CBF8DA1-13D4-4A1E-B1A1-98C00BA7422D}"/>
+                <a16:creationId xmlns:a16="http://schemas.microsoft.com/office/drawing/2014/main" id="{31C901F7-7EAB-43DA-9AC6-6D024991E11F}"/>
               </a:ext>
             </a:extLst>
           </p:cNvPr>
@@ -15697,7 +15697,7 @@
           <p:cNvPr id="19" name="">
             <a:extLst xmlns:a="http://schemas.openxmlformats.org/drawingml/2006/main">
               <a:ext uri="{FF2B5EF4-FFF2-40B4-BE49-F238E27FC236}">
-                <a16:creationId xmlns:a16="http://schemas.microsoft.com/office/drawing/2014/main" id="{66496B3D-5F2D-4509-B299-1DDC88B3D11E}"/>
+                <a16:creationId xmlns:a16="http://schemas.microsoft.com/office/drawing/2014/main" id="{FADB6FE0-8FCF-4101-A57F-3AC15A223CC1}"/>
               </a:ext>
             </a:extLst>
           </p:cNvPr>
@@ -15754,7 +15754,7 @@
           <p:cNvPr id="20" name="">
             <a:extLst xmlns:a="http://schemas.openxmlformats.org/drawingml/2006/main">
               <a:ext uri="{FF2B5EF4-FFF2-40B4-BE49-F238E27FC236}">
-                <a16:creationId xmlns:a16="http://schemas.microsoft.com/office/drawing/2014/main" id="{55DDD581-6BDE-4A6A-B312-464EF46ABC6E}"/>
+                <a16:creationId xmlns:a16="http://schemas.microsoft.com/office/drawing/2014/main" id="{8729338F-411B-43ED-99E8-6D6ED70E35AF}"/>
               </a:ext>
             </a:extLst>
           </p:cNvPr>
@@ -15811,7 +15811,7 @@
           <p:cNvPr id="21" name="">
             <a:extLst xmlns:a="http://schemas.openxmlformats.org/drawingml/2006/main">
               <a:ext uri="{FF2B5EF4-FFF2-40B4-BE49-F238E27FC236}">
-                <a16:creationId xmlns:a16="http://schemas.microsoft.com/office/drawing/2014/main" id="{4EBC5723-20AE-4B78-B753-CDB9ADA6A172}"/>
+                <a16:creationId xmlns:a16="http://schemas.microsoft.com/office/drawing/2014/main" id="{2A377B21-3BB9-43B7-AD24-756E7BFD188E}"/>
               </a:ext>
             </a:extLst>
           </p:cNvPr>
@@ -15844,7 +15844,7 @@
           <p:cNvPr id="22" name="">
             <a:extLst xmlns:a="http://schemas.openxmlformats.org/drawingml/2006/main">
               <a:ext uri="{FF2B5EF4-FFF2-40B4-BE49-F238E27FC236}">
-                <a16:creationId xmlns:a16="http://schemas.microsoft.com/office/drawing/2014/main" id="{10183018-9238-4A5E-90DE-3BABD472E500}"/>
+                <a16:creationId xmlns:a16="http://schemas.microsoft.com/office/drawing/2014/main" id="{9058FB7B-E230-4FEC-A719-902EE8187F72}"/>
               </a:ext>
             </a:extLst>
           </p:cNvPr>
@@ -15879,7 +15879,7 @@
           <p:cNvPr id="23" name="">
             <a:extLst xmlns:a="http://schemas.openxmlformats.org/drawingml/2006/main">
               <a:ext uri="{FF2B5EF4-FFF2-40B4-BE49-F238E27FC236}">
-                <a16:creationId xmlns:a16="http://schemas.microsoft.com/office/drawing/2014/main" id="{FC4B9AC6-79AA-4BAD-9134-1414A155B543}"/>
+                <a16:creationId xmlns:a16="http://schemas.microsoft.com/office/drawing/2014/main" id="{8BDC2245-1895-4913-AEF3-2346FDB7CD0C}"/>
               </a:ext>
             </a:extLst>
           </p:cNvPr>
@@ -15936,7 +15936,7 @@
           <p:cNvPr id="24" name="">
             <a:extLst xmlns:a="http://schemas.openxmlformats.org/drawingml/2006/main">
               <a:ext uri="{FF2B5EF4-FFF2-40B4-BE49-F238E27FC236}">
-                <a16:creationId xmlns:a16="http://schemas.microsoft.com/office/drawing/2014/main" id="{4772DBBA-E2B1-4289-824C-3DFCD8D2DF65}"/>
+                <a16:creationId xmlns:a16="http://schemas.microsoft.com/office/drawing/2014/main" id="{8C0EDA06-DCEE-4D31-8068-2EF8631084F2}"/>
               </a:ext>
             </a:extLst>
           </p:cNvPr>
@@ -15993,7 +15993,7 @@
           <p:cNvPr id="25" name="">
             <a:extLst xmlns:a="http://schemas.openxmlformats.org/drawingml/2006/main">
               <a:ext uri="{FF2B5EF4-FFF2-40B4-BE49-F238E27FC236}">
-                <a16:creationId xmlns:a16="http://schemas.microsoft.com/office/drawing/2014/main" id="{41E1566E-197B-40F1-8BA6-747554B66D04}"/>
+                <a16:creationId xmlns:a16="http://schemas.microsoft.com/office/drawing/2014/main" id="{F4E95CBE-8381-4A2F-B50A-7E4C1E22743F}"/>
               </a:ext>
             </a:extLst>
           </p:cNvPr>
@@ -16024,7 +16024,7 @@
           <p:cNvPr id="26" name="">
             <a:extLst xmlns:a="http://schemas.openxmlformats.org/drawingml/2006/main">
               <a:ext uri="{FF2B5EF4-FFF2-40B4-BE49-F238E27FC236}">
-                <a16:creationId xmlns:a16="http://schemas.microsoft.com/office/drawing/2014/main" id="{31B8D0F9-25CD-464E-9F59-BCE850F15FA5}"/>
+                <a16:creationId xmlns:a16="http://schemas.microsoft.com/office/drawing/2014/main" id="{3B249784-BC42-4B53-86C4-5B89AD20F48F}"/>
               </a:ext>
             </a:extLst>
           </p:cNvPr>
@@ -16055,7 +16055,7 @@
           <p:cNvPr id="27" name="">
             <a:extLst xmlns:a="http://schemas.openxmlformats.org/drawingml/2006/main">
               <a:ext uri="{FF2B5EF4-FFF2-40B4-BE49-F238E27FC236}">
-                <a16:creationId xmlns:a16="http://schemas.microsoft.com/office/drawing/2014/main" id="{B5CCA5CB-9021-4607-B3C9-6F3D3F1061DE}"/>
+                <a16:creationId xmlns:a16="http://schemas.microsoft.com/office/drawing/2014/main" id="{8E7B94A0-729D-4FCE-ABC6-3B5D61A6BCAD}"/>
               </a:ext>
             </a:extLst>
           </p:cNvPr>
@@ -16087,7 +16087,7 @@
           <p:cNvPr id="28" name="">
             <a:extLst xmlns:a="http://schemas.openxmlformats.org/drawingml/2006/main">
               <a:ext uri="{FF2B5EF4-FFF2-40B4-BE49-F238E27FC236}">
-                <a16:creationId xmlns:a16="http://schemas.microsoft.com/office/drawing/2014/main" id="{3BBF118C-3F9D-4246-ADBE-897E6995258D}"/>
+                <a16:creationId xmlns:a16="http://schemas.microsoft.com/office/drawing/2014/main" id="{21DFF415-7AC6-4417-A04E-6B635BA25257}"/>
               </a:ext>
             </a:extLst>
           </p:cNvPr>
@@ -16118,7 +16118,7 @@
           <p:cNvPr id="29" name="">
             <a:extLst xmlns:a="http://schemas.openxmlformats.org/drawingml/2006/main">
               <a:ext uri="{FF2B5EF4-FFF2-40B4-BE49-F238E27FC236}">
-                <a16:creationId xmlns:a16="http://schemas.microsoft.com/office/drawing/2014/main" id="{BBEACBF5-A25B-4339-8CDA-E241B634D076}"/>
+                <a16:creationId xmlns:a16="http://schemas.microsoft.com/office/drawing/2014/main" id="{C8332124-4A7E-4305-BBBC-4B11A3D3D573}"/>
               </a:ext>
             </a:extLst>
           </p:cNvPr>
@@ -16149,7 +16149,7 @@
           <p:cNvPr id="30" name="">
             <a:extLst xmlns:a="http://schemas.openxmlformats.org/drawingml/2006/main">
               <a:ext uri="{FF2B5EF4-FFF2-40B4-BE49-F238E27FC236}">
-                <a16:creationId xmlns:a16="http://schemas.microsoft.com/office/drawing/2014/main" id="{502AF0F3-5ADB-4F0F-8508-F312B545CAFD}"/>
+                <a16:creationId xmlns:a16="http://schemas.microsoft.com/office/drawing/2014/main" id="{3781A958-15DB-474B-90B2-00E801F83E33}"/>
               </a:ext>
             </a:extLst>
           </p:cNvPr>
@@ -16181,7 +16181,7 @@
           <p:cNvPr id="31" name="">
             <a:extLst xmlns:a="http://schemas.openxmlformats.org/drawingml/2006/main">
               <a:ext uri="{FF2B5EF4-FFF2-40B4-BE49-F238E27FC236}">
-                <a16:creationId xmlns:a16="http://schemas.microsoft.com/office/drawing/2014/main" id="{2D0E962E-BC38-451A-8714-093D3DA47970}"/>
+                <a16:creationId xmlns:a16="http://schemas.microsoft.com/office/drawing/2014/main" id="{EC29B53D-F82B-4614-8DA1-86EFE57A42C8}"/>
               </a:ext>
             </a:extLst>
           </p:cNvPr>
@@ -16212,7 +16212,7 @@
           <p:cNvPr id="32" name="">
             <a:extLst xmlns:a="http://schemas.openxmlformats.org/drawingml/2006/main">
               <a:ext uri="{FF2B5EF4-FFF2-40B4-BE49-F238E27FC236}">
-                <a16:creationId xmlns:a16="http://schemas.microsoft.com/office/drawing/2014/main" id="{6B3381AD-087C-4905-A6E1-C88E875CE068}"/>
+                <a16:creationId xmlns:a16="http://schemas.microsoft.com/office/drawing/2014/main" id="{C87AAAF4-7A20-4950-9D33-91DF12E34C7F}"/>
               </a:ext>
             </a:extLst>
           </p:cNvPr>
@@ -16243,7 +16243,7 @@
           <p:cNvPr id="33" name="">
             <a:extLst xmlns:a="http://schemas.openxmlformats.org/drawingml/2006/main">
               <a:ext uri="{FF2B5EF4-FFF2-40B4-BE49-F238E27FC236}">
-                <a16:creationId xmlns:a16="http://schemas.microsoft.com/office/drawing/2014/main" id="{99545B5A-3D81-4859-A160-5373134AE914}"/>
+                <a16:creationId xmlns:a16="http://schemas.microsoft.com/office/drawing/2014/main" id="{7B9E8316-AB0E-40DB-A327-4C4DE2F0AA01}"/>
               </a:ext>
             </a:extLst>
           </p:cNvPr>
@@ -16275,7 +16275,7 @@
           <p:cNvPr id="34" name="">
             <a:extLst xmlns:a="http://schemas.openxmlformats.org/drawingml/2006/main">
               <a:ext uri="{FF2B5EF4-FFF2-40B4-BE49-F238E27FC236}">
-                <a16:creationId xmlns:a16="http://schemas.microsoft.com/office/drawing/2014/main" id="{2D01C920-F086-4C84-BD7A-D34F132D6122}"/>
+                <a16:creationId xmlns:a16="http://schemas.microsoft.com/office/drawing/2014/main" id="{499C5800-EA03-4172-B917-A74B7766BA99}"/>
               </a:ext>
             </a:extLst>
           </p:cNvPr>
@@ -16306,7 +16306,7 @@
           <p:cNvPr id="35" name="">
             <a:extLst xmlns:a="http://schemas.openxmlformats.org/drawingml/2006/main">
               <a:ext uri="{FF2B5EF4-FFF2-40B4-BE49-F238E27FC236}">
-                <a16:creationId xmlns:a16="http://schemas.microsoft.com/office/drawing/2014/main" id="{0298EC5C-6B62-4C06-A0E5-5649CA862927}"/>
+                <a16:creationId xmlns:a16="http://schemas.microsoft.com/office/drawing/2014/main" id="{1262CBDA-26CC-4AFB-9AED-0891AE10647F}"/>
               </a:ext>
             </a:extLst>
           </p:cNvPr>
@@ -16337,7 +16337,7 @@
           <p:cNvPr id="36" name="">
             <a:extLst xmlns:a="http://schemas.openxmlformats.org/drawingml/2006/main">
               <a:ext uri="{FF2B5EF4-FFF2-40B4-BE49-F238E27FC236}">
-                <a16:creationId xmlns:a16="http://schemas.microsoft.com/office/drawing/2014/main" id="{A572BDCE-E489-4535-93EF-B7A65646E5CC}"/>
+                <a16:creationId xmlns:a16="http://schemas.microsoft.com/office/drawing/2014/main" id="{54667B1C-C337-4AEC-94B7-235CD627A61A}"/>
               </a:ext>
             </a:extLst>
           </p:cNvPr>
@@ -16369,7 +16369,7 @@
           <p:cNvPr id="37" name="">
             <a:extLst xmlns:a="http://schemas.openxmlformats.org/drawingml/2006/main">
               <a:ext uri="{FF2B5EF4-FFF2-40B4-BE49-F238E27FC236}">
-                <a16:creationId xmlns:a16="http://schemas.microsoft.com/office/drawing/2014/main" id="{29C87745-EE39-4A44-873E-8E04E2A5D000}"/>
+                <a16:creationId xmlns:a16="http://schemas.microsoft.com/office/drawing/2014/main" id="{79B9AF09-7AC8-4E9B-971D-4261DF08059E}"/>
               </a:ext>
             </a:extLst>
           </p:cNvPr>
@@ -16426,7 +16426,7 @@
           <p:cNvPr id="38" name="">
             <a:extLst xmlns:a="http://schemas.openxmlformats.org/drawingml/2006/main">
               <a:ext uri="{FF2B5EF4-FFF2-40B4-BE49-F238E27FC236}">
-                <a16:creationId xmlns:a16="http://schemas.microsoft.com/office/drawing/2014/main" id="{EC839839-6EEE-4517-90D3-717A978EAE0B}"/>
+                <a16:creationId xmlns:a16="http://schemas.microsoft.com/office/drawing/2014/main" id="{D383C215-C67D-4E2D-9313-F69CEBD44A2A}"/>
               </a:ext>
             </a:extLst>
           </p:cNvPr>
@@ -16483,7 +16483,7 @@
           <p:cNvPr id="39" name="">
             <a:extLst xmlns:a="http://schemas.openxmlformats.org/drawingml/2006/main">
               <a:ext uri="{FF2B5EF4-FFF2-40B4-BE49-F238E27FC236}">
-                <a16:creationId xmlns:a16="http://schemas.microsoft.com/office/drawing/2014/main" id="{389F7AE2-609A-441A-BA96-072C98361ED9}"/>
+                <a16:creationId xmlns:a16="http://schemas.microsoft.com/office/drawing/2014/main" id="{F653A3E3-BE40-4A25-902D-0AD4C5053C63}"/>
               </a:ext>
             </a:extLst>
           </p:cNvPr>
@@ -16538,7 +16538,7 @@
     </p:spTree>
     <p:extLst>
       <p:ext uri="{BB962C8B-B14F-4D97-AF65-F5344CB8AC3E}">
-        <p14:creationId xmlns:p14="http://schemas.microsoft.com/office/powerpoint/2010/main" val="999679418"/>
+        <p14:creationId xmlns:p14="http://schemas.microsoft.com/office/powerpoint/2010/main" val="1115013038"/>
       </p:ext>
     </p:extLst>
   </p:cSld>
@@ -16566,10 +16566,10 @@
       </p:grpSpPr>
       <p:sp>
         <p:nvSpPr>
-          <p:cNvPr id="27" name="">
-            <a:extLst xmlns:a="http://schemas.openxmlformats.org/drawingml/2006/main">
-              <a:ext uri="{FF2B5EF4-FFF2-40B4-BE49-F238E27FC236}">
-                <a16:creationId xmlns:a16="http://schemas.microsoft.com/office/drawing/2014/main" id="{9FE88D55-AA03-49E5-B56A-EA43DFEBBE61}"/>
+          <p:cNvPr id="28" name="">
+            <a:extLst xmlns:a="http://schemas.openxmlformats.org/drawingml/2006/main">
+              <a:ext uri="{FF2B5EF4-FFF2-40B4-BE49-F238E27FC236}">
+                <a16:creationId xmlns:a16="http://schemas.microsoft.com/office/drawing/2014/main" id="{45C2636E-99EB-409B-B58C-E6348463312D}"/>
               </a:ext>
             </a:extLst>
           </p:cNvPr>
@@ -16600,7 +16600,7 @@
           <p:cNvPr id="2" name="">
             <a:extLst xmlns:a="http://schemas.openxmlformats.org/drawingml/2006/main">
               <a:ext uri="{FF2B5EF4-FFF2-40B4-BE49-F238E27FC236}">
-                <a16:creationId xmlns:a16="http://schemas.microsoft.com/office/drawing/2014/main" id="{22FD1D74-1D4D-4826-9082-EA3B8B0495F0}"/>
+                <a16:creationId xmlns:a16="http://schemas.microsoft.com/office/drawing/2014/main" id="{F81A285D-F0E6-4A99-AB51-9AA6B42C8B23}"/>
               </a:ext>
             </a:extLst>
           </p:cNvPr>
@@ -16631,7 +16631,7 @@
           <p:cNvPr id="3" name="">
             <a:extLst xmlns:a="http://schemas.openxmlformats.org/drawingml/2006/main">
               <a:ext uri="{FF2B5EF4-FFF2-40B4-BE49-F238E27FC236}">
-                <a16:creationId xmlns:a16="http://schemas.microsoft.com/office/drawing/2014/main" id="{FAB10A64-6DD7-4E30-BD0A-F598EC8A6514}"/>
+                <a16:creationId xmlns:a16="http://schemas.microsoft.com/office/drawing/2014/main" id="{07006C98-1B57-4AF6-89FC-ACB784B55E61}"/>
               </a:ext>
             </a:extLst>
           </p:cNvPr>
@@ -16688,7 +16688,7 @@
           <p:cNvPr id="4" name="">
             <a:extLst xmlns:a="http://schemas.openxmlformats.org/drawingml/2006/main">
               <a:ext uri="{FF2B5EF4-FFF2-40B4-BE49-F238E27FC236}">
-                <a16:creationId xmlns:a16="http://schemas.microsoft.com/office/drawing/2014/main" id="{50A096BC-5346-47B0-BB5B-162E76E37B72}"/>
+                <a16:creationId xmlns:a16="http://schemas.microsoft.com/office/drawing/2014/main" id="{DF28C7DA-B4C6-460A-B15F-DB8593879BB6}"/>
               </a:ext>
             </a:extLst>
           </p:cNvPr>
@@ -16745,7 +16745,7 @@
           <p:cNvPr id="5" name="">
             <a:extLst xmlns:a="http://schemas.openxmlformats.org/drawingml/2006/main">
               <a:ext uri="{FF2B5EF4-FFF2-40B4-BE49-F238E27FC236}">
-                <a16:creationId xmlns:a16="http://schemas.microsoft.com/office/drawing/2014/main" id="{8E1163AF-29D5-4514-98D1-560B1E136C76}"/>
+                <a16:creationId xmlns:a16="http://schemas.microsoft.com/office/drawing/2014/main" id="{866B5E26-7596-4853-833A-D3DE930C994B}"/>
               </a:ext>
             </a:extLst>
           </p:cNvPr>
@@ -16802,7 +16802,7 @@
           <p:cNvPr id="6" name="">
             <a:extLst xmlns:a="http://schemas.openxmlformats.org/drawingml/2006/main">
               <a:ext uri="{FF2B5EF4-FFF2-40B4-BE49-F238E27FC236}">
-                <a16:creationId xmlns:a16="http://schemas.microsoft.com/office/drawing/2014/main" id="{714DD259-EA74-48CF-8249-220F78508CFA}"/>
+                <a16:creationId xmlns:a16="http://schemas.microsoft.com/office/drawing/2014/main" id="{135107CD-B327-45DF-A3EB-B1F046556D20}"/>
               </a:ext>
             </a:extLst>
           </p:cNvPr>
@@ -16859,7 +16859,7 @@
           <p:cNvPr id="7" name="">
             <a:extLst xmlns:a="http://schemas.openxmlformats.org/drawingml/2006/main">
               <a:ext uri="{FF2B5EF4-FFF2-40B4-BE49-F238E27FC236}">
-                <a16:creationId xmlns:a16="http://schemas.microsoft.com/office/drawing/2014/main" id="{21629DAF-318E-4A23-AA26-117185909435}"/>
+                <a16:creationId xmlns:a16="http://schemas.microsoft.com/office/drawing/2014/main" id="{E96D7EC8-121B-4E64-924A-686C389AE6B5}"/>
               </a:ext>
             </a:extLst>
           </p:cNvPr>
@@ -16890,7 +16890,7 @@
           <p:cNvPr id="8" name="">
             <a:extLst xmlns:a="http://schemas.openxmlformats.org/drawingml/2006/main">
               <a:ext uri="{FF2B5EF4-FFF2-40B4-BE49-F238E27FC236}">
-                <a16:creationId xmlns:a16="http://schemas.microsoft.com/office/drawing/2014/main" id="{362733A3-6014-437A-836A-CC5FD28E665E}"/>
+                <a16:creationId xmlns:a16="http://schemas.microsoft.com/office/drawing/2014/main" id="{A4ED23A2-549F-4937-8AE3-5604DFC64B68}"/>
               </a:ext>
             </a:extLst>
           </p:cNvPr>
@@ -16947,7 +16947,7 @@
           <p:cNvPr id="9" name="">
             <a:extLst xmlns:a="http://schemas.openxmlformats.org/drawingml/2006/main">
               <a:ext uri="{FF2B5EF4-FFF2-40B4-BE49-F238E27FC236}">
-                <a16:creationId xmlns:a16="http://schemas.microsoft.com/office/drawing/2014/main" id="{E82BBC2E-BF32-4BB9-9A2D-DBFEDA9ACEBF}"/>
+                <a16:creationId xmlns:a16="http://schemas.microsoft.com/office/drawing/2014/main" id="{28E246F3-F31F-4FCF-8BD4-605D5292E9EF}"/>
               </a:ext>
             </a:extLst>
           </p:cNvPr>
@@ -17004,7 +17004,7 @@
           <p:cNvPr id="10" name="">
             <a:extLst xmlns:a="http://schemas.openxmlformats.org/drawingml/2006/main">
               <a:ext uri="{FF2B5EF4-FFF2-40B4-BE49-F238E27FC236}">
-                <a16:creationId xmlns:a16="http://schemas.microsoft.com/office/drawing/2014/main" id="{7F20D503-DE4D-4EF7-8E4F-292EA0BD8C95}"/>
+                <a16:creationId xmlns:a16="http://schemas.microsoft.com/office/drawing/2014/main" id="{9885B5A0-07A0-46B7-A8BB-DFB719E86D52}"/>
               </a:ext>
             </a:extLst>
           </p:cNvPr>
@@ -17035,7 +17035,7 @@
           <p:cNvPr id="11" name="">
             <a:extLst xmlns:a="http://schemas.openxmlformats.org/drawingml/2006/main">
               <a:ext uri="{FF2B5EF4-FFF2-40B4-BE49-F238E27FC236}">
-                <a16:creationId xmlns:a16="http://schemas.microsoft.com/office/drawing/2014/main" id="{A61D305D-8FBC-4EFE-8BB5-94C7E8A2317A}"/>
+                <a16:creationId xmlns:a16="http://schemas.microsoft.com/office/drawing/2014/main" id="{E1B57917-4AA4-4551-B804-845DA041AD54}"/>
               </a:ext>
             </a:extLst>
           </p:cNvPr>
@@ -17092,7 +17092,7 @@
           <p:cNvPr id="12" name="">
             <a:extLst xmlns:a="http://schemas.openxmlformats.org/drawingml/2006/main">
               <a:ext uri="{FF2B5EF4-FFF2-40B4-BE49-F238E27FC236}">
-                <a16:creationId xmlns:a16="http://schemas.microsoft.com/office/drawing/2014/main" id="{3FA6C297-E3FA-4B0B-81D0-2CBEF07689D3}"/>
+                <a16:creationId xmlns:a16="http://schemas.microsoft.com/office/drawing/2014/main" id="{129B286D-B8AD-4F2B-B25E-09F5508744BE}"/>
               </a:ext>
             </a:extLst>
           </p:cNvPr>
@@ -17149,7 +17149,7 @@
           <p:cNvPr id="13" name="">
             <a:extLst xmlns:a="http://schemas.openxmlformats.org/drawingml/2006/main">
               <a:ext uri="{FF2B5EF4-FFF2-40B4-BE49-F238E27FC236}">
-                <a16:creationId xmlns:a16="http://schemas.microsoft.com/office/drawing/2014/main" id="{D4C9FA6B-31C2-41D8-ADF3-1ACC7233E3CD}"/>
+                <a16:creationId xmlns:a16="http://schemas.microsoft.com/office/drawing/2014/main" id="{47595A1E-BE4E-4DBD-A06F-A9BA58B9AD21}"/>
               </a:ext>
             </a:extLst>
           </p:cNvPr>
@@ -17180,7 +17180,7 @@
           <p:cNvPr id="14" name="">
             <a:extLst xmlns:a="http://schemas.openxmlformats.org/drawingml/2006/main">
               <a:ext uri="{FF2B5EF4-FFF2-40B4-BE49-F238E27FC236}">
-                <a16:creationId xmlns:a16="http://schemas.microsoft.com/office/drawing/2014/main" id="{35B0AABE-FBCE-4325-AC48-804C353D9CDD}"/>
+                <a16:creationId xmlns:a16="http://schemas.microsoft.com/office/drawing/2014/main" id="{DD96F49A-5281-4EA1-9665-C412694A67F4}"/>
               </a:ext>
             </a:extLst>
           </p:cNvPr>
@@ -17237,7 +17237,7 @@
           <p:cNvPr id="15" name="">
             <a:extLst xmlns:a="http://schemas.openxmlformats.org/drawingml/2006/main">
               <a:ext uri="{FF2B5EF4-FFF2-40B4-BE49-F238E27FC236}">
-                <a16:creationId xmlns:a16="http://schemas.microsoft.com/office/drawing/2014/main" id="{8C59F4D2-F485-44F1-A350-CA651912A07C}"/>
+                <a16:creationId xmlns:a16="http://schemas.microsoft.com/office/drawing/2014/main" id="{B47F7F42-774C-46AD-8E02-BA3F462BD7B7}"/>
               </a:ext>
             </a:extLst>
           </p:cNvPr>
@@ -17294,7 +17294,7 @@
           <p:cNvPr id="16" name="">
             <a:extLst xmlns:a="http://schemas.openxmlformats.org/drawingml/2006/main">
               <a:ext uri="{FF2B5EF4-FFF2-40B4-BE49-F238E27FC236}">
-                <a16:creationId xmlns:a16="http://schemas.microsoft.com/office/drawing/2014/main" id="{7F17B328-1355-42EF-9EC4-94148B27DBB8}"/>
+                <a16:creationId xmlns:a16="http://schemas.microsoft.com/office/drawing/2014/main" id="{9A85507C-BE42-4D8F-A0DB-21D994858234}"/>
               </a:ext>
             </a:extLst>
           </p:cNvPr>
@@ -17325,7 +17325,7 @@
           <p:cNvPr id="17" name="">
             <a:extLst xmlns:a="http://schemas.openxmlformats.org/drawingml/2006/main">
               <a:ext uri="{FF2B5EF4-FFF2-40B4-BE49-F238E27FC236}">
-                <a16:creationId xmlns:a16="http://schemas.microsoft.com/office/drawing/2014/main" id="{A0A177ED-2DB8-4888-9204-8E565BF8D533}"/>
+                <a16:creationId xmlns:a16="http://schemas.microsoft.com/office/drawing/2014/main" id="{94D479C1-68E1-48BE-90A5-5302A9B0461D}"/>
               </a:ext>
             </a:extLst>
           </p:cNvPr>
@@ -17382,7 +17382,7 @@
           <p:cNvPr id="18" name="">
             <a:extLst xmlns:a="http://schemas.openxmlformats.org/drawingml/2006/main">
               <a:ext uri="{FF2B5EF4-FFF2-40B4-BE49-F238E27FC236}">
-                <a16:creationId xmlns:a16="http://schemas.microsoft.com/office/drawing/2014/main" id="{0959DC9C-F8B6-4D56-891A-43E54F553B59}"/>
+                <a16:creationId xmlns:a16="http://schemas.microsoft.com/office/drawing/2014/main" id="{315A7A30-50B1-4635-950D-A83679FF0BE4}"/>
               </a:ext>
             </a:extLst>
           </p:cNvPr>
@@ -17439,7 +17439,7 @@
           <p:cNvPr id="19" name="">
             <a:extLst xmlns:a="http://schemas.openxmlformats.org/drawingml/2006/main">
               <a:ext uri="{FF2B5EF4-FFF2-40B4-BE49-F238E27FC236}">
-                <a16:creationId xmlns:a16="http://schemas.microsoft.com/office/drawing/2014/main" id="{86C441EC-B50F-4D19-9C51-A9E0B92BE6E3}"/>
+                <a16:creationId xmlns:a16="http://schemas.microsoft.com/office/drawing/2014/main" id="{5472CFBD-BC41-498E-B8BC-62F67BEEDBA8}"/>
               </a:ext>
             </a:extLst>
           </p:cNvPr>
@@ -17470,19 +17470,19 @@
           <p:cNvPr id="20" name="">
             <a:extLst xmlns:a="http://schemas.openxmlformats.org/drawingml/2006/main">
               <a:ext uri="{FF2B5EF4-FFF2-40B4-BE49-F238E27FC236}">
-                <a16:creationId xmlns:a16="http://schemas.microsoft.com/office/drawing/2014/main" id="{A36FFFC3-6036-4CD0-9E09-7C0F98D0EEE5}"/>
-              </a:ext>
-            </a:extLst>
-          </p:cNvPr>
-          <p:cNvSpPr>
-            <a:spLocks xmlns:a="http://schemas.openxmlformats.org/drawingml/2006/main" noGrp="1"/>
-          </p:cNvSpPr>
-          <p:nvPr/>
-        </p:nvSpPr>
-        <p:spPr>
-          <a:xfrm xmlns:a="http://schemas.openxmlformats.org/drawingml/2006/main">
-            <a:off x="9115425" y="2266950"/>
-            <a:ext cx="2095500" cy="2095500"/>
+                <a16:creationId xmlns:a16="http://schemas.microsoft.com/office/drawing/2014/main" id="{79ADFBBC-99F6-434D-99D3-356AD3D303E7}"/>
+              </a:ext>
+            </a:extLst>
+          </p:cNvPr>
+          <p:cNvSpPr>
+            <a:spLocks xmlns:a="http://schemas.openxmlformats.org/drawingml/2006/main" noGrp="1"/>
+          </p:cNvSpPr>
+          <p:nvPr/>
+        </p:nvSpPr>
+        <p:spPr>
+          <a:xfrm xmlns:a="http://schemas.openxmlformats.org/drawingml/2006/main">
+            <a:off x="8496300" y="2266950"/>
+            <a:ext cx="2952750" cy="2095500"/>
           </a:xfrm>
           <a:prstGeom xmlns:a="http://schemas.openxmlformats.org/drawingml/2006/main" prst="roundRect">
             <a:avLst>
@@ -17503,19 +17503,19 @@
           <p:cNvPr id="21" name="">
             <a:extLst xmlns:a="http://schemas.openxmlformats.org/drawingml/2006/main">
               <a:ext uri="{FF2B5EF4-FFF2-40B4-BE49-F238E27FC236}">
-                <a16:creationId xmlns:a16="http://schemas.microsoft.com/office/drawing/2014/main" id="{B21AD054-0F9F-4AC5-9E55-C9041A0B6EB3}"/>
-              </a:ext>
-            </a:extLst>
-          </p:cNvPr>
-          <p:cNvSpPr>
-            <a:spLocks xmlns:a="http://schemas.openxmlformats.org/drawingml/2006/main" noGrp="1"/>
-          </p:cNvSpPr>
-          <p:nvPr/>
-        </p:nvSpPr>
-        <p:spPr>
-          <a:xfrm xmlns:a="http://schemas.openxmlformats.org/drawingml/2006/main">
-            <a:off x="9048750" y="2190750"/>
-            <a:ext cx="2095500" cy="2095500"/>
+                <a16:creationId xmlns:a16="http://schemas.microsoft.com/office/drawing/2014/main" id="{B24AD9DC-E575-4979-ADB2-FD00E8BF81EE}"/>
+              </a:ext>
+            </a:extLst>
+          </p:cNvPr>
+          <p:cNvSpPr>
+            <a:spLocks xmlns:a="http://schemas.openxmlformats.org/drawingml/2006/main" noGrp="1"/>
+          </p:cNvSpPr>
+          <p:nvPr/>
+        </p:nvSpPr>
+        <p:spPr>
+          <a:xfrm xmlns:a="http://schemas.openxmlformats.org/drawingml/2006/main">
+            <a:off x="8429625" y="2190750"/>
+            <a:ext cx="2952750" cy="2095500"/>
           </a:xfrm>
           <a:prstGeom xmlns:a="http://schemas.openxmlformats.org/drawingml/2006/main" prst="roundRect">
             <a:avLst>
@@ -17538,19 +17538,19 @@
           <p:cNvPr id="22" name="">
             <a:extLst xmlns:a="http://schemas.openxmlformats.org/drawingml/2006/main">
               <a:ext uri="{FF2B5EF4-FFF2-40B4-BE49-F238E27FC236}">
-                <a16:creationId xmlns:a16="http://schemas.microsoft.com/office/drawing/2014/main" id="{834C938D-3542-4CC3-AEA7-97CB8A2700C7}"/>
-              </a:ext>
-            </a:extLst>
-          </p:cNvPr>
-          <p:cNvSpPr>
-            <a:spLocks xmlns:a="http://schemas.openxmlformats.org/drawingml/2006/main" noGrp="1"/>
-          </p:cNvSpPr>
-          <p:nvPr/>
-        </p:nvSpPr>
-        <p:spPr>
-          <a:xfrm xmlns:a="http://schemas.openxmlformats.org/drawingml/2006/main">
-            <a:off x="9277350" y="2362200"/>
-            <a:ext cx="1638300" cy="209550"/>
+                <a16:creationId xmlns:a16="http://schemas.microsoft.com/office/drawing/2014/main" id="{0C45B2EE-4A29-44DF-8AFB-4A17FF11AF43}"/>
+              </a:ext>
+            </a:extLst>
+          </p:cNvPr>
+          <p:cNvSpPr>
+            <a:spLocks xmlns:a="http://schemas.openxmlformats.org/drawingml/2006/main" noGrp="1"/>
+          </p:cNvSpPr>
+          <p:nvPr/>
+        </p:nvSpPr>
+        <p:spPr>
+          <a:xfrm xmlns:a="http://schemas.openxmlformats.org/drawingml/2006/main">
+            <a:off x="8658225" y="2362200"/>
+            <a:ext cx="2495550" cy="209550"/>
           </a:xfrm>
           <a:prstGeom xmlns:a="http://schemas.openxmlformats.org/drawingml/2006/main" prst="rect">
             <a:avLst/>
@@ -17595,19 +17595,19 @@
           <p:cNvPr id="23" name="">
             <a:extLst xmlns:a="http://schemas.openxmlformats.org/drawingml/2006/main">
               <a:ext uri="{FF2B5EF4-FFF2-40B4-BE49-F238E27FC236}">
-                <a16:creationId xmlns:a16="http://schemas.microsoft.com/office/drawing/2014/main" id="{EDC38CA3-176F-4128-BD01-2FD9AE70B982}"/>
-              </a:ext>
-            </a:extLst>
-          </p:cNvPr>
-          <p:cNvSpPr>
-            <a:spLocks xmlns:a="http://schemas.openxmlformats.org/drawingml/2006/main" noGrp="1"/>
-          </p:cNvSpPr>
-          <p:nvPr/>
-        </p:nvSpPr>
-        <p:spPr>
-          <a:xfrm xmlns:a="http://schemas.openxmlformats.org/drawingml/2006/main">
-            <a:off x="9277350" y="2705100"/>
-            <a:ext cx="1638300" cy="381000"/>
+                <a16:creationId xmlns:a16="http://schemas.microsoft.com/office/drawing/2014/main" id="{7D71395F-5596-4E1D-9F81-D911E287A6BB}"/>
+              </a:ext>
+            </a:extLst>
+          </p:cNvPr>
+          <p:cNvSpPr>
+            <a:spLocks xmlns:a="http://schemas.openxmlformats.org/drawingml/2006/main" noGrp="1"/>
+          </p:cNvSpPr>
+          <p:nvPr/>
+        </p:nvSpPr>
+        <p:spPr>
+          <a:xfrm xmlns:a="http://schemas.openxmlformats.org/drawingml/2006/main">
+            <a:off x="8658225" y="2705100"/>
+            <a:ext cx="2495550" cy="381000"/>
           </a:xfrm>
           <a:prstGeom xmlns:a="http://schemas.openxmlformats.org/drawingml/2006/main" prst="rect">
             <a:avLst/>
@@ -17652,19 +17652,19 @@
           <p:cNvPr id="24" name="">
             <a:extLst xmlns:a="http://schemas.openxmlformats.org/drawingml/2006/main">
               <a:ext uri="{FF2B5EF4-FFF2-40B4-BE49-F238E27FC236}">
-                <a16:creationId xmlns:a16="http://schemas.microsoft.com/office/drawing/2014/main" id="{D80C968F-1ACE-4395-B6D5-C651E3D364AD}"/>
-              </a:ext>
-            </a:extLst>
-          </p:cNvPr>
-          <p:cNvSpPr>
-            <a:spLocks xmlns:a="http://schemas.openxmlformats.org/drawingml/2006/main" noGrp="1"/>
-          </p:cNvSpPr>
-          <p:nvPr/>
-        </p:nvSpPr>
-        <p:spPr>
-          <a:xfrm xmlns:a="http://schemas.openxmlformats.org/drawingml/2006/main">
-            <a:off x="9277350" y="3162300"/>
-            <a:ext cx="1638300" cy="971550"/>
+                <a16:creationId xmlns:a16="http://schemas.microsoft.com/office/drawing/2014/main" id="{A4AAFD77-9821-4B74-89DD-4C94EBD38F33}"/>
+              </a:ext>
+            </a:extLst>
+          </p:cNvPr>
+          <p:cNvSpPr>
+            <a:spLocks xmlns:a="http://schemas.openxmlformats.org/drawingml/2006/main" noGrp="1"/>
+          </p:cNvSpPr>
+          <p:nvPr/>
+        </p:nvSpPr>
+        <p:spPr>
+          <a:xfrm xmlns:a="http://schemas.openxmlformats.org/drawingml/2006/main">
+            <a:off x="8658225" y="3219450"/>
+            <a:ext cx="2495550" cy="266700"/>
           </a:xfrm>
           <a:prstGeom xmlns:a="http://schemas.openxmlformats.org/drawingml/2006/main" prst="rect">
             <a:avLst/>
@@ -17681,9 +17681,9 @@
           <a:lstStyle xmlns:a="http://schemas.openxmlformats.org/drawingml/2006/main"/>
           <a:p xmlns:a="http://schemas.openxmlformats.org/drawingml/2006/main">
             <a:pPr algn="l">
-              <a:defRPr sz="1275" b="0" i="0">
-                <a:solidFill>
-                  <a:srgbClr val="68675F"/>
+              <a:defRPr sz="1050" b="1" i="0">
+                <a:solidFill>
+                  <a:srgbClr val="22231F"/>
                 </a:solidFill>
                 <a:latin typeface="Avenir Next"/>
                 <a:ea typeface="Avenir Next"/>
@@ -17691,27 +17691,57 @@
               </a:defRPr>
             </a:pPr>
             <a:r>
-              <a:rPr sz="1275" b="0" i="0">
-                <a:solidFill>
-                  <a:srgbClr val="68675F"/>
-                </a:solidFill>
-                <a:latin typeface="Avenir Next"/>
-                <a:ea typeface="Avenir Next"/>
-                <a:cs typeface="Avenir Next"/>
+              <a:rPr sz="1050" b="1" u="sng">
+                <a:solidFill>
+                  <a:srgbClr val="9E315E"/>
+                </a:solidFill>
+                <a:latin typeface="Avenir Next"/>
+                <a:ea typeface="Avenir Next"/>
+                <a:cs typeface="Avenir Next"/>
+                <a:hlinkClick xmlns:r="http://schemas.openxmlformats.org/officeDocument/2006/relationships" r:id="R197060fa66364df3"/>
               </a:rPr>
-              <a:t>everythingpython.in</a:t>
-            </a:r>
-          </a:p>
-          <a:p xmlns:a="http://schemas.openxmlformats.org/drawingml/2006/main">
-            <a:r>
-              <a:t/>
-            </a:r>
-          </a:p>
+              <a:t>https://everythingpython.in</a:t>
+            </a:r>
+          </a:p>
+        </p:txBody>
+      </p:sp>
+      <p:sp>
+        <p:nvSpPr>
+          <p:cNvPr id="25" name="">
+            <a:extLst xmlns:a="http://schemas.openxmlformats.org/drawingml/2006/main">
+              <a:ext uri="{FF2B5EF4-FFF2-40B4-BE49-F238E27FC236}">
+                <a16:creationId xmlns:a16="http://schemas.microsoft.com/office/drawing/2014/main" id="{23C628FD-A64D-4008-91E8-92234B1FDA59}"/>
+              </a:ext>
+            </a:extLst>
+          </p:cNvPr>
+          <p:cNvSpPr>
+            <a:spLocks xmlns:a="http://schemas.openxmlformats.org/drawingml/2006/main" noGrp="1"/>
+          </p:cNvSpPr>
+          <p:nvPr/>
+        </p:nvSpPr>
+        <p:spPr>
+          <a:xfrm xmlns:a="http://schemas.openxmlformats.org/drawingml/2006/main">
+            <a:off x="8658225" y="3667125"/>
+            <a:ext cx="2495550" cy="400050"/>
+          </a:xfrm>
+          <a:prstGeom xmlns:a="http://schemas.openxmlformats.org/drawingml/2006/main" prst="rect">
+            <a:avLst/>
+          </a:prstGeom>
+          <a:noFill xmlns:a="http://schemas.openxmlformats.org/drawingml/2006/main"/>
+          <a:ln xmlns:a="http://schemas.openxmlformats.org/drawingml/2006/main" w="0">
+            <a:noFill/>
+          </a:ln>
+        </p:spPr>
+        <p:txBody>
+          <a:bodyPr xmlns:a="http://schemas.openxmlformats.org/drawingml/2006/main" wrap="square" lIns="0" tIns="0" rIns="0" bIns="0" anchor="t">
+            <a:normAutofit fontScale="100000"/>
+          </a:bodyPr>
+          <a:lstStyle xmlns:a="http://schemas.openxmlformats.org/drawingml/2006/main"/>
           <a:p xmlns:a="http://schemas.openxmlformats.org/drawingml/2006/main">
             <a:pPr algn="l">
-              <a:defRPr sz="1275" b="0" i="0">
-                <a:solidFill>
-                  <a:srgbClr val="68675F"/>
+              <a:defRPr sz="938" b="1" i="0">
+                <a:solidFill>
+                  <a:srgbClr val="22231F"/>
                 </a:solidFill>
                 <a:latin typeface="Avenir Next"/>
                 <a:ea typeface="Avenir Next"/>
@@ -17719,48 +17749,26 @@
               </a:defRPr>
             </a:pPr>
             <a:r>
-              <a:rPr sz="1275" b="0" i="0">
-                <a:solidFill>
-                  <a:srgbClr val="68675F"/>
-                </a:solidFill>
-                <a:latin typeface="Avenir Next"/>
-                <a:ea typeface="Avenir Next"/>
-                <a:cs typeface="Avenir Next"/>
+              <a:rPr sz="938" b="1" u="sng">
+                <a:solidFill>
+                  <a:srgbClr val="9E315E"/>
+                </a:solidFill>
+                <a:latin typeface="Avenir Next"/>
+                <a:ea typeface="Avenir Next"/>
+                <a:cs typeface="Avenir Next"/>
+                <a:hlinkClick xmlns:r="http://schemas.openxmlformats.org/officeDocument/2006/relationships" r:id="R93ba6a35cefe4c08"/>
               </a:rPr>
-              <a:t>linkedin.com/in/</a:t>
-            </a:r>
-          </a:p>
-          <a:p xmlns:a="http://schemas.openxmlformats.org/drawingml/2006/main">
-            <a:pPr algn="l">
-              <a:defRPr sz="1275" b="0" i="0">
-                <a:solidFill>
-                  <a:srgbClr val="68675F"/>
-                </a:solidFill>
-                <a:latin typeface="Avenir Next"/>
-                <a:ea typeface="Avenir Next"/>
-                <a:cs typeface="Avenir Next"/>
-              </a:defRPr>
-            </a:pPr>
-            <a:r>
-              <a:rPr sz="1275" b="0" i="0">
-                <a:solidFill>
-                  <a:srgbClr val="68675F"/>
-                </a:solidFill>
-                <a:latin typeface="Avenir Next"/>
-                <a:ea typeface="Avenir Next"/>
-                <a:cs typeface="Avenir Next"/>
-              </a:rPr>
-              <a:t>abhiramr5459</a:t>
-            </a:r>
-          </a:p>
-        </p:txBody>
-      </p:sp>
-      <p:sp>
-        <p:nvSpPr>
-          <p:cNvPr id="25" name="">
-            <a:extLst xmlns:a="http://schemas.openxmlformats.org/drawingml/2006/main">
-              <a:ext uri="{FF2B5EF4-FFF2-40B4-BE49-F238E27FC236}">
-                <a16:creationId xmlns:a16="http://schemas.microsoft.com/office/drawing/2014/main" id="{043BDECB-3D3D-4C4C-A466-F5CF7AC61155}"/>
+              <a:t>https://linkedin.com/in/abhiramr5459</a:t>
+            </a:r>
+          </a:p>
+        </p:txBody>
+      </p:sp>
+      <p:sp>
+        <p:nvSpPr>
+          <p:cNvPr id="26" name="">
+            <a:extLst xmlns:a="http://schemas.openxmlformats.org/drawingml/2006/main">
+              <a:ext uri="{FF2B5EF4-FFF2-40B4-BE49-F238E27FC236}">
+                <a16:creationId xmlns:a16="http://schemas.microsoft.com/office/drawing/2014/main" id="{087432C6-A051-4EF9-BDC8-E95489340F0C}"/>
               </a:ext>
             </a:extLst>
           </p:cNvPr>
@@ -17814,10 +17822,10 @@
       </p:sp>
       <p:sp>
         <p:nvSpPr>
-          <p:cNvPr id="26" name="">
-            <a:extLst xmlns:a="http://schemas.openxmlformats.org/drawingml/2006/main">
-              <a:ext uri="{FF2B5EF4-FFF2-40B4-BE49-F238E27FC236}">
-                <a16:creationId xmlns:a16="http://schemas.microsoft.com/office/drawing/2014/main" id="{8944366B-832C-48C6-9B36-A47A92719495}"/>
+          <p:cNvPr id="27" name="">
+            <a:extLst xmlns:a="http://schemas.openxmlformats.org/drawingml/2006/main">
+              <a:ext uri="{FF2B5EF4-FFF2-40B4-BE49-F238E27FC236}">
+                <a16:creationId xmlns:a16="http://schemas.microsoft.com/office/drawing/2014/main" id="{546F6E44-BBBB-489F-A99D-485A247C15C7}"/>
               </a:ext>
             </a:extLst>
           </p:cNvPr>
@@ -17872,7 +17880,7 @@
     </p:spTree>
     <p:extLst>
       <p:ext uri="{BB962C8B-B14F-4D97-AF65-F5344CB8AC3E}">
-        <p14:creationId xmlns:p14="http://schemas.microsoft.com/office/powerpoint/2010/main" val="172808604"/>
+        <p14:creationId xmlns:p14="http://schemas.microsoft.com/office/powerpoint/2010/main" val="987798152"/>
       </p:ext>
     </p:extLst>
   </p:cSld>
@@ -17903,7 +17911,7 @@
           <p:cNvPr id="43" name="">
             <a:extLst xmlns:a="http://schemas.openxmlformats.org/drawingml/2006/main">
               <a:ext uri="{FF2B5EF4-FFF2-40B4-BE49-F238E27FC236}">
-                <a16:creationId xmlns:a16="http://schemas.microsoft.com/office/drawing/2014/main" id="{47AE48DB-5CDA-4EEC-847D-14F9AE3A0409}"/>
+                <a16:creationId xmlns:a16="http://schemas.microsoft.com/office/drawing/2014/main" id="{A2A06D24-3951-4E68-BA9D-16EA0BCCBB90}"/>
               </a:ext>
             </a:extLst>
           </p:cNvPr>
@@ -17934,7 +17942,7 @@
           <p:cNvPr id="2" name="">
             <a:extLst xmlns:a="http://schemas.openxmlformats.org/drawingml/2006/main">
               <a:ext uri="{FF2B5EF4-FFF2-40B4-BE49-F238E27FC236}">
-                <a16:creationId xmlns:a16="http://schemas.microsoft.com/office/drawing/2014/main" id="{84BFA9CB-30E7-4ED8-8DA5-0CDEB3603080}"/>
+                <a16:creationId xmlns:a16="http://schemas.microsoft.com/office/drawing/2014/main" id="{A887512B-BFCE-4162-8389-486E0BA5A76B}"/>
               </a:ext>
             </a:extLst>
           </p:cNvPr>
@@ -17965,7 +17973,7 @@
           <p:cNvPr id="3" name="">
             <a:extLst xmlns:a="http://schemas.openxmlformats.org/drawingml/2006/main">
               <a:ext uri="{FF2B5EF4-FFF2-40B4-BE49-F238E27FC236}">
-                <a16:creationId xmlns:a16="http://schemas.microsoft.com/office/drawing/2014/main" id="{45950B89-FBD8-4AC8-9796-765B1C3E1110}"/>
+                <a16:creationId xmlns:a16="http://schemas.microsoft.com/office/drawing/2014/main" id="{AD0C2B42-44DC-455A-8F69-8FD0D6013E65}"/>
               </a:ext>
             </a:extLst>
           </p:cNvPr>
@@ -18022,7 +18030,7 @@
           <p:cNvPr id="4" name="">
             <a:extLst xmlns:a="http://schemas.openxmlformats.org/drawingml/2006/main">
               <a:ext uri="{FF2B5EF4-FFF2-40B4-BE49-F238E27FC236}">
-                <a16:creationId xmlns:a16="http://schemas.microsoft.com/office/drawing/2014/main" id="{2F392DEF-5A69-421F-9ECF-B468E2C0705C}"/>
+                <a16:creationId xmlns:a16="http://schemas.microsoft.com/office/drawing/2014/main" id="{4A240790-F8CE-454C-8A3F-CD8F68D69476}"/>
               </a:ext>
             </a:extLst>
           </p:cNvPr>
@@ -18079,7 +18087,7 @@
           <p:cNvPr id="5" name="">
             <a:extLst xmlns:a="http://schemas.openxmlformats.org/drawingml/2006/main">
               <a:ext uri="{FF2B5EF4-FFF2-40B4-BE49-F238E27FC236}">
-                <a16:creationId xmlns:a16="http://schemas.microsoft.com/office/drawing/2014/main" id="{34C85900-5E63-4B17-87BE-7E5EC683E3E7}"/>
+                <a16:creationId xmlns:a16="http://schemas.microsoft.com/office/drawing/2014/main" id="{BFF6894D-39DD-465B-BF55-57844395E03B}"/>
               </a:ext>
             </a:extLst>
           </p:cNvPr>
@@ -18112,7 +18120,7 @@
           <p:cNvPr id="6" name="">
             <a:extLst xmlns:a="http://schemas.openxmlformats.org/drawingml/2006/main">
               <a:ext uri="{FF2B5EF4-FFF2-40B4-BE49-F238E27FC236}">
-                <a16:creationId xmlns:a16="http://schemas.microsoft.com/office/drawing/2014/main" id="{DEE7BB40-D4E8-4BA2-9525-B0F5AF48EB63}"/>
+                <a16:creationId xmlns:a16="http://schemas.microsoft.com/office/drawing/2014/main" id="{95687CE5-285F-4637-80D7-9E7C5794E08C}"/>
               </a:ext>
             </a:extLst>
           </p:cNvPr>
@@ -18147,7 +18155,7 @@
           <p:cNvPr id="7" name="">
             <a:extLst xmlns:a="http://schemas.openxmlformats.org/drawingml/2006/main">
               <a:ext uri="{FF2B5EF4-FFF2-40B4-BE49-F238E27FC236}">
-                <a16:creationId xmlns:a16="http://schemas.microsoft.com/office/drawing/2014/main" id="{54776742-8364-4EFF-A0A2-F54665EA94E0}"/>
+                <a16:creationId xmlns:a16="http://schemas.microsoft.com/office/drawing/2014/main" id="{00D5A6D6-CBFE-4638-9169-89EABE907E7A}"/>
               </a:ext>
             </a:extLst>
           </p:cNvPr>
@@ -18204,7 +18212,7 @@
           <p:cNvPr id="8" name="">
             <a:extLst xmlns:a="http://schemas.openxmlformats.org/drawingml/2006/main">
               <a:ext uri="{FF2B5EF4-FFF2-40B4-BE49-F238E27FC236}">
-                <a16:creationId xmlns:a16="http://schemas.microsoft.com/office/drawing/2014/main" id="{52841538-1166-4CDF-AEEC-8152C896D4CA}"/>
+                <a16:creationId xmlns:a16="http://schemas.microsoft.com/office/drawing/2014/main" id="{6042AF44-1935-48FA-A558-8F74A37083F4}"/>
               </a:ext>
             </a:extLst>
           </p:cNvPr>
@@ -18261,7 +18269,7 @@
           <p:cNvPr id="9" name="">
             <a:extLst xmlns:a="http://schemas.openxmlformats.org/drawingml/2006/main">
               <a:ext uri="{FF2B5EF4-FFF2-40B4-BE49-F238E27FC236}">
-                <a16:creationId xmlns:a16="http://schemas.microsoft.com/office/drawing/2014/main" id="{A2BF5224-7118-4E66-A888-0BE8B475B5F2}"/>
+                <a16:creationId xmlns:a16="http://schemas.microsoft.com/office/drawing/2014/main" id="{E7B3D39C-86CD-4D79-955C-1E73758659DF}"/>
               </a:ext>
             </a:extLst>
           </p:cNvPr>
@@ -18294,7 +18302,7 @@
           <p:cNvPr id="10" name="">
             <a:extLst xmlns:a="http://schemas.openxmlformats.org/drawingml/2006/main">
               <a:ext uri="{FF2B5EF4-FFF2-40B4-BE49-F238E27FC236}">
-                <a16:creationId xmlns:a16="http://schemas.microsoft.com/office/drawing/2014/main" id="{6F549A29-BAC7-44F6-AF14-EB0E18CAE92A}"/>
+                <a16:creationId xmlns:a16="http://schemas.microsoft.com/office/drawing/2014/main" id="{1F8D4698-2929-49A3-9CB3-E032973D7C78}"/>
               </a:ext>
             </a:extLst>
           </p:cNvPr>
@@ -18329,7 +18337,7 @@
           <p:cNvPr id="11" name="">
             <a:extLst xmlns:a="http://schemas.openxmlformats.org/drawingml/2006/main">
               <a:ext uri="{FF2B5EF4-FFF2-40B4-BE49-F238E27FC236}">
-                <a16:creationId xmlns:a16="http://schemas.microsoft.com/office/drawing/2014/main" id="{19452003-8E14-4E8A-BBEF-1CD8CBA2E927}"/>
+                <a16:creationId xmlns:a16="http://schemas.microsoft.com/office/drawing/2014/main" id="{52A36F0A-60BB-4E74-91AF-E689658FDDD3}"/>
               </a:ext>
             </a:extLst>
           </p:cNvPr>
@@ -18386,7 +18394,7 @@
           <p:cNvPr id="12" name="">
             <a:extLst xmlns:a="http://schemas.openxmlformats.org/drawingml/2006/main">
               <a:ext uri="{FF2B5EF4-FFF2-40B4-BE49-F238E27FC236}">
-                <a16:creationId xmlns:a16="http://schemas.microsoft.com/office/drawing/2014/main" id="{0556D7A1-202D-47C3-B048-3CE8003577F2}"/>
+                <a16:creationId xmlns:a16="http://schemas.microsoft.com/office/drawing/2014/main" id="{AB56C6C0-DC0E-4722-9F51-288995D0F1F4}"/>
               </a:ext>
             </a:extLst>
           </p:cNvPr>
@@ -18443,7 +18451,7 @@
           <p:cNvPr id="13" name="">
             <a:extLst xmlns:a="http://schemas.openxmlformats.org/drawingml/2006/main">
               <a:ext uri="{FF2B5EF4-FFF2-40B4-BE49-F238E27FC236}">
-                <a16:creationId xmlns:a16="http://schemas.microsoft.com/office/drawing/2014/main" id="{CBE57082-5A92-49A6-BEE2-AA03C0913C04}"/>
+                <a16:creationId xmlns:a16="http://schemas.microsoft.com/office/drawing/2014/main" id="{9ED84FBE-C944-4A07-AF9D-572872F6F92C}"/>
               </a:ext>
             </a:extLst>
           </p:cNvPr>
@@ -18476,7 +18484,7 @@
           <p:cNvPr id="14" name="">
             <a:extLst xmlns:a="http://schemas.openxmlformats.org/drawingml/2006/main">
               <a:ext uri="{FF2B5EF4-FFF2-40B4-BE49-F238E27FC236}">
-                <a16:creationId xmlns:a16="http://schemas.microsoft.com/office/drawing/2014/main" id="{6BEDA398-82FE-41D2-92C0-9BC3F4856852}"/>
+                <a16:creationId xmlns:a16="http://schemas.microsoft.com/office/drawing/2014/main" id="{FDB990A7-8568-4DD6-8BDB-626890AED713}"/>
               </a:ext>
             </a:extLst>
           </p:cNvPr>
@@ -18511,7 +18519,7 @@
           <p:cNvPr id="15" name="">
             <a:extLst xmlns:a="http://schemas.openxmlformats.org/drawingml/2006/main">
               <a:ext uri="{FF2B5EF4-FFF2-40B4-BE49-F238E27FC236}">
-                <a16:creationId xmlns:a16="http://schemas.microsoft.com/office/drawing/2014/main" id="{C4A69782-A0AE-431B-AB96-D4D63AC1C811}"/>
+                <a16:creationId xmlns:a16="http://schemas.microsoft.com/office/drawing/2014/main" id="{A7C1CFF4-3E60-4442-9BCE-4E2236CD8BCD}"/>
               </a:ext>
             </a:extLst>
           </p:cNvPr>
@@ -18568,7 +18576,7 @@
           <p:cNvPr id="16" name="">
             <a:extLst xmlns:a="http://schemas.openxmlformats.org/drawingml/2006/main">
               <a:ext uri="{FF2B5EF4-FFF2-40B4-BE49-F238E27FC236}">
-                <a16:creationId xmlns:a16="http://schemas.microsoft.com/office/drawing/2014/main" id="{C30BBA92-3464-40D3-82B8-68133130C1DB}"/>
+                <a16:creationId xmlns:a16="http://schemas.microsoft.com/office/drawing/2014/main" id="{2A2F767F-E83A-4B27-942F-B0B948B18AFC}"/>
               </a:ext>
             </a:extLst>
           </p:cNvPr>
@@ -18625,7 +18633,7 @@
           <p:cNvPr id="17" name="">
             <a:extLst xmlns:a="http://schemas.openxmlformats.org/drawingml/2006/main">
               <a:ext uri="{FF2B5EF4-FFF2-40B4-BE49-F238E27FC236}">
-                <a16:creationId xmlns:a16="http://schemas.microsoft.com/office/drawing/2014/main" id="{01836730-00E7-48C2-9818-0A99BFB54AA1}"/>
+                <a16:creationId xmlns:a16="http://schemas.microsoft.com/office/drawing/2014/main" id="{4EF46D89-B0AE-4ACD-B7E7-2AB534DE0488}"/>
               </a:ext>
             </a:extLst>
           </p:cNvPr>
@@ -18658,7 +18666,7 @@
           <p:cNvPr id="18" name="">
             <a:extLst xmlns:a="http://schemas.openxmlformats.org/drawingml/2006/main">
               <a:ext uri="{FF2B5EF4-FFF2-40B4-BE49-F238E27FC236}">
-                <a16:creationId xmlns:a16="http://schemas.microsoft.com/office/drawing/2014/main" id="{2355B5DC-721A-4723-8969-221C545D1F6C}"/>
+                <a16:creationId xmlns:a16="http://schemas.microsoft.com/office/drawing/2014/main" id="{CF3445FD-15AC-4C25-8641-F33B523F3358}"/>
               </a:ext>
             </a:extLst>
           </p:cNvPr>
@@ -18693,7 +18701,7 @@
           <p:cNvPr id="19" name="">
             <a:extLst xmlns:a="http://schemas.openxmlformats.org/drawingml/2006/main">
               <a:ext uri="{FF2B5EF4-FFF2-40B4-BE49-F238E27FC236}">
-                <a16:creationId xmlns:a16="http://schemas.microsoft.com/office/drawing/2014/main" id="{DFA8CAEC-F5A2-48FB-889B-0972C8B198FF}"/>
+                <a16:creationId xmlns:a16="http://schemas.microsoft.com/office/drawing/2014/main" id="{5C726ED3-F990-4688-BDC3-5BF2C511BAFA}"/>
               </a:ext>
             </a:extLst>
           </p:cNvPr>
@@ -18750,7 +18758,7 @@
           <p:cNvPr id="20" name="">
             <a:extLst xmlns:a="http://schemas.openxmlformats.org/drawingml/2006/main">
               <a:ext uri="{FF2B5EF4-FFF2-40B4-BE49-F238E27FC236}">
-                <a16:creationId xmlns:a16="http://schemas.microsoft.com/office/drawing/2014/main" id="{DBD61F7F-A8BB-4833-B7A0-9D95B535054F}"/>
+                <a16:creationId xmlns:a16="http://schemas.microsoft.com/office/drawing/2014/main" id="{D98C0D33-618B-45C8-8670-44038A023DD4}"/>
               </a:ext>
             </a:extLst>
           </p:cNvPr>
@@ -18807,7 +18815,7 @@
           <p:cNvPr id="21" name="">
             <a:extLst xmlns:a="http://schemas.openxmlformats.org/drawingml/2006/main">
               <a:ext uri="{FF2B5EF4-FFF2-40B4-BE49-F238E27FC236}">
-                <a16:creationId xmlns:a16="http://schemas.microsoft.com/office/drawing/2014/main" id="{4497375B-0FA3-41DF-8C23-4D08EA4F947A}"/>
+                <a16:creationId xmlns:a16="http://schemas.microsoft.com/office/drawing/2014/main" id="{9CF494FC-3618-490B-8CDE-20D51E36DC05}"/>
               </a:ext>
             </a:extLst>
           </p:cNvPr>
@@ -18840,7 +18848,7 @@
           <p:cNvPr id="22" name="">
             <a:extLst xmlns:a="http://schemas.openxmlformats.org/drawingml/2006/main">
               <a:ext uri="{FF2B5EF4-FFF2-40B4-BE49-F238E27FC236}">
-                <a16:creationId xmlns:a16="http://schemas.microsoft.com/office/drawing/2014/main" id="{6D4154BF-E9FE-41C2-BEF1-DE8BC3C3B4E9}"/>
+                <a16:creationId xmlns:a16="http://schemas.microsoft.com/office/drawing/2014/main" id="{0ADB14A8-D893-4DAB-A6D1-76328EFFC715}"/>
               </a:ext>
             </a:extLst>
           </p:cNvPr>
@@ -18875,7 +18883,7 @@
           <p:cNvPr id="23" name="">
             <a:extLst xmlns:a="http://schemas.openxmlformats.org/drawingml/2006/main">
               <a:ext uri="{FF2B5EF4-FFF2-40B4-BE49-F238E27FC236}">
-                <a16:creationId xmlns:a16="http://schemas.microsoft.com/office/drawing/2014/main" id="{99C6A4FE-2D0B-4577-9B73-592C5ABC0DDA}"/>
+                <a16:creationId xmlns:a16="http://schemas.microsoft.com/office/drawing/2014/main" id="{2F7C8148-469C-4854-8F58-E0018D85C6CC}"/>
               </a:ext>
             </a:extLst>
           </p:cNvPr>
@@ -18932,7 +18940,7 @@
           <p:cNvPr id="24" name="">
             <a:extLst xmlns:a="http://schemas.openxmlformats.org/drawingml/2006/main">
               <a:ext uri="{FF2B5EF4-FFF2-40B4-BE49-F238E27FC236}">
-                <a16:creationId xmlns:a16="http://schemas.microsoft.com/office/drawing/2014/main" id="{3E434F46-F497-444C-93FB-927446B64A5B}"/>
+                <a16:creationId xmlns:a16="http://schemas.microsoft.com/office/drawing/2014/main" id="{90ADBB25-7CD5-4F5F-9FEA-91FF4F1FBE9E}"/>
               </a:ext>
             </a:extLst>
           </p:cNvPr>
@@ -18989,7 +18997,7 @@
           <p:cNvPr id="25" name="">
             <a:extLst xmlns:a="http://schemas.openxmlformats.org/drawingml/2006/main">
               <a:ext uri="{FF2B5EF4-FFF2-40B4-BE49-F238E27FC236}">
-                <a16:creationId xmlns:a16="http://schemas.microsoft.com/office/drawing/2014/main" id="{98C9EB6A-7B91-4EDF-AADA-693F3A5464B4}"/>
+                <a16:creationId xmlns:a16="http://schemas.microsoft.com/office/drawing/2014/main" id="{D1F751B7-474D-4546-9B84-BE0DF4C62CC3}"/>
               </a:ext>
             </a:extLst>
           </p:cNvPr>
@@ -19020,7 +19028,7 @@
           <p:cNvPr id="26" name="">
             <a:extLst xmlns:a="http://schemas.openxmlformats.org/drawingml/2006/main">
               <a:ext uri="{FF2B5EF4-FFF2-40B4-BE49-F238E27FC236}">
-                <a16:creationId xmlns:a16="http://schemas.microsoft.com/office/drawing/2014/main" id="{C971BF84-F067-4809-97E5-CF3CC9392492}"/>
+                <a16:creationId xmlns:a16="http://schemas.microsoft.com/office/drawing/2014/main" id="{83DDB48F-239A-4CCB-8744-03A568B1DD0D}"/>
               </a:ext>
             </a:extLst>
           </p:cNvPr>
@@ -19051,7 +19059,7 @@
           <p:cNvPr id="27" name="">
             <a:extLst xmlns:a="http://schemas.openxmlformats.org/drawingml/2006/main">
               <a:ext uri="{FF2B5EF4-FFF2-40B4-BE49-F238E27FC236}">
-                <a16:creationId xmlns:a16="http://schemas.microsoft.com/office/drawing/2014/main" id="{42A3972C-C470-474E-8E48-AE0086633D3C}"/>
+                <a16:creationId xmlns:a16="http://schemas.microsoft.com/office/drawing/2014/main" id="{0284FAEA-D004-4443-B3BA-0AFC660B72CB}"/>
               </a:ext>
             </a:extLst>
           </p:cNvPr>
@@ -19083,7 +19091,7 @@
           <p:cNvPr id="28" name="">
             <a:extLst xmlns:a="http://schemas.openxmlformats.org/drawingml/2006/main">
               <a:ext uri="{FF2B5EF4-FFF2-40B4-BE49-F238E27FC236}">
-                <a16:creationId xmlns:a16="http://schemas.microsoft.com/office/drawing/2014/main" id="{DEDB291B-657A-47AA-B591-712A10ADB2FB}"/>
+                <a16:creationId xmlns:a16="http://schemas.microsoft.com/office/drawing/2014/main" id="{7878A8F3-82C5-4763-9F89-509B014D7860}"/>
               </a:ext>
             </a:extLst>
           </p:cNvPr>
@@ -19114,7 +19122,7 @@
           <p:cNvPr id="29" name="">
             <a:extLst xmlns:a="http://schemas.openxmlformats.org/drawingml/2006/main">
               <a:ext uri="{FF2B5EF4-FFF2-40B4-BE49-F238E27FC236}">
-                <a16:creationId xmlns:a16="http://schemas.microsoft.com/office/drawing/2014/main" id="{C2B797F4-08CE-48F5-BF79-B64AB1B3743C}"/>
+                <a16:creationId xmlns:a16="http://schemas.microsoft.com/office/drawing/2014/main" id="{E22CF953-3531-4077-BB82-5334935E0A53}"/>
               </a:ext>
             </a:extLst>
           </p:cNvPr>
@@ -19145,7 +19153,7 @@
           <p:cNvPr id="30" name="">
             <a:extLst xmlns:a="http://schemas.openxmlformats.org/drawingml/2006/main">
               <a:ext uri="{FF2B5EF4-FFF2-40B4-BE49-F238E27FC236}">
-                <a16:creationId xmlns:a16="http://schemas.microsoft.com/office/drawing/2014/main" id="{792E4F26-1E0F-45A2-BE51-60D7513A4CD6}"/>
+                <a16:creationId xmlns:a16="http://schemas.microsoft.com/office/drawing/2014/main" id="{8E1C338E-BCD2-4DA1-B229-9916DCCE137F}"/>
               </a:ext>
             </a:extLst>
           </p:cNvPr>
@@ -19177,7 +19185,7 @@
           <p:cNvPr id="31" name="">
             <a:extLst xmlns:a="http://schemas.openxmlformats.org/drawingml/2006/main">
               <a:ext uri="{FF2B5EF4-FFF2-40B4-BE49-F238E27FC236}">
-                <a16:creationId xmlns:a16="http://schemas.microsoft.com/office/drawing/2014/main" id="{EEF43D05-56B7-4457-BAE7-60B2F5E6BB33}"/>
+                <a16:creationId xmlns:a16="http://schemas.microsoft.com/office/drawing/2014/main" id="{4D332133-6BA0-4A34-88D4-B207184474B2}"/>
               </a:ext>
             </a:extLst>
           </p:cNvPr>
@@ -19208,7 +19216,7 @@
           <p:cNvPr id="32" name="">
             <a:extLst xmlns:a="http://schemas.openxmlformats.org/drawingml/2006/main">
               <a:ext uri="{FF2B5EF4-FFF2-40B4-BE49-F238E27FC236}">
-                <a16:creationId xmlns:a16="http://schemas.microsoft.com/office/drawing/2014/main" id="{948628C4-B84E-48B1-9267-1609DCBE401E}"/>
+                <a16:creationId xmlns:a16="http://schemas.microsoft.com/office/drawing/2014/main" id="{0C047690-A763-488E-B7F1-FBC9B52D50D0}"/>
               </a:ext>
             </a:extLst>
           </p:cNvPr>
@@ -19239,7 +19247,7 @@
           <p:cNvPr id="33" name="">
             <a:extLst xmlns:a="http://schemas.openxmlformats.org/drawingml/2006/main">
               <a:ext uri="{FF2B5EF4-FFF2-40B4-BE49-F238E27FC236}">
-                <a16:creationId xmlns:a16="http://schemas.microsoft.com/office/drawing/2014/main" id="{5E697060-B8D6-4C42-827E-A77B0864BF28}"/>
+                <a16:creationId xmlns:a16="http://schemas.microsoft.com/office/drawing/2014/main" id="{0F537B3D-E1DD-41B8-B995-B38AED2C7CB5}"/>
               </a:ext>
             </a:extLst>
           </p:cNvPr>
@@ -19271,7 +19279,7 @@
           <p:cNvPr id="34" name="">
             <a:extLst xmlns:a="http://schemas.openxmlformats.org/drawingml/2006/main">
               <a:ext uri="{FF2B5EF4-FFF2-40B4-BE49-F238E27FC236}">
-                <a16:creationId xmlns:a16="http://schemas.microsoft.com/office/drawing/2014/main" id="{4B6D46A1-FE63-4716-9380-3C73AC83815F}"/>
+                <a16:creationId xmlns:a16="http://schemas.microsoft.com/office/drawing/2014/main" id="{ADC3BF11-7BC7-4CA1-8BDC-22BD753735D6}"/>
               </a:ext>
             </a:extLst>
           </p:cNvPr>
@@ -19302,7 +19310,7 @@
           <p:cNvPr id="35" name="">
             <a:extLst xmlns:a="http://schemas.openxmlformats.org/drawingml/2006/main">
               <a:ext uri="{FF2B5EF4-FFF2-40B4-BE49-F238E27FC236}">
-                <a16:creationId xmlns:a16="http://schemas.microsoft.com/office/drawing/2014/main" id="{8A561CCF-C907-4A27-84EE-916FD6F9FF18}"/>
+                <a16:creationId xmlns:a16="http://schemas.microsoft.com/office/drawing/2014/main" id="{CD8B5E08-6B59-41BC-A85B-734096BFA34A}"/>
               </a:ext>
             </a:extLst>
           </p:cNvPr>
@@ -19333,7 +19341,7 @@
           <p:cNvPr id="36" name="">
             <a:extLst xmlns:a="http://schemas.openxmlformats.org/drawingml/2006/main">
               <a:ext uri="{FF2B5EF4-FFF2-40B4-BE49-F238E27FC236}">
-                <a16:creationId xmlns:a16="http://schemas.microsoft.com/office/drawing/2014/main" id="{D6D99F68-100B-4A49-A595-6FB32F476FB4}"/>
+                <a16:creationId xmlns:a16="http://schemas.microsoft.com/office/drawing/2014/main" id="{40E8E9C6-D09A-473A-9CD9-00C44AFDA05D}"/>
               </a:ext>
             </a:extLst>
           </p:cNvPr>
@@ -19365,7 +19373,7 @@
           <p:cNvPr id="37" name="">
             <a:extLst xmlns:a="http://schemas.openxmlformats.org/drawingml/2006/main">
               <a:ext uri="{FF2B5EF4-FFF2-40B4-BE49-F238E27FC236}">
-                <a16:creationId xmlns:a16="http://schemas.microsoft.com/office/drawing/2014/main" id="{A89575DB-38F2-4C5C-944D-73F7410A70FB}"/>
+                <a16:creationId xmlns:a16="http://schemas.microsoft.com/office/drawing/2014/main" id="{0EE7FB82-F213-4D1C-BC3C-1B7566EA5EC1}"/>
               </a:ext>
             </a:extLst>
           </p:cNvPr>
@@ -19396,7 +19404,7 @@
           <p:cNvPr id="38" name="">
             <a:extLst xmlns:a="http://schemas.openxmlformats.org/drawingml/2006/main">
               <a:ext uri="{FF2B5EF4-FFF2-40B4-BE49-F238E27FC236}">
-                <a16:creationId xmlns:a16="http://schemas.microsoft.com/office/drawing/2014/main" id="{98CA4D09-41C9-4EBD-A8C2-7C2DA44A3877}"/>
+                <a16:creationId xmlns:a16="http://schemas.microsoft.com/office/drawing/2014/main" id="{235B005F-342A-4FC6-8254-340071DDFBFF}"/>
               </a:ext>
             </a:extLst>
           </p:cNvPr>
@@ -19453,7 +19461,7 @@
           <p:cNvPr id="39" name="">
             <a:extLst xmlns:a="http://schemas.openxmlformats.org/drawingml/2006/main">
               <a:ext uri="{FF2B5EF4-FFF2-40B4-BE49-F238E27FC236}">
-                <a16:creationId xmlns:a16="http://schemas.microsoft.com/office/drawing/2014/main" id="{0964454A-CA15-4EAE-A98E-4C54B0DD9B73}"/>
+                <a16:creationId xmlns:a16="http://schemas.microsoft.com/office/drawing/2014/main" id="{8A6DCEA5-5511-42B7-8A2D-D590F6A573A6}"/>
               </a:ext>
             </a:extLst>
           </p:cNvPr>
@@ -19510,7 +19518,7 @@
           <p:cNvPr id="40" name="">
             <a:extLst xmlns:a="http://schemas.openxmlformats.org/drawingml/2006/main">
               <a:ext uri="{FF2B5EF4-FFF2-40B4-BE49-F238E27FC236}">
-                <a16:creationId xmlns:a16="http://schemas.microsoft.com/office/drawing/2014/main" id="{09BA0BBC-8F0E-4FC2-8753-65FB33E6A330}"/>
+                <a16:creationId xmlns:a16="http://schemas.microsoft.com/office/drawing/2014/main" id="{CF8E92A2-4165-4E69-A9F2-E41287B8719B}"/>
               </a:ext>
             </a:extLst>
           </p:cNvPr>
@@ -19543,7 +19551,7 @@
           <p:cNvPr id="41" name="">
             <a:extLst xmlns:a="http://schemas.openxmlformats.org/drawingml/2006/main">
               <a:ext uri="{FF2B5EF4-FFF2-40B4-BE49-F238E27FC236}">
-                <a16:creationId xmlns:a16="http://schemas.microsoft.com/office/drawing/2014/main" id="{E7C4FDAF-BBBF-46F1-AD62-BEDCD428A7F4}"/>
+                <a16:creationId xmlns:a16="http://schemas.microsoft.com/office/drawing/2014/main" id="{545CF105-C140-40C7-8094-9C51E8168D51}"/>
               </a:ext>
             </a:extLst>
           </p:cNvPr>
@@ -19600,7 +19608,7 @@
           <p:cNvPr id="42" name="">
             <a:extLst xmlns:a="http://schemas.openxmlformats.org/drawingml/2006/main">
               <a:ext uri="{FF2B5EF4-FFF2-40B4-BE49-F238E27FC236}">
-                <a16:creationId xmlns:a16="http://schemas.microsoft.com/office/drawing/2014/main" id="{9EAADF39-CFAE-450A-B3C1-E511C5D3955E}"/>
+                <a16:creationId xmlns:a16="http://schemas.microsoft.com/office/drawing/2014/main" id="{90372BA9-1E6B-4A32-BF2A-8D568B7B476A}"/>
               </a:ext>
             </a:extLst>
           </p:cNvPr>
@@ -19655,7 +19663,7 @@
     </p:spTree>
     <p:extLst>
       <p:ext uri="{BB962C8B-B14F-4D97-AF65-F5344CB8AC3E}">
-        <p14:creationId xmlns:p14="http://schemas.microsoft.com/office/powerpoint/2010/main" val="1945813858"/>
+        <p14:creationId xmlns:p14="http://schemas.microsoft.com/office/powerpoint/2010/main" val="1391319336"/>
       </p:ext>
     </p:extLst>
   </p:cSld>
@@ -19686,7 +19694,7 @@
           <p:cNvPr id="29" name="">
             <a:extLst xmlns:a="http://schemas.openxmlformats.org/drawingml/2006/main">
               <a:ext uri="{FF2B5EF4-FFF2-40B4-BE49-F238E27FC236}">
-                <a16:creationId xmlns:a16="http://schemas.microsoft.com/office/drawing/2014/main" id="{FE44CE1C-B2E0-463A-A144-0D38D4CC8750}"/>
+                <a16:creationId xmlns:a16="http://schemas.microsoft.com/office/drawing/2014/main" id="{A0670EE6-12A4-4F86-A8EF-D66083034A3E}"/>
               </a:ext>
             </a:extLst>
           </p:cNvPr>
@@ -19717,7 +19725,7 @@
           <p:cNvPr id="2" name="">
             <a:extLst xmlns:a="http://schemas.openxmlformats.org/drawingml/2006/main">
               <a:ext uri="{FF2B5EF4-FFF2-40B4-BE49-F238E27FC236}">
-                <a16:creationId xmlns:a16="http://schemas.microsoft.com/office/drawing/2014/main" id="{88FEFD78-82A2-49EA-8E75-30A89B5CC443}"/>
+                <a16:creationId xmlns:a16="http://schemas.microsoft.com/office/drawing/2014/main" id="{C3313A0F-3BB6-40D3-BB98-4F9FC2C1303F}"/>
               </a:ext>
             </a:extLst>
           </p:cNvPr>
@@ -19748,7 +19756,7 @@
           <p:cNvPr id="3" name="">
             <a:extLst xmlns:a="http://schemas.openxmlformats.org/drawingml/2006/main">
               <a:ext uri="{FF2B5EF4-FFF2-40B4-BE49-F238E27FC236}">
-                <a16:creationId xmlns:a16="http://schemas.microsoft.com/office/drawing/2014/main" id="{C6D0139D-0CA5-43CE-B63F-164872E5DB8E}"/>
+                <a16:creationId xmlns:a16="http://schemas.microsoft.com/office/drawing/2014/main" id="{DD1431AA-934F-46F9-946F-AD70B25B0B3E}"/>
               </a:ext>
             </a:extLst>
           </p:cNvPr>
@@ -19805,7 +19813,7 @@
           <p:cNvPr id="4" name="">
             <a:extLst xmlns:a="http://schemas.openxmlformats.org/drawingml/2006/main">
               <a:ext uri="{FF2B5EF4-FFF2-40B4-BE49-F238E27FC236}">
-                <a16:creationId xmlns:a16="http://schemas.microsoft.com/office/drawing/2014/main" id="{D32AC82C-DFDF-4AD0-A494-31067A290C0B}"/>
+                <a16:creationId xmlns:a16="http://schemas.microsoft.com/office/drawing/2014/main" id="{7623A7D6-1E57-4545-B5CA-42E015810EA6}"/>
               </a:ext>
             </a:extLst>
           </p:cNvPr>
@@ -19862,7 +19870,7 @@
           <p:cNvPr id="5" name="">
             <a:extLst xmlns:a="http://schemas.openxmlformats.org/drawingml/2006/main">
               <a:ext uri="{FF2B5EF4-FFF2-40B4-BE49-F238E27FC236}">
-                <a16:creationId xmlns:a16="http://schemas.microsoft.com/office/drawing/2014/main" id="{388282A0-4443-4BEC-BD8E-E2D0C5DB2AE3}"/>
+                <a16:creationId xmlns:a16="http://schemas.microsoft.com/office/drawing/2014/main" id="{4454320C-C3C6-4513-AEE7-BB0D7F5C186A}"/>
               </a:ext>
             </a:extLst>
           </p:cNvPr>
@@ -19895,7 +19903,7 @@
           <p:cNvPr id="6" name="">
             <a:extLst xmlns:a="http://schemas.openxmlformats.org/drawingml/2006/main">
               <a:ext uri="{FF2B5EF4-FFF2-40B4-BE49-F238E27FC236}">
-                <a16:creationId xmlns:a16="http://schemas.microsoft.com/office/drawing/2014/main" id="{E715807D-C271-440D-A759-CA2232596549}"/>
+                <a16:creationId xmlns:a16="http://schemas.microsoft.com/office/drawing/2014/main" id="{6305F9AE-4FEE-454F-9EFE-061283294905}"/>
               </a:ext>
             </a:extLst>
           </p:cNvPr>
@@ -19930,7 +19938,7 @@
           <p:cNvPr id="7" name="">
             <a:extLst xmlns:a="http://schemas.openxmlformats.org/drawingml/2006/main">
               <a:ext uri="{FF2B5EF4-FFF2-40B4-BE49-F238E27FC236}">
-                <a16:creationId xmlns:a16="http://schemas.microsoft.com/office/drawing/2014/main" id="{2CC13956-CB84-42D6-A706-5DCF6F8BAFD8}"/>
+                <a16:creationId xmlns:a16="http://schemas.microsoft.com/office/drawing/2014/main" id="{09E6FD9B-6D02-4DBA-93A5-4E3F6752AC4B}"/>
               </a:ext>
             </a:extLst>
           </p:cNvPr>
@@ -19987,7 +19995,7 @@
           <p:cNvPr id="8" name="">
             <a:extLst xmlns:a="http://schemas.openxmlformats.org/drawingml/2006/main">
               <a:ext uri="{FF2B5EF4-FFF2-40B4-BE49-F238E27FC236}">
-                <a16:creationId xmlns:a16="http://schemas.microsoft.com/office/drawing/2014/main" id="{C267FF5D-D6A2-43C5-A1E0-120DEF1BC703}"/>
+                <a16:creationId xmlns:a16="http://schemas.microsoft.com/office/drawing/2014/main" id="{DB769E86-D7FE-4245-ACA9-3AB4CB3C3CF0}"/>
               </a:ext>
             </a:extLst>
           </p:cNvPr>
@@ -20044,7 +20052,7 @@
           <p:cNvPr id="9" name="">
             <a:extLst xmlns:a="http://schemas.openxmlformats.org/drawingml/2006/main">
               <a:ext uri="{FF2B5EF4-FFF2-40B4-BE49-F238E27FC236}">
-                <a16:creationId xmlns:a16="http://schemas.microsoft.com/office/drawing/2014/main" id="{446A16AC-A0AA-4B8D-88DB-BF33DECB329C}"/>
+                <a16:creationId xmlns:a16="http://schemas.microsoft.com/office/drawing/2014/main" id="{C1026198-64F0-47C2-ACDD-B2C14C2ABFE7}"/>
               </a:ext>
             </a:extLst>
           </p:cNvPr>
@@ -20101,7 +20109,7 @@
           <p:cNvPr id="10" name="">
             <a:extLst xmlns:a="http://schemas.openxmlformats.org/drawingml/2006/main">
               <a:ext uri="{FF2B5EF4-FFF2-40B4-BE49-F238E27FC236}">
-                <a16:creationId xmlns:a16="http://schemas.microsoft.com/office/drawing/2014/main" id="{71A2055B-FEA6-4246-B368-60DF28FAB6A5}"/>
+                <a16:creationId xmlns:a16="http://schemas.microsoft.com/office/drawing/2014/main" id="{D812CB1C-E24A-419F-AFEA-54F94E572965}"/>
               </a:ext>
             </a:extLst>
           </p:cNvPr>
@@ -20134,7 +20142,7 @@
           <p:cNvPr id="11" name="">
             <a:extLst xmlns:a="http://schemas.openxmlformats.org/drawingml/2006/main">
               <a:ext uri="{FF2B5EF4-FFF2-40B4-BE49-F238E27FC236}">
-                <a16:creationId xmlns:a16="http://schemas.microsoft.com/office/drawing/2014/main" id="{EF288AD2-7B27-4CCE-B305-703662380FCB}"/>
+                <a16:creationId xmlns:a16="http://schemas.microsoft.com/office/drawing/2014/main" id="{0E184AF3-B0FC-4C16-BC36-71748397D98F}"/>
               </a:ext>
             </a:extLst>
           </p:cNvPr>
@@ -20169,7 +20177,7 @@
           <p:cNvPr id="12" name="">
             <a:extLst xmlns:a="http://schemas.openxmlformats.org/drawingml/2006/main">
               <a:ext uri="{FF2B5EF4-FFF2-40B4-BE49-F238E27FC236}">
-                <a16:creationId xmlns:a16="http://schemas.microsoft.com/office/drawing/2014/main" id="{F2B31F60-2168-40E6-A215-680B36D4E61D}"/>
+                <a16:creationId xmlns:a16="http://schemas.microsoft.com/office/drawing/2014/main" id="{F2FB686A-B055-44C7-9927-46D33A44CBB9}"/>
               </a:ext>
             </a:extLst>
           </p:cNvPr>
@@ -20226,7 +20234,7 @@
           <p:cNvPr id="13" name="">
             <a:extLst xmlns:a="http://schemas.openxmlformats.org/drawingml/2006/main">
               <a:ext uri="{FF2B5EF4-FFF2-40B4-BE49-F238E27FC236}">
-                <a16:creationId xmlns:a16="http://schemas.microsoft.com/office/drawing/2014/main" id="{5DA5C561-589E-4D50-A8A8-6C2C8BAE18A4}"/>
+                <a16:creationId xmlns:a16="http://schemas.microsoft.com/office/drawing/2014/main" id="{D50EC10D-17C0-4C65-A0CD-822DD8B7E825}"/>
               </a:ext>
             </a:extLst>
           </p:cNvPr>
@@ -20283,7 +20291,7 @@
           <p:cNvPr id="14" name="">
             <a:extLst xmlns:a="http://schemas.openxmlformats.org/drawingml/2006/main">
               <a:ext uri="{FF2B5EF4-FFF2-40B4-BE49-F238E27FC236}">
-                <a16:creationId xmlns:a16="http://schemas.microsoft.com/office/drawing/2014/main" id="{B0C95E8B-5A6A-4091-96E8-9ED8AB982738}"/>
+                <a16:creationId xmlns:a16="http://schemas.microsoft.com/office/drawing/2014/main" id="{B44398AC-3D30-4FF1-AE6D-65544B7D9881}"/>
               </a:ext>
             </a:extLst>
           </p:cNvPr>
@@ -20316,7 +20324,7 @@
           <p:cNvPr id="15" name="">
             <a:extLst xmlns:a="http://schemas.openxmlformats.org/drawingml/2006/main">
               <a:ext uri="{FF2B5EF4-FFF2-40B4-BE49-F238E27FC236}">
-                <a16:creationId xmlns:a16="http://schemas.microsoft.com/office/drawing/2014/main" id="{5AD4D4BA-0531-4E5A-9F79-F93AF40F2AEF}"/>
+                <a16:creationId xmlns:a16="http://schemas.microsoft.com/office/drawing/2014/main" id="{0AF3ECE2-8C08-40B3-8CBA-BCE32BAB16D4}"/>
               </a:ext>
             </a:extLst>
           </p:cNvPr>
@@ -20351,7 +20359,7 @@
           <p:cNvPr id="16" name="">
             <a:extLst xmlns:a="http://schemas.openxmlformats.org/drawingml/2006/main">
               <a:ext uri="{FF2B5EF4-FFF2-40B4-BE49-F238E27FC236}">
-                <a16:creationId xmlns:a16="http://schemas.microsoft.com/office/drawing/2014/main" id="{11FEE33C-B51A-4364-BA4C-C39B2CC8B9A9}"/>
+                <a16:creationId xmlns:a16="http://schemas.microsoft.com/office/drawing/2014/main" id="{17BEDB51-1883-4A17-AF4A-EB621F90FB75}"/>
               </a:ext>
             </a:extLst>
           </p:cNvPr>
@@ -20408,7 +20416,7 @@
           <p:cNvPr id="17" name="">
             <a:extLst xmlns:a="http://schemas.openxmlformats.org/drawingml/2006/main">
               <a:ext uri="{FF2B5EF4-FFF2-40B4-BE49-F238E27FC236}">
-                <a16:creationId xmlns:a16="http://schemas.microsoft.com/office/drawing/2014/main" id="{5C039897-47C5-46D3-ACC9-5E1B31D116A7}"/>
+                <a16:creationId xmlns:a16="http://schemas.microsoft.com/office/drawing/2014/main" id="{6A28354C-DE66-4534-970A-95D99B86A0DB}"/>
               </a:ext>
             </a:extLst>
           </p:cNvPr>
@@ -20465,7 +20473,7 @@
           <p:cNvPr id="18" name="">
             <a:extLst xmlns:a="http://schemas.openxmlformats.org/drawingml/2006/main">
               <a:ext uri="{FF2B5EF4-FFF2-40B4-BE49-F238E27FC236}">
-                <a16:creationId xmlns:a16="http://schemas.microsoft.com/office/drawing/2014/main" id="{BA63F206-DA32-40F6-9404-B211ECFE8D8D}"/>
+                <a16:creationId xmlns:a16="http://schemas.microsoft.com/office/drawing/2014/main" id="{377B889A-1D37-4D03-97EA-11FB55517719}"/>
               </a:ext>
             </a:extLst>
           </p:cNvPr>
@@ -20498,7 +20506,7 @@
           <p:cNvPr id="19" name="">
             <a:extLst xmlns:a="http://schemas.openxmlformats.org/drawingml/2006/main">
               <a:ext uri="{FF2B5EF4-FFF2-40B4-BE49-F238E27FC236}">
-                <a16:creationId xmlns:a16="http://schemas.microsoft.com/office/drawing/2014/main" id="{0F4C883D-E353-43E8-BD8B-924B4FF30B4D}"/>
+                <a16:creationId xmlns:a16="http://schemas.microsoft.com/office/drawing/2014/main" id="{0467AAFE-5DF5-4D42-BA57-2971E0CCCCC9}"/>
               </a:ext>
             </a:extLst>
           </p:cNvPr>
@@ -20533,7 +20541,7 @@
           <p:cNvPr id="20" name="">
             <a:extLst xmlns:a="http://schemas.openxmlformats.org/drawingml/2006/main">
               <a:ext uri="{FF2B5EF4-FFF2-40B4-BE49-F238E27FC236}">
-                <a16:creationId xmlns:a16="http://schemas.microsoft.com/office/drawing/2014/main" id="{5D872797-AA0F-4B16-9E64-2884DD30E14D}"/>
+                <a16:creationId xmlns:a16="http://schemas.microsoft.com/office/drawing/2014/main" id="{9B722BA1-ED56-4D69-A719-1980895F0048}"/>
               </a:ext>
             </a:extLst>
           </p:cNvPr>
@@ -20590,7 +20598,7 @@
           <p:cNvPr id="21" name="">
             <a:extLst xmlns:a="http://schemas.openxmlformats.org/drawingml/2006/main">
               <a:ext uri="{FF2B5EF4-FFF2-40B4-BE49-F238E27FC236}">
-                <a16:creationId xmlns:a16="http://schemas.microsoft.com/office/drawing/2014/main" id="{772420CD-2D66-4FD4-8D8D-DE88BEADAE24}"/>
+                <a16:creationId xmlns:a16="http://schemas.microsoft.com/office/drawing/2014/main" id="{A2828ED5-AD04-44DC-9F8B-912F42634FB9}"/>
               </a:ext>
             </a:extLst>
           </p:cNvPr>
@@ -20647,7 +20655,7 @@
           <p:cNvPr id="22" name="">
             <a:extLst xmlns:a="http://schemas.openxmlformats.org/drawingml/2006/main">
               <a:ext uri="{FF2B5EF4-FFF2-40B4-BE49-F238E27FC236}">
-                <a16:creationId xmlns:a16="http://schemas.microsoft.com/office/drawing/2014/main" id="{0577053B-5B01-45C9-83B8-D5D22B0F2A5D}"/>
+                <a16:creationId xmlns:a16="http://schemas.microsoft.com/office/drawing/2014/main" id="{D8BE3ED1-3BAA-4A15-BA25-BD02A07B0612}"/>
               </a:ext>
             </a:extLst>
           </p:cNvPr>
@@ -20680,7 +20688,7 @@
           <p:cNvPr id="23" name="">
             <a:extLst xmlns:a="http://schemas.openxmlformats.org/drawingml/2006/main">
               <a:ext uri="{FF2B5EF4-FFF2-40B4-BE49-F238E27FC236}">
-                <a16:creationId xmlns:a16="http://schemas.microsoft.com/office/drawing/2014/main" id="{8BCEFEFA-81EA-479A-8C7F-398F3BA0786E}"/>
+                <a16:creationId xmlns:a16="http://schemas.microsoft.com/office/drawing/2014/main" id="{EE336BA5-BEF6-4BA4-BD0A-DA07C86BD6C7}"/>
               </a:ext>
             </a:extLst>
           </p:cNvPr>
@@ -20715,7 +20723,7 @@
           <p:cNvPr id="24" name="">
             <a:extLst xmlns:a="http://schemas.openxmlformats.org/drawingml/2006/main">
               <a:ext uri="{FF2B5EF4-FFF2-40B4-BE49-F238E27FC236}">
-                <a16:creationId xmlns:a16="http://schemas.microsoft.com/office/drawing/2014/main" id="{3BF55C4D-96CF-40C6-85B4-352604AD3778}"/>
+                <a16:creationId xmlns:a16="http://schemas.microsoft.com/office/drawing/2014/main" id="{203D6015-8FE9-4D2D-A360-E933ADC6DC3D}"/>
               </a:ext>
             </a:extLst>
           </p:cNvPr>
@@ -20772,7 +20780,7 @@
           <p:cNvPr id="25" name="">
             <a:extLst xmlns:a="http://schemas.openxmlformats.org/drawingml/2006/main">
               <a:ext uri="{FF2B5EF4-FFF2-40B4-BE49-F238E27FC236}">
-                <a16:creationId xmlns:a16="http://schemas.microsoft.com/office/drawing/2014/main" id="{0CF62069-41DD-4CB8-8D00-2CEE283D58F3}"/>
+                <a16:creationId xmlns:a16="http://schemas.microsoft.com/office/drawing/2014/main" id="{A67BA0BE-70E8-4402-AFA2-94990155DFCA}"/>
               </a:ext>
             </a:extLst>
           </p:cNvPr>
@@ -20829,7 +20837,7 @@
           <p:cNvPr id="26" name="">
             <a:extLst xmlns:a="http://schemas.openxmlformats.org/drawingml/2006/main">
               <a:ext uri="{FF2B5EF4-FFF2-40B4-BE49-F238E27FC236}">
-                <a16:creationId xmlns:a16="http://schemas.microsoft.com/office/drawing/2014/main" id="{0AF689EA-0705-4E9B-BA3A-0A6EB07A2DB4}"/>
+                <a16:creationId xmlns:a16="http://schemas.microsoft.com/office/drawing/2014/main" id="{E894CD30-FA40-474D-9F6F-48A76614EBA0}"/>
               </a:ext>
             </a:extLst>
           </p:cNvPr>
@@ -20860,7 +20868,7 @@
           <p:cNvPr id="27" name="">
             <a:extLst xmlns:a="http://schemas.openxmlformats.org/drawingml/2006/main">
               <a:ext uri="{FF2B5EF4-FFF2-40B4-BE49-F238E27FC236}">
-                <a16:creationId xmlns:a16="http://schemas.microsoft.com/office/drawing/2014/main" id="{B4CD0434-62EE-4156-A494-F15983CA0088}"/>
+                <a16:creationId xmlns:a16="http://schemas.microsoft.com/office/drawing/2014/main" id="{3CEF582B-1EDE-454F-9F6C-CDD5819C863D}"/>
               </a:ext>
             </a:extLst>
           </p:cNvPr>
@@ -20891,7 +20899,7 @@
           <p:cNvPr id="28" name="">
             <a:extLst xmlns:a="http://schemas.openxmlformats.org/drawingml/2006/main">
               <a:ext uri="{FF2B5EF4-FFF2-40B4-BE49-F238E27FC236}">
-                <a16:creationId xmlns:a16="http://schemas.microsoft.com/office/drawing/2014/main" id="{92717B03-DF77-4B3B-B4C8-0A83CFAF7432}"/>
+                <a16:creationId xmlns:a16="http://schemas.microsoft.com/office/drawing/2014/main" id="{2E932D1C-718F-4013-AAE5-0CC95B8AF682}"/>
               </a:ext>
             </a:extLst>
           </p:cNvPr>
@@ -20946,7 +20954,7 @@
     </p:spTree>
     <p:extLst>
       <p:ext uri="{BB962C8B-B14F-4D97-AF65-F5344CB8AC3E}">
-        <p14:creationId xmlns:p14="http://schemas.microsoft.com/office/powerpoint/2010/main" val="40618132"/>
+        <p14:creationId xmlns:p14="http://schemas.microsoft.com/office/powerpoint/2010/main" val="744319097"/>
       </p:ext>
     </p:extLst>
   </p:cSld>
@@ -20977,7 +20985,7 @@
           <p:cNvPr id="18" name="">
             <a:extLst xmlns:a="http://schemas.openxmlformats.org/drawingml/2006/main">
               <a:ext uri="{FF2B5EF4-FFF2-40B4-BE49-F238E27FC236}">
-                <a16:creationId xmlns:a16="http://schemas.microsoft.com/office/drawing/2014/main" id="{06333ABA-F77B-45BE-BF72-7DB4F3F52A86}"/>
+                <a16:creationId xmlns:a16="http://schemas.microsoft.com/office/drawing/2014/main" id="{8816110D-E88E-4A5D-9616-BD434C6FC1BC}"/>
               </a:ext>
             </a:extLst>
           </p:cNvPr>
@@ -21008,7 +21016,7 @@
           <p:cNvPr id="2" name="">
             <a:extLst xmlns:a="http://schemas.openxmlformats.org/drawingml/2006/main">
               <a:ext uri="{FF2B5EF4-FFF2-40B4-BE49-F238E27FC236}">
-                <a16:creationId xmlns:a16="http://schemas.microsoft.com/office/drawing/2014/main" id="{5E20A7AD-6CE5-40BF-B850-613847C13542}"/>
+                <a16:creationId xmlns:a16="http://schemas.microsoft.com/office/drawing/2014/main" id="{FFD4B74D-26D4-4E04-B8C8-67DEC11878E7}"/>
               </a:ext>
             </a:extLst>
           </p:cNvPr>
@@ -21039,7 +21047,7 @@
           <p:cNvPr id="3" name="">
             <a:extLst xmlns:a="http://schemas.openxmlformats.org/drawingml/2006/main">
               <a:ext uri="{FF2B5EF4-FFF2-40B4-BE49-F238E27FC236}">
-                <a16:creationId xmlns:a16="http://schemas.microsoft.com/office/drawing/2014/main" id="{A281BE44-9605-4C25-BB12-456B03C79036}"/>
+                <a16:creationId xmlns:a16="http://schemas.microsoft.com/office/drawing/2014/main" id="{1079D922-C398-4C6F-9A30-348E0FAD6D87}"/>
               </a:ext>
             </a:extLst>
           </p:cNvPr>
@@ -21096,7 +21104,7 @@
           <p:cNvPr id="4" name="">
             <a:extLst xmlns:a="http://schemas.openxmlformats.org/drawingml/2006/main">
               <a:ext uri="{FF2B5EF4-FFF2-40B4-BE49-F238E27FC236}">
-                <a16:creationId xmlns:a16="http://schemas.microsoft.com/office/drawing/2014/main" id="{BD99322A-792C-4D94-A46C-6864B70AD103}"/>
+                <a16:creationId xmlns:a16="http://schemas.microsoft.com/office/drawing/2014/main" id="{16A49C20-955F-440A-B69A-5F7B77B090C6}"/>
               </a:ext>
             </a:extLst>
           </p:cNvPr>
@@ -21153,7 +21161,7 @@
           <p:cNvPr id="5" name="">
             <a:extLst xmlns:a="http://schemas.openxmlformats.org/drawingml/2006/main">
               <a:ext uri="{FF2B5EF4-FFF2-40B4-BE49-F238E27FC236}">
-                <a16:creationId xmlns:a16="http://schemas.microsoft.com/office/drawing/2014/main" id="{E3FEB58A-D3AF-4837-83F3-5AE99AF24274}"/>
+                <a16:creationId xmlns:a16="http://schemas.microsoft.com/office/drawing/2014/main" id="{90552064-CA51-438E-A8B4-9DE48F08B8EB}"/>
               </a:ext>
             </a:extLst>
           </p:cNvPr>
@@ -21210,7 +21218,7 @@
           <p:cNvPr id="6" name="">
             <a:extLst xmlns:a="http://schemas.openxmlformats.org/drawingml/2006/main">
               <a:ext uri="{FF2B5EF4-FFF2-40B4-BE49-F238E27FC236}">
-                <a16:creationId xmlns:a16="http://schemas.microsoft.com/office/drawing/2014/main" id="{58190490-4169-40B9-9168-1DBF55A8AC2D}"/>
+                <a16:creationId xmlns:a16="http://schemas.microsoft.com/office/drawing/2014/main" id="{6C77F1D8-71EC-4E75-8845-3AB128469893}"/>
               </a:ext>
             </a:extLst>
           </p:cNvPr>
@@ -21267,7 +21275,7 @@
           <p:cNvPr id="7" name="">
             <a:extLst xmlns:a="http://schemas.openxmlformats.org/drawingml/2006/main">
               <a:ext uri="{FF2B5EF4-FFF2-40B4-BE49-F238E27FC236}">
-                <a16:creationId xmlns:a16="http://schemas.microsoft.com/office/drawing/2014/main" id="{24DD768C-D7D9-4601-A073-29A2370919BF}"/>
+                <a16:creationId xmlns:a16="http://schemas.microsoft.com/office/drawing/2014/main" id="{691B51CD-2DCF-43FD-AAC0-3A29CDB97641}"/>
               </a:ext>
             </a:extLst>
           </p:cNvPr>
@@ -21300,7 +21308,7 @@
           <p:cNvPr id="8" name="">
             <a:extLst xmlns:a="http://schemas.openxmlformats.org/drawingml/2006/main">
               <a:ext uri="{FF2B5EF4-FFF2-40B4-BE49-F238E27FC236}">
-                <a16:creationId xmlns:a16="http://schemas.microsoft.com/office/drawing/2014/main" id="{60338EC4-EEEA-4618-9A6B-714139492576}"/>
+                <a16:creationId xmlns:a16="http://schemas.microsoft.com/office/drawing/2014/main" id="{A8E57FA0-9CEB-413D-8D7E-5EF3CBCC7AF5}"/>
               </a:ext>
             </a:extLst>
           </p:cNvPr>
@@ -21335,7 +21343,7 @@
           <p:cNvPr id="9" name="">
             <a:extLst xmlns:a="http://schemas.openxmlformats.org/drawingml/2006/main">
               <a:ext uri="{FF2B5EF4-FFF2-40B4-BE49-F238E27FC236}">
-                <a16:creationId xmlns:a16="http://schemas.microsoft.com/office/drawing/2014/main" id="{E360DEFB-2297-4EDA-A5AF-82DB33B5BEB7}"/>
+                <a16:creationId xmlns:a16="http://schemas.microsoft.com/office/drawing/2014/main" id="{213CA95D-C5EB-4B34-A3B0-F890D44B8449}"/>
               </a:ext>
             </a:extLst>
           </p:cNvPr>
@@ -21392,7 +21400,7 @@
           <p:cNvPr id="10" name="">
             <a:extLst xmlns:a="http://schemas.openxmlformats.org/drawingml/2006/main">
               <a:ext uri="{FF2B5EF4-FFF2-40B4-BE49-F238E27FC236}">
-                <a16:creationId xmlns:a16="http://schemas.microsoft.com/office/drawing/2014/main" id="{AA3F39CB-CE56-4DF4-9666-0421D8C35C66}"/>
+                <a16:creationId xmlns:a16="http://schemas.microsoft.com/office/drawing/2014/main" id="{02DD70F6-6F9A-4F8C-972E-F5F436D0D75B}"/>
               </a:ext>
             </a:extLst>
           </p:cNvPr>
@@ -21449,7 +21457,7 @@
           <p:cNvPr id="11" name="">
             <a:extLst xmlns:a="http://schemas.openxmlformats.org/drawingml/2006/main">
               <a:ext uri="{FF2B5EF4-FFF2-40B4-BE49-F238E27FC236}">
-                <a16:creationId xmlns:a16="http://schemas.microsoft.com/office/drawing/2014/main" id="{48FF77A9-006A-4DDB-91A7-8270E8A851A8}"/>
+                <a16:creationId xmlns:a16="http://schemas.microsoft.com/office/drawing/2014/main" id="{9954BFBF-7B72-4273-A3E3-C0626C3E55DF}"/>
               </a:ext>
             </a:extLst>
           </p:cNvPr>
@@ -21482,7 +21490,7 @@
           <p:cNvPr id="12" name="">
             <a:extLst xmlns:a="http://schemas.openxmlformats.org/drawingml/2006/main">
               <a:ext uri="{FF2B5EF4-FFF2-40B4-BE49-F238E27FC236}">
-                <a16:creationId xmlns:a16="http://schemas.microsoft.com/office/drawing/2014/main" id="{D2F7D238-EA4F-42D6-AFAA-A5F305F15A4C}"/>
+                <a16:creationId xmlns:a16="http://schemas.microsoft.com/office/drawing/2014/main" id="{839E8043-D57E-4A40-BFBD-BA5D6565D1A8}"/>
               </a:ext>
             </a:extLst>
           </p:cNvPr>
@@ -21517,7 +21525,7 @@
           <p:cNvPr id="13" name="">
             <a:extLst xmlns:a="http://schemas.openxmlformats.org/drawingml/2006/main">
               <a:ext uri="{FF2B5EF4-FFF2-40B4-BE49-F238E27FC236}">
-                <a16:creationId xmlns:a16="http://schemas.microsoft.com/office/drawing/2014/main" id="{E3D73D0E-77DC-4F6C-B6B3-A10E54D51409}"/>
+                <a16:creationId xmlns:a16="http://schemas.microsoft.com/office/drawing/2014/main" id="{09CBF631-4D9E-42F3-9314-DF1F5FCC7918}"/>
               </a:ext>
             </a:extLst>
           </p:cNvPr>
@@ -21574,7 +21582,7 @@
           <p:cNvPr id="14" name="">
             <a:extLst xmlns:a="http://schemas.openxmlformats.org/drawingml/2006/main">
               <a:ext uri="{FF2B5EF4-FFF2-40B4-BE49-F238E27FC236}">
-                <a16:creationId xmlns:a16="http://schemas.microsoft.com/office/drawing/2014/main" id="{5A3FA6D4-4CE7-4278-AD12-3DFFA77C61E8}"/>
+                <a16:creationId xmlns:a16="http://schemas.microsoft.com/office/drawing/2014/main" id="{6B5AC95B-D91E-412E-B99B-3BD90C760666}"/>
               </a:ext>
             </a:extLst>
           </p:cNvPr>
@@ -21631,7 +21639,7 @@
           <p:cNvPr id="15" name="">
             <a:extLst xmlns:a="http://schemas.openxmlformats.org/drawingml/2006/main">
               <a:ext uri="{FF2B5EF4-FFF2-40B4-BE49-F238E27FC236}">
-                <a16:creationId xmlns:a16="http://schemas.microsoft.com/office/drawing/2014/main" id="{25D44C4B-E883-46E7-966C-AEB98B705CF6}"/>
+                <a16:creationId xmlns:a16="http://schemas.microsoft.com/office/drawing/2014/main" id="{54B8B3AB-F1A9-4A7F-BAC3-AC4DB46A846B}"/>
               </a:ext>
             </a:extLst>
           </p:cNvPr>
@@ -21662,7 +21670,7 @@
           <p:cNvPr id="16" name="">
             <a:extLst xmlns:a="http://schemas.openxmlformats.org/drawingml/2006/main">
               <a:ext uri="{FF2B5EF4-FFF2-40B4-BE49-F238E27FC236}">
-                <a16:creationId xmlns:a16="http://schemas.microsoft.com/office/drawing/2014/main" id="{A05E4FF7-3560-46A9-9CFF-660DD8027FB5}"/>
+                <a16:creationId xmlns:a16="http://schemas.microsoft.com/office/drawing/2014/main" id="{E2ACFAE2-BD18-4C11-8085-88ABB0580BF8}"/>
               </a:ext>
             </a:extLst>
           </p:cNvPr>
@@ -21719,7 +21727,7 @@
           <p:cNvPr id="17" name="">
             <a:extLst xmlns:a="http://schemas.openxmlformats.org/drawingml/2006/main">
               <a:ext uri="{FF2B5EF4-FFF2-40B4-BE49-F238E27FC236}">
-                <a16:creationId xmlns:a16="http://schemas.microsoft.com/office/drawing/2014/main" id="{915852D9-CED3-4502-8F98-B690CC894A2D}"/>
+                <a16:creationId xmlns:a16="http://schemas.microsoft.com/office/drawing/2014/main" id="{F45F4336-99F7-4477-9126-4510786B826C}"/>
               </a:ext>
             </a:extLst>
           </p:cNvPr>
@@ -21774,7 +21782,7 @@
     </p:spTree>
     <p:extLst>
       <p:ext uri="{BB962C8B-B14F-4D97-AF65-F5344CB8AC3E}">
-        <p14:creationId xmlns:p14="http://schemas.microsoft.com/office/powerpoint/2010/main" val="999595923"/>
+        <p14:creationId xmlns:p14="http://schemas.microsoft.com/office/powerpoint/2010/main" val="447713480"/>
       </p:ext>
     </p:extLst>
   </p:cSld>
@@ -21805,7 +21813,7 @@
           <p:cNvPr id="20" name="">
             <a:extLst xmlns:a="http://schemas.openxmlformats.org/drawingml/2006/main">
               <a:ext uri="{FF2B5EF4-FFF2-40B4-BE49-F238E27FC236}">
-                <a16:creationId xmlns:a16="http://schemas.microsoft.com/office/drawing/2014/main" id="{32492E1A-10D3-43B2-9DC6-59E3E0A0AE32}"/>
+                <a16:creationId xmlns:a16="http://schemas.microsoft.com/office/drawing/2014/main" id="{1958DAB7-8049-4B64-830B-BD901E6DD878}"/>
               </a:ext>
             </a:extLst>
           </p:cNvPr>
@@ -21836,7 +21844,7 @@
           <p:cNvPr id="2" name="">
             <a:extLst xmlns:a="http://schemas.openxmlformats.org/drawingml/2006/main">
               <a:ext uri="{FF2B5EF4-FFF2-40B4-BE49-F238E27FC236}">
-                <a16:creationId xmlns:a16="http://schemas.microsoft.com/office/drawing/2014/main" id="{05106221-BCF3-4F75-8E0E-D7B531D2780B}"/>
+                <a16:creationId xmlns:a16="http://schemas.microsoft.com/office/drawing/2014/main" id="{91FFD914-FACE-4482-8CB8-98ADE2A05AC3}"/>
               </a:ext>
             </a:extLst>
           </p:cNvPr>
@@ -21867,7 +21875,7 @@
           <p:cNvPr id="3" name="">
             <a:extLst xmlns:a="http://schemas.openxmlformats.org/drawingml/2006/main">
               <a:ext uri="{FF2B5EF4-FFF2-40B4-BE49-F238E27FC236}">
-                <a16:creationId xmlns:a16="http://schemas.microsoft.com/office/drawing/2014/main" id="{A8513024-95E4-458A-AF0B-58DD1612C0D5}"/>
+                <a16:creationId xmlns:a16="http://schemas.microsoft.com/office/drawing/2014/main" id="{2BB717A2-4E98-4015-A699-B130990AC588}"/>
               </a:ext>
             </a:extLst>
           </p:cNvPr>
@@ -21924,7 +21932,7 @@
           <p:cNvPr id="4" name="">
             <a:extLst xmlns:a="http://schemas.openxmlformats.org/drawingml/2006/main">
               <a:ext uri="{FF2B5EF4-FFF2-40B4-BE49-F238E27FC236}">
-                <a16:creationId xmlns:a16="http://schemas.microsoft.com/office/drawing/2014/main" id="{3E673D44-B8AA-4535-88FA-B09E7F7F4AE9}"/>
+                <a16:creationId xmlns:a16="http://schemas.microsoft.com/office/drawing/2014/main" id="{D4A5CE1D-22BC-4AC8-8C01-64E913383811}"/>
               </a:ext>
             </a:extLst>
           </p:cNvPr>
@@ -21981,7 +21989,7 @@
           <p:cNvPr id="5" name="">
             <a:extLst xmlns:a="http://schemas.openxmlformats.org/drawingml/2006/main">
               <a:ext uri="{FF2B5EF4-FFF2-40B4-BE49-F238E27FC236}">
-                <a16:creationId xmlns:a16="http://schemas.microsoft.com/office/drawing/2014/main" id="{13B4F7DF-079E-4C16-95B3-97097D806AAD}"/>
+                <a16:creationId xmlns:a16="http://schemas.microsoft.com/office/drawing/2014/main" id="{6E36F8BC-98A5-4AA4-96D2-B6F31C832F64}"/>
               </a:ext>
             </a:extLst>
           </p:cNvPr>
@@ -22014,7 +22022,7 @@
           <p:cNvPr id="6" name="">
             <a:extLst xmlns:a="http://schemas.openxmlformats.org/drawingml/2006/main">
               <a:ext uri="{FF2B5EF4-FFF2-40B4-BE49-F238E27FC236}">
-                <a16:creationId xmlns:a16="http://schemas.microsoft.com/office/drawing/2014/main" id="{31E7E2B7-1991-437C-99FB-B76DC0947925}"/>
+                <a16:creationId xmlns:a16="http://schemas.microsoft.com/office/drawing/2014/main" id="{6CD0FA9F-353C-4042-B977-0EB7D24DBDD1}"/>
               </a:ext>
             </a:extLst>
           </p:cNvPr>
@@ -22049,7 +22057,7 @@
           <p:cNvPr id="7" name="">
             <a:extLst xmlns:a="http://schemas.openxmlformats.org/drawingml/2006/main">
               <a:ext uri="{FF2B5EF4-FFF2-40B4-BE49-F238E27FC236}">
-                <a16:creationId xmlns:a16="http://schemas.microsoft.com/office/drawing/2014/main" id="{2B8BDEA3-C7EB-47AD-B321-773FDCA9D705}"/>
+                <a16:creationId xmlns:a16="http://schemas.microsoft.com/office/drawing/2014/main" id="{170A5974-25CB-4F40-88A5-517C2AF18101}"/>
               </a:ext>
             </a:extLst>
           </p:cNvPr>
@@ -22106,7 +22114,7 @@
           <p:cNvPr id="8" name="">
             <a:extLst xmlns:a="http://schemas.openxmlformats.org/drawingml/2006/main">
               <a:ext uri="{FF2B5EF4-FFF2-40B4-BE49-F238E27FC236}">
-                <a16:creationId xmlns:a16="http://schemas.microsoft.com/office/drawing/2014/main" id="{DDA1BE05-3EB3-4D66-9187-6EE180000E70}"/>
+                <a16:creationId xmlns:a16="http://schemas.microsoft.com/office/drawing/2014/main" id="{C0CD09AE-7446-4A6B-AE94-E987EF1D96E3}"/>
               </a:ext>
             </a:extLst>
           </p:cNvPr>
@@ -22163,7 +22171,7 @@
           <p:cNvPr id="9" name="">
             <a:extLst xmlns:a="http://schemas.openxmlformats.org/drawingml/2006/main">
               <a:ext uri="{FF2B5EF4-FFF2-40B4-BE49-F238E27FC236}">
-                <a16:creationId xmlns:a16="http://schemas.microsoft.com/office/drawing/2014/main" id="{C8FAA9D5-E1D0-4DEE-ADB9-7F21EC855FB9}"/>
+                <a16:creationId xmlns:a16="http://schemas.microsoft.com/office/drawing/2014/main" id="{5C0E4659-1CF4-4900-B36A-CAF2CC784A3F}"/>
               </a:ext>
             </a:extLst>
           </p:cNvPr>
@@ -22220,7 +22228,7 @@
           <p:cNvPr id="10" name="">
             <a:extLst xmlns:a="http://schemas.openxmlformats.org/drawingml/2006/main">
               <a:ext uri="{FF2B5EF4-FFF2-40B4-BE49-F238E27FC236}">
-                <a16:creationId xmlns:a16="http://schemas.microsoft.com/office/drawing/2014/main" id="{88AAA09E-C46B-464F-89FF-DAF7460452CC}"/>
+                <a16:creationId xmlns:a16="http://schemas.microsoft.com/office/drawing/2014/main" id="{F51593FC-FBC7-43C5-917D-9EF43B8C84DF}"/>
               </a:ext>
             </a:extLst>
           </p:cNvPr>
@@ -22253,7 +22261,7 @@
           <p:cNvPr id="11" name="">
             <a:extLst xmlns:a="http://schemas.openxmlformats.org/drawingml/2006/main">
               <a:ext uri="{FF2B5EF4-FFF2-40B4-BE49-F238E27FC236}">
-                <a16:creationId xmlns:a16="http://schemas.microsoft.com/office/drawing/2014/main" id="{59C24507-1119-4A7B-AA84-3B2C18245720}"/>
+                <a16:creationId xmlns:a16="http://schemas.microsoft.com/office/drawing/2014/main" id="{9FF554C5-3572-4C7A-A2B8-D6D5DD6B80D2}"/>
               </a:ext>
             </a:extLst>
           </p:cNvPr>
@@ -22288,7 +22296,7 @@
           <p:cNvPr id="12" name="">
             <a:extLst xmlns:a="http://schemas.openxmlformats.org/drawingml/2006/main">
               <a:ext uri="{FF2B5EF4-FFF2-40B4-BE49-F238E27FC236}">
-                <a16:creationId xmlns:a16="http://schemas.microsoft.com/office/drawing/2014/main" id="{94048588-D8EA-4F7D-897F-98017ECD8DE7}"/>
+                <a16:creationId xmlns:a16="http://schemas.microsoft.com/office/drawing/2014/main" id="{24199A7F-5ECA-401D-9948-475540ADDAC1}"/>
               </a:ext>
             </a:extLst>
           </p:cNvPr>
@@ -22345,7 +22353,7 @@
           <p:cNvPr id="13" name="">
             <a:extLst xmlns:a="http://schemas.openxmlformats.org/drawingml/2006/main">
               <a:ext uri="{FF2B5EF4-FFF2-40B4-BE49-F238E27FC236}">
-                <a16:creationId xmlns:a16="http://schemas.microsoft.com/office/drawing/2014/main" id="{61723F56-6E04-446F-B0FF-5734C528880E}"/>
+                <a16:creationId xmlns:a16="http://schemas.microsoft.com/office/drawing/2014/main" id="{D88A671F-DFFC-44F2-B8F3-F64F726CFFD6}"/>
               </a:ext>
             </a:extLst>
           </p:cNvPr>
@@ -22402,7 +22410,7 @@
           <p:cNvPr id="14" name="">
             <a:extLst xmlns:a="http://schemas.openxmlformats.org/drawingml/2006/main">
               <a:ext uri="{FF2B5EF4-FFF2-40B4-BE49-F238E27FC236}">
-                <a16:creationId xmlns:a16="http://schemas.microsoft.com/office/drawing/2014/main" id="{9396B404-BBF7-47E8-B8E4-346B2B096CDB}"/>
+                <a16:creationId xmlns:a16="http://schemas.microsoft.com/office/drawing/2014/main" id="{914C448A-22E5-4C0C-9CA8-8EFD41CE42DD}"/>
               </a:ext>
             </a:extLst>
           </p:cNvPr>
@@ -22459,7 +22467,7 @@
           <p:cNvPr id="15" name="">
             <a:extLst xmlns:a="http://schemas.openxmlformats.org/drawingml/2006/main">
               <a:ext uri="{FF2B5EF4-FFF2-40B4-BE49-F238E27FC236}">
-                <a16:creationId xmlns:a16="http://schemas.microsoft.com/office/drawing/2014/main" id="{41D85A0D-A027-43CA-A7A0-F33241CD78E2}"/>
+                <a16:creationId xmlns:a16="http://schemas.microsoft.com/office/drawing/2014/main" id="{A61F1E4B-2CE3-4DC2-86B1-8FD109ADE8B9}"/>
               </a:ext>
             </a:extLst>
           </p:cNvPr>
@@ -22516,7 +22524,7 @@
           <p:cNvPr id="16" name="">
             <a:extLst xmlns:a="http://schemas.openxmlformats.org/drawingml/2006/main">
               <a:ext uri="{FF2B5EF4-FFF2-40B4-BE49-F238E27FC236}">
-                <a16:creationId xmlns:a16="http://schemas.microsoft.com/office/drawing/2014/main" id="{A2BACBDD-13B3-490D-BDC6-A627C5CBB4E5}"/>
+                <a16:creationId xmlns:a16="http://schemas.microsoft.com/office/drawing/2014/main" id="{115CF84C-D1DA-4A15-ACAE-98DBFC020A22}"/>
               </a:ext>
             </a:extLst>
           </p:cNvPr>
@@ -22573,7 +22581,7 @@
           <p:cNvPr id="17" name="">
             <a:extLst xmlns:a="http://schemas.openxmlformats.org/drawingml/2006/main">
               <a:ext uri="{FF2B5EF4-FFF2-40B4-BE49-F238E27FC236}">
-                <a16:creationId xmlns:a16="http://schemas.microsoft.com/office/drawing/2014/main" id="{457CAE1C-C21F-4E4F-AA5E-D98C246AFE96}"/>
+                <a16:creationId xmlns:a16="http://schemas.microsoft.com/office/drawing/2014/main" id="{949052BF-77C1-4DDC-9FBC-13BCD616B8F4}"/>
               </a:ext>
             </a:extLst>
           </p:cNvPr>
@@ -22606,7 +22614,7 @@
           <p:cNvPr id="18" name="">
             <a:extLst xmlns:a="http://schemas.openxmlformats.org/drawingml/2006/main">
               <a:ext uri="{FF2B5EF4-FFF2-40B4-BE49-F238E27FC236}">
-                <a16:creationId xmlns:a16="http://schemas.microsoft.com/office/drawing/2014/main" id="{C36D1D2A-CBBF-4283-B4CF-5D5A0BFED3DC}"/>
+                <a16:creationId xmlns:a16="http://schemas.microsoft.com/office/drawing/2014/main" id="{DB99804A-E922-4A6A-AFD6-5C10804D5A64}"/>
               </a:ext>
             </a:extLst>
           </p:cNvPr>
@@ -22663,7 +22671,7 @@
           <p:cNvPr id="19" name="">
             <a:extLst xmlns:a="http://schemas.openxmlformats.org/drawingml/2006/main">
               <a:ext uri="{FF2B5EF4-FFF2-40B4-BE49-F238E27FC236}">
-                <a16:creationId xmlns:a16="http://schemas.microsoft.com/office/drawing/2014/main" id="{11705E18-518F-4FB0-B159-BD71879229E7}"/>
+                <a16:creationId xmlns:a16="http://schemas.microsoft.com/office/drawing/2014/main" id="{AF8D281C-6CCE-4C8D-83B0-FFF64440F913}"/>
               </a:ext>
             </a:extLst>
           </p:cNvPr>
@@ -22718,7 +22726,7 @@
     </p:spTree>
     <p:extLst>
       <p:ext uri="{BB962C8B-B14F-4D97-AF65-F5344CB8AC3E}">
-        <p14:creationId xmlns:p14="http://schemas.microsoft.com/office/powerpoint/2010/main" val="1985438366"/>
+        <p14:creationId xmlns:p14="http://schemas.microsoft.com/office/powerpoint/2010/main" val="650828320"/>
       </p:ext>
     </p:extLst>
   </p:cSld>
@@ -22749,7 +22757,7 @@
           <p:cNvPr id="42" name="">
             <a:extLst xmlns:a="http://schemas.openxmlformats.org/drawingml/2006/main">
               <a:ext uri="{FF2B5EF4-FFF2-40B4-BE49-F238E27FC236}">
-                <a16:creationId xmlns:a16="http://schemas.microsoft.com/office/drawing/2014/main" id="{1CF97B0A-7C3F-4665-B58F-743FB46AAD5E}"/>
+                <a16:creationId xmlns:a16="http://schemas.microsoft.com/office/drawing/2014/main" id="{CB34F50F-5041-4477-B7B5-0CC0E0AD2760}"/>
               </a:ext>
             </a:extLst>
           </p:cNvPr>
@@ -22780,7 +22788,7 @@
           <p:cNvPr id="2" name="">
             <a:extLst xmlns:a="http://schemas.openxmlformats.org/drawingml/2006/main">
               <a:ext uri="{FF2B5EF4-FFF2-40B4-BE49-F238E27FC236}">
-                <a16:creationId xmlns:a16="http://schemas.microsoft.com/office/drawing/2014/main" id="{AAB9E726-84CC-4723-906E-E2E28E1CB4F7}"/>
+                <a16:creationId xmlns:a16="http://schemas.microsoft.com/office/drawing/2014/main" id="{71426331-4D86-450E-BE09-82A81BB648D8}"/>
               </a:ext>
             </a:extLst>
           </p:cNvPr>
@@ -22811,7 +22819,7 @@
           <p:cNvPr id="3" name="">
             <a:extLst xmlns:a="http://schemas.openxmlformats.org/drawingml/2006/main">
               <a:ext uri="{FF2B5EF4-FFF2-40B4-BE49-F238E27FC236}">
-                <a16:creationId xmlns:a16="http://schemas.microsoft.com/office/drawing/2014/main" id="{61DF39A3-ACD1-436B-A9D9-D7415548EE25}"/>
+                <a16:creationId xmlns:a16="http://schemas.microsoft.com/office/drawing/2014/main" id="{D1EFABD1-B690-4A4A-ABA5-AC7FE8124900}"/>
               </a:ext>
             </a:extLst>
           </p:cNvPr>
@@ -22868,7 +22876,7 @@
           <p:cNvPr id="4" name="">
             <a:extLst xmlns:a="http://schemas.openxmlformats.org/drawingml/2006/main">
               <a:ext uri="{FF2B5EF4-FFF2-40B4-BE49-F238E27FC236}">
-                <a16:creationId xmlns:a16="http://schemas.microsoft.com/office/drawing/2014/main" id="{95EF6E37-8AA8-46EC-BE42-FA1E3A2C80AC}"/>
+                <a16:creationId xmlns:a16="http://schemas.microsoft.com/office/drawing/2014/main" id="{8C84149D-FE7D-46CD-B4DA-54DECF44E558}"/>
               </a:ext>
             </a:extLst>
           </p:cNvPr>
@@ -22925,7 +22933,7 @@
           <p:cNvPr id="5" name="">
             <a:extLst xmlns:a="http://schemas.openxmlformats.org/drawingml/2006/main">
               <a:ext uri="{FF2B5EF4-FFF2-40B4-BE49-F238E27FC236}">
-                <a16:creationId xmlns:a16="http://schemas.microsoft.com/office/drawing/2014/main" id="{21FCFAE7-3395-4927-9C2F-769BA9495403}"/>
+                <a16:creationId xmlns:a16="http://schemas.microsoft.com/office/drawing/2014/main" id="{E4A32A0C-C194-4752-857F-414BC52D17B4}"/>
               </a:ext>
             </a:extLst>
           </p:cNvPr>
@@ -22958,7 +22966,7 @@
           <p:cNvPr id="6" name="">
             <a:extLst xmlns:a="http://schemas.openxmlformats.org/drawingml/2006/main">
               <a:ext uri="{FF2B5EF4-FFF2-40B4-BE49-F238E27FC236}">
-                <a16:creationId xmlns:a16="http://schemas.microsoft.com/office/drawing/2014/main" id="{49FAF39C-38B5-4675-AAC8-B01E55200BF6}"/>
+                <a16:creationId xmlns:a16="http://schemas.microsoft.com/office/drawing/2014/main" id="{39ACE7F1-535D-4356-BCBE-18DBB56A680C}"/>
               </a:ext>
             </a:extLst>
           </p:cNvPr>
@@ -22993,7 +23001,7 @@
           <p:cNvPr id="7" name="">
             <a:extLst xmlns:a="http://schemas.openxmlformats.org/drawingml/2006/main">
               <a:ext uri="{FF2B5EF4-FFF2-40B4-BE49-F238E27FC236}">
-                <a16:creationId xmlns:a16="http://schemas.microsoft.com/office/drawing/2014/main" id="{F56E8760-57C4-41BB-B79E-24B5EE477579}"/>
+                <a16:creationId xmlns:a16="http://schemas.microsoft.com/office/drawing/2014/main" id="{8A2B7ADD-F349-4B9F-9D01-641773415756}"/>
               </a:ext>
             </a:extLst>
           </p:cNvPr>
@@ -23050,7 +23058,7 @@
           <p:cNvPr id="8" name="">
             <a:extLst xmlns:a="http://schemas.openxmlformats.org/drawingml/2006/main">
               <a:ext uri="{FF2B5EF4-FFF2-40B4-BE49-F238E27FC236}">
-                <a16:creationId xmlns:a16="http://schemas.microsoft.com/office/drawing/2014/main" id="{2D7402BD-CB6D-4DB5-9975-2496E62B1F39}"/>
+                <a16:creationId xmlns:a16="http://schemas.microsoft.com/office/drawing/2014/main" id="{48C0BE12-DB0C-4B54-A547-A90482A70DE5}"/>
               </a:ext>
             </a:extLst>
           </p:cNvPr>
@@ -23107,7 +23115,7 @@
           <p:cNvPr id="9" name="">
             <a:extLst xmlns:a="http://schemas.openxmlformats.org/drawingml/2006/main">
               <a:ext uri="{FF2B5EF4-FFF2-40B4-BE49-F238E27FC236}">
-                <a16:creationId xmlns:a16="http://schemas.microsoft.com/office/drawing/2014/main" id="{2D6AE657-6F6E-45AE-8166-AF352CF1630E}"/>
+                <a16:creationId xmlns:a16="http://schemas.microsoft.com/office/drawing/2014/main" id="{AEA243A0-C25A-4FCD-B481-FD2F663946A2}"/>
               </a:ext>
             </a:extLst>
           </p:cNvPr>
@@ -23140,7 +23148,7 @@
           <p:cNvPr id="10" name="">
             <a:extLst xmlns:a="http://schemas.openxmlformats.org/drawingml/2006/main">
               <a:ext uri="{FF2B5EF4-FFF2-40B4-BE49-F238E27FC236}">
-                <a16:creationId xmlns:a16="http://schemas.microsoft.com/office/drawing/2014/main" id="{CAFE3474-3AAF-445B-B37C-734819BB6528}"/>
+                <a16:creationId xmlns:a16="http://schemas.microsoft.com/office/drawing/2014/main" id="{CD21D020-4446-44CA-995C-1071FBCE5A55}"/>
               </a:ext>
             </a:extLst>
           </p:cNvPr>
@@ -23175,7 +23183,7 @@
           <p:cNvPr id="11" name="">
             <a:extLst xmlns:a="http://schemas.openxmlformats.org/drawingml/2006/main">
               <a:ext uri="{FF2B5EF4-FFF2-40B4-BE49-F238E27FC236}">
-                <a16:creationId xmlns:a16="http://schemas.microsoft.com/office/drawing/2014/main" id="{DDB1F4EC-972F-4BA3-AEA5-7440D55C1F51}"/>
+                <a16:creationId xmlns:a16="http://schemas.microsoft.com/office/drawing/2014/main" id="{0B3B0984-D1F7-4B6F-96B4-4D36BFFA5946}"/>
               </a:ext>
             </a:extLst>
           </p:cNvPr>
@@ -23232,7 +23240,7 @@
           <p:cNvPr id="12" name="">
             <a:extLst xmlns:a="http://schemas.openxmlformats.org/drawingml/2006/main">
               <a:ext uri="{FF2B5EF4-FFF2-40B4-BE49-F238E27FC236}">
-                <a16:creationId xmlns:a16="http://schemas.microsoft.com/office/drawing/2014/main" id="{33304494-50A6-4E74-8B3A-09297F7F47AB}"/>
+                <a16:creationId xmlns:a16="http://schemas.microsoft.com/office/drawing/2014/main" id="{8E091701-25C0-44E0-B27C-BB6914280C56}"/>
               </a:ext>
             </a:extLst>
           </p:cNvPr>
@@ -23289,7 +23297,7 @@
           <p:cNvPr id="13" name="">
             <a:extLst xmlns:a="http://schemas.openxmlformats.org/drawingml/2006/main">
               <a:ext uri="{FF2B5EF4-FFF2-40B4-BE49-F238E27FC236}">
-                <a16:creationId xmlns:a16="http://schemas.microsoft.com/office/drawing/2014/main" id="{5DA80B22-3A4E-4A06-802D-E40A3687DDB1}"/>
+                <a16:creationId xmlns:a16="http://schemas.microsoft.com/office/drawing/2014/main" id="{647F507A-1DC4-4335-A9A5-112A9E38B199}"/>
               </a:ext>
             </a:extLst>
           </p:cNvPr>
@@ -23322,7 +23330,7 @@
           <p:cNvPr id="14" name="">
             <a:extLst xmlns:a="http://schemas.openxmlformats.org/drawingml/2006/main">
               <a:ext uri="{FF2B5EF4-FFF2-40B4-BE49-F238E27FC236}">
-                <a16:creationId xmlns:a16="http://schemas.microsoft.com/office/drawing/2014/main" id="{A1AA1E55-E630-428D-9EE8-4DFF82950746}"/>
+                <a16:creationId xmlns:a16="http://schemas.microsoft.com/office/drawing/2014/main" id="{7991934C-B88B-44EA-B60D-1BD5B95F8C00}"/>
               </a:ext>
             </a:extLst>
           </p:cNvPr>
@@ -23357,7 +23365,7 @@
           <p:cNvPr id="15" name="">
             <a:extLst xmlns:a="http://schemas.openxmlformats.org/drawingml/2006/main">
               <a:ext uri="{FF2B5EF4-FFF2-40B4-BE49-F238E27FC236}">
-                <a16:creationId xmlns:a16="http://schemas.microsoft.com/office/drawing/2014/main" id="{A9BB9742-FE0C-4BF8-A44F-9288444F06BF}"/>
+                <a16:creationId xmlns:a16="http://schemas.microsoft.com/office/drawing/2014/main" id="{5836BC4E-19DA-4BD9-8286-3CFA17A60522}"/>
               </a:ext>
             </a:extLst>
           </p:cNvPr>
@@ -23414,7 +23422,7 @@
           <p:cNvPr id="16" name="">
             <a:extLst xmlns:a="http://schemas.openxmlformats.org/drawingml/2006/main">
               <a:ext uri="{FF2B5EF4-FFF2-40B4-BE49-F238E27FC236}">
-                <a16:creationId xmlns:a16="http://schemas.microsoft.com/office/drawing/2014/main" id="{7251923F-BA7C-4FD3-A80F-79C2C1FAA0C8}"/>
+                <a16:creationId xmlns:a16="http://schemas.microsoft.com/office/drawing/2014/main" id="{E226F0C2-81B2-48D4-BF11-433ECD8E88A5}"/>
               </a:ext>
             </a:extLst>
           </p:cNvPr>
@@ -23471,7 +23479,7 @@
           <p:cNvPr id="17" name="">
             <a:extLst xmlns:a="http://schemas.openxmlformats.org/drawingml/2006/main">
               <a:ext uri="{FF2B5EF4-FFF2-40B4-BE49-F238E27FC236}">
-                <a16:creationId xmlns:a16="http://schemas.microsoft.com/office/drawing/2014/main" id="{2BFB438F-729C-4C18-9D38-2E2A7794E7FC}"/>
+                <a16:creationId xmlns:a16="http://schemas.microsoft.com/office/drawing/2014/main" id="{39A7191B-42AA-400E-B9F9-AB58FCDCE218}"/>
               </a:ext>
             </a:extLst>
           </p:cNvPr>
@@ -23504,7 +23512,7 @@
           <p:cNvPr id="18" name="">
             <a:extLst xmlns:a="http://schemas.openxmlformats.org/drawingml/2006/main">
               <a:ext uri="{FF2B5EF4-FFF2-40B4-BE49-F238E27FC236}">
-                <a16:creationId xmlns:a16="http://schemas.microsoft.com/office/drawing/2014/main" id="{BA48271A-E3B6-4C7A-90FB-7496BEB8804C}"/>
+                <a16:creationId xmlns:a16="http://schemas.microsoft.com/office/drawing/2014/main" id="{90286EA2-F401-4C15-AA6A-94481EFB844F}"/>
               </a:ext>
             </a:extLst>
           </p:cNvPr>
@@ -23539,7 +23547,7 @@
           <p:cNvPr id="19" name="">
             <a:extLst xmlns:a="http://schemas.openxmlformats.org/drawingml/2006/main">
               <a:ext uri="{FF2B5EF4-FFF2-40B4-BE49-F238E27FC236}">
-                <a16:creationId xmlns:a16="http://schemas.microsoft.com/office/drawing/2014/main" id="{752C3519-3135-4F33-9F4E-AB9C65C5975F}"/>
+                <a16:creationId xmlns:a16="http://schemas.microsoft.com/office/drawing/2014/main" id="{CD7296B2-3072-4005-86F0-F8EA2F4E38BC}"/>
               </a:ext>
             </a:extLst>
           </p:cNvPr>
@@ -23596,7 +23604,7 @@
           <p:cNvPr id="20" name="">
             <a:extLst xmlns:a="http://schemas.openxmlformats.org/drawingml/2006/main">
               <a:ext uri="{FF2B5EF4-FFF2-40B4-BE49-F238E27FC236}">
-                <a16:creationId xmlns:a16="http://schemas.microsoft.com/office/drawing/2014/main" id="{E3E5ECBC-DE3B-4BBB-8929-32609CF28BB2}"/>
+                <a16:creationId xmlns:a16="http://schemas.microsoft.com/office/drawing/2014/main" id="{3B685F18-540C-412E-BF03-03A4084D9C23}"/>
               </a:ext>
             </a:extLst>
           </p:cNvPr>
@@ -23653,7 +23661,7 @@
           <p:cNvPr id="21" name="">
             <a:extLst xmlns:a="http://schemas.openxmlformats.org/drawingml/2006/main">
               <a:ext uri="{FF2B5EF4-FFF2-40B4-BE49-F238E27FC236}">
-                <a16:creationId xmlns:a16="http://schemas.microsoft.com/office/drawing/2014/main" id="{04EFB808-E302-4445-ACAF-01897C89D611}"/>
+                <a16:creationId xmlns:a16="http://schemas.microsoft.com/office/drawing/2014/main" id="{095C1168-8EA1-445F-90B1-1F0F91B2FCD6}"/>
               </a:ext>
             </a:extLst>
           </p:cNvPr>
@@ -23686,7 +23694,7 @@
           <p:cNvPr id="22" name="">
             <a:extLst xmlns:a="http://schemas.openxmlformats.org/drawingml/2006/main">
               <a:ext uri="{FF2B5EF4-FFF2-40B4-BE49-F238E27FC236}">
-                <a16:creationId xmlns:a16="http://schemas.microsoft.com/office/drawing/2014/main" id="{FCCDD2DB-85E6-479B-85F7-16A2CE00E4D9}"/>
+                <a16:creationId xmlns:a16="http://schemas.microsoft.com/office/drawing/2014/main" id="{B520A5A0-E2A7-463D-B8B2-964A7B97218A}"/>
               </a:ext>
             </a:extLst>
           </p:cNvPr>
@@ -23721,7 +23729,7 @@
           <p:cNvPr id="23" name="">
             <a:extLst xmlns:a="http://schemas.openxmlformats.org/drawingml/2006/main">
               <a:ext uri="{FF2B5EF4-FFF2-40B4-BE49-F238E27FC236}">
-                <a16:creationId xmlns:a16="http://schemas.microsoft.com/office/drawing/2014/main" id="{1421378F-C122-4EB6-AD2D-F13631DECC48}"/>
+                <a16:creationId xmlns:a16="http://schemas.microsoft.com/office/drawing/2014/main" id="{54F62B22-4E48-413D-9731-C19D8611E9B4}"/>
               </a:ext>
             </a:extLst>
           </p:cNvPr>
@@ -23778,7 +23786,7 @@
           <p:cNvPr id="24" name="">
             <a:extLst xmlns:a="http://schemas.openxmlformats.org/drawingml/2006/main">
               <a:ext uri="{FF2B5EF4-FFF2-40B4-BE49-F238E27FC236}">
-                <a16:creationId xmlns:a16="http://schemas.microsoft.com/office/drawing/2014/main" id="{66505B91-0630-42CD-B4F1-050C5693D101}"/>
+                <a16:creationId xmlns:a16="http://schemas.microsoft.com/office/drawing/2014/main" id="{FE9F2E76-E7CE-4F38-9BFC-0F788FDBD690}"/>
               </a:ext>
             </a:extLst>
           </p:cNvPr>
@@ -23835,7 +23843,7 @@
           <p:cNvPr id="25" name="">
             <a:extLst xmlns:a="http://schemas.openxmlformats.org/drawingml/2006/main">
               <a:ext uri="{FF2B5EF4-FFF2-40B4-BE49-F238E27FC236}">
-                <a16:creationId xmlns:a16="http://schemas.microsoft.com/office/drawing/2014/main" id="{65581F65-BDB0-476A-93E1-1D98E54214CF}"/>
+                <a16:creationId xmlns:a16="http://schemas.microsoft.com/office/drawing/2014/main" id="{A0136ED9-A530-415A-A33A-DF2A3D57E90A}"/>
               </a:ext>
             </a:extLst>
           </p:cNvPr>
@@ -23866,7 +23874,7 @@
           <p:cNvPr id="26" name="">
             <a:extLst xmlns:a="http://schemas.openxmlformats.org/drawingml/2006/main">
               <a:ext uri="{FF2B5EF4-FFF2-40B4-BE49-F238E27FC236}">
-                <a16:creationId xmlns:a16="http://schemas.microsoft.com/office/drawing/2014/main" id="{E12F4CB0-789A-4D0B-9066-0BB703485B98}"/>
+                <a16:creationId xmlns:a16="http://schemas.microsoft.com/office/drawing/2014/main" id="{786956E4-AA9B-472A-8BCA-AECF4BAFB394}"/>
               </a:ext>
             </a:extLst>
           </p:cNvPr>
@@ -23897,7 +23905,7 @@
           <p:cNvPr id="27" name="">
             <a:extLst xmlns:a="http://schemas.openxmlformats.org/drawingml/2006/main">
               <a:ext uri="{FF2B5EF4-FFF2-40B4-BE49-F238E27FC236}">
-                <a16:creationId xmlns:a16="http://schemas.microsoft.com/office/drawing/2014/main" id="{E90A7680-54F1-4656-9F3E-052F7929A1C2}"/>
+                <a16:creationId xmlns:a16="http://schemas.microsoft.com/office/drawing/2014/main" id="{7214710D-8A15-40B2-A319-0F61F9951980}"/>
               </a:ext>
             </a:extLst>
           </p:cNvPr>
@@ -23929,7 +23937,7 @@
           <p:cNvPr id="28" name="">
             <a:extLst xmlns:a="http://schemas.openxmlformats.org/drawingml/2006/main">
               <a:ext uri="{FF2B5EF4-FFF2-40B4-BE49-F238E27FC236}">
-                <a16:creationId xmlns:a16="http://schemas.microsoft.com/office/drawing/2014/main" id="{5E10975E-374A-4169-A334-FE2CAF93A9A2}"/>
+                <a16:creationId xmlns:a16="http://schemas.microsoft.com/office/drawing/2014/main" id="{7C770962-5FD3-469C-8F9F-E78FA88F9DD1}"/>
               </a:ext>
             </a:extLst>
           </p:cNvPr>
@@ -23960,7 +23968,7 @@
           <p:cNvPr id="29" name="">
             <a:extLst xmlns:a="http://schemas.openxmlformats.org/drawingml/2006/main">
               <a:ext uri="{FF2B5EF4-FFF2-40B4-BE49-F238E27FC236}">
-                <a16:creationId xmlns:a16="http://schemas.microsoft.com/office/drawing/2014/main" id="{C0FE52EA-CBD8-4D43-B4D8-AC4205169573}"/>
+                <a16:creationId xmlns:a16="http://schemas.microsoft.com/office/drawing/2014/main" id="{6ED6AB2E-EC9F-4055-9469-B3E532573A82}"/>
               </a:ext>
             </a:extLst>
           </p:cNvPr>
@@ -23991,7 +23999,7 @@
           <p:cNvPr id="30" name="">
             <a:extLst xmlns:a="http://schemas.openxmlformats.org/drawingml/2006/main">
               <a:ext uri="{FF2B5EF4-FFF2-40B4-BE49-F238E27FC236}">
-                <a16:creationId xmlns:a16="http://schemas.microsoft.com/office/drawing/2014/main" id="{3EC0BFB9-6218-47DC-B9C1-D663A88523F2}"/>
+                <a16:creationId xmlns:a16="http://schemas.microsoft.com/office/drawing/2014/main" id="{4958B054-8E11-464E-89B9-E118CF0660E5}"/>
               </a:ext>
             </a:extLst>
           </p:cNvPr>
@@ -24023,7 +24031,7 @@
           <p:cNvPr id="31" name="">
             <a:extLst xmlns:a="http://schemas.openxmlformats.org/drawingml/2006/main">
               <a:ext uri="{FF2B5EF4-FFF2-40B4-BE49-F238E27FC236}">
-                <a16:creationId xmlns:a16="http://schemas.microsoft.com/office/drawing/2014/main" id="{5443A643-9FBB-49DB-AA53-0CB59D3E3D45}"/>
+                <a16:creationId xmlns:a16="http://schemas.microsoft.com/office/drawing/2014/main" id="{66AE607A-A717-4D27-BF49-F5DE1C1A6D8C}"/>
               </a:ext>
             </a:extLst>
           </p:cNvPr>
@@ -24054,7 +24062,7 @@
           <p:cNvPr id="32" name="">
             <a:extLst xmlns:a="http://schemas.openxmlformats.org/drawingml/2006/main">
               <a:ext uri="{FF2B5EF4-FFF2-40B4-BE49-F238E27FC236}">
-                <a16:creationId xmlns:a16="http://schemas.microsoft.com/office/drawing/2014/main" id="{4C5FFDDF-4D03-4AF6-97AC-74F0401FEEA0}"/>
+                <a16:creationId xmlns:a16="http://schemas.microsoft.com/office/drawing/2014/main" id="{3E1ED41F-7DEE-4AEC-9649-80A4CE341532}"/>
               </a:ext>
             </a:extLst>
           </p:cNvPr>
@@ -24085,7 +24093,7 @@
           <p:cNvPr id="33" name="">
             <a:extLst xmlns:a="http://schemas.openxmlformats.org/drawingml/2006/main">
               <a:ext uri="{FF2B5EF4-FFF2-40B4-BE49-F238E27FC236}">
-                <a16:creationId xmlns:a16="http://schemas.microsoft.com/office/drawing/2014/main" id="{429073DC-22EA-421E-8138-EB4B90B162D4}"/>
+                <a16:creationId xmlns:a16="http://schemas.microsoft.com/office/drawing/2014/main" id="{47629F93-3722-4585-8D08-8C84E38CBBCB}"/>
               </a:ext>
             </a:extLst>
           </p:cNvPr>
@@ -24117,7 +24125,7 @@
           <p:cNvPr id="34" name="">
             <a:extLst xmlns:a="http://schemas.openxmlformats.org/drawingml/2006/main">
               <a:ext uri="{FF2B5EF4-FFF2-40B4-BE49-F238E27FC236}">
-                <a16:creationId xmlns:a16="http://schemas.microsoft.com/office/drawing/2014/main" id="{1AF7F5BC-8FB0-4EF4-BBC3-9D5E86A93C15}"/>
+                <a16:creationId xmlns:a16="http://schemas.microsoft.com/office/drawing/2014/main" id="{9A81B71F-05EC-47FE-93AD-D489618FCA5A}"/>
               </a:ext>
             </a:extLst>
           </p:cNvPr>
@@ -24148,7 +24156,7 @@
           <p:cNvPr id="35" name="">
             <a:extLst xmlns:a="http://schemas.openxmlformats.org/drawingml/2006/main">
               <a:ext uri="{FF2B5EF4-FFF2-40B4-BE49-F238E27FC236}">
-                <a16:creationId xmlns:a16="http://schemas.microsoft.com/office/drawing/2014/main" id="{4E657781-7532-4A4E-AACB-EA7C52F86510}"/>
+                <a16:creationId xmlns:a16="http://schemas.microsoft.com/office/drawing/2014/main" id="{351C6E18-79E7-4170-B8C1-7DFB71F970EF}"/>
               </a:ext>
             </a:extLst>
           </p:cNvPr>
@@ -24179,7 +24187,7 @@
           <p:cNvPr id="36" name="">
             <a:extLst xmlns:a="http://schemas.openxmlformats.org/drawingml/2006/main">
               <a:ext uri="{FF2B5EF4-FFF2-40B4-BE49-F238E27FC236}">
-                <a16:creationId xmlns:a16="http://schemas.microsoft.com/office/drawing/2014/main" id="{010A66C4-7E40-476A-ABFE-38D7773C1124}"/>
+                <a16:creationId xmlns:a16="http://schemas.microsoft.com/office/drawing/2014/main" id="{44D5C024-B698-4CEA-BB57-3D6BAB321B6C}"/>
               </a:ext>
             </a:extLst>
           </p:cNvPr>
@@ -24211,7 +24219,7 @@
           <p:cNvPr id="37" name="">
             <a:extLst xmlns:a="http://schemas.openxmlformats.org/drawingml/2006/main">
               <a:ext uri="{FF2B5EF4-FFF2-40B4-BE49-F238E27FC236}">
-                <a16:creationId xmlns:a16="http://schemas.microsoft.com/office/drawing/2014/main" id="{AD9BF3EE-8429-42DF-B2CF-B15C9B974D43}"/>
+                <a16:creationId xmlns:a16="http://schemas.microsoft.com/office/drawing/2014/main" id="{5C596FA3-D0EC-4B4D-B414-52C9231D6262}"/>
               </a:ext>
             </a:extLst>
           </p:cNvPr>
@@ -24244,7 +24252,7 @@
           <p:cNvPr id="38" name="">
             <a:extLst xmlns:a="http://schemas.openxmlformats.org/drawingml/2006/main">
               <a:ext uri="{FF2B5EF4-FFF2-40B4-BE49-F238E27FC236}">
-                <a16:creationId xmlns:a16="http://schemas.microsoft.com/office/drawing/2014/main" id="{B4BA2941-0AC5-4145-8358-DFCA39F6AB7E}"/>
+                <a16:creationId xmlns:a16="http://schemas.microsoft.com/office/drawing/2014/main" id="{10452DBC-10B6-46A0-828B-1F12115C8628}"/>
               </a:ext>
             </a:extLst>
           </p:cNvPr>
@@ -24279,7 +24287,7 @@
           <p:cNvPr id="39" name="">
             <a:extLst xmlns:a="http://schemas.openxmlformats.org/drawingml/2006/main">
               <a:ext uri="{FF2B5EF4-FFF2-40B4-BE49-F238E27FC236}">
-                <a16:creationId xmlns:a16="http://schemas.microsoft.com/office/drawing/2014/main" id="{40878ED6-CDBD-4588-B8AE-0D8922A24F1A}"/>
+                <a16:creationId xmlns:a16="http://schemas.microsoft.com/office/drawing/2014/main" id="{9B49104F-3B9C-4556-84B4-1E8972399619}"/>
               </a:ext>
             </a:extLst>
           </p:cNvPr>
@@ -24336,7 +24344,7 @@
           <p:cNvPr id="40" name="">
             <a:extLst xmlns:a="http://schemas.openxmlformats.org/drawingml/2006/main">
               <a:ext uri="{FF2B5EF4-FFF2-40B4-BE49-F238E27FC236}">
-                <a16:creationId xmlns:a16="http://schemas.microsoft.com/office/drawing/2014/main" id="{0519A626-46FA-4D08-A123-26EBEA41B6D7}"/>
+                <a16:creationId xmlns:a16="http://schemas.microsoft.com/office/drawing/2014/main" id="{3A8FB098-E74C-417F-9A37-12EAE2D3DA33}"/>
               </a:ext>
             </a:extLst>
           </p:cNvPr>
@@ -24393,7 +24401,7 @@
           <p:cNvPr id="41" name="">
             <a:extLst xmlns:a="http://schemas.openxmlformats.org/drawingml/2006/main">
               <a:ext uri="{FF2B5EF4-FFF2-40B4-BE49-F238E27FC236}">
-                <a16:creationId xmlns:a16="http://schemas.microsoft.com/office/drawing/2014/main" id="{1E36C716-C479-4623-B33D-AA7F732CFFB6}"/>
+                <a16:creationId xmlns:a16="http://schemas.microsoft.com/office/drawing/2014/main" id="{3FFBDA5A-86FB-46DF-AD32-DABF2483CB78}"/>
               </a:ext>
             </a:extLst>
           </p:cNvPr>
@@ -24448,7 +24456,7 @@
     </p:spTree>
     <p:extLst>
       <p:ext uri="{BB962C8B-B14F-4D97-AF65-F5344CB8AC3E}">
-        <p14:creationId xmlns:p14="http://schemas.microsoft.com/office/powerpoint/2010/main" val="425988009"/>
+        <p14:creationId xmlns:p14="http://schemas.microsoft.com/office/powerpoint/2010/main" val="264666215"/>
       </p:ext>
     </p:extLst>
   </p:cSld>
@@ -24479,7 +24487,7 @@
           <p:cNvPr id="32" name="">
             <a:extLst xmlns:a="http://schemas.openxmlformats.org/drawingml/2006/main">
               <a:ext uri="{FF2B5EF4-FFF2-40B4-BE49-F238E27FC236}">
-                <a16:creationId xmlns:a16="http://schemas.microsoft.com/office/drawing/2014/main" id="{485E8E7F-EBE2-41CD-9BA8-1960F1CB883D}"/>
+                <a16:creationId xmlns:a16="http://schemas.microsoft.com/office/drawing/2014/main" id="{24958983-B59C-4901-AAB6-638BA22AF7A1}"/>
               </a:ext>
             </a:extLst>
           </p:cNvPr>
@@ -24510,7 +24518,7 @@
           <p:cNvPr id="2" name="">
             <a:extLst xmlns:a="http://schemas.openxmlformats.org/drawingml/2006/main">
               <a:ext uri="{FF2B5EF4-FFF2-40B4-BE49-F238E27FC236}">
-                <a16:creationId xmlns:a16="http://schemas.microsoft.com/office/drawing/2014/main" id="{1FE7A5E1-677A-48B1-BE72-FE5AB582CD17}"/>
+                <a16:creationId xmlns:a16="http://schemas.microsoft.com/office/drawing/2014/main" id="{54047B27-71C4-4945-A7FB-0E2379651C20}"/>
               </a:ext>
             </a:extLst>
           </p:cNvPr>
@@ -24541,7 +24549,7 @@
           <p:cNvPr id="3" name="">
             <a:extLst xmlns:a="http://schemas.openxmlformats.org/drawingml/2006/main">
               <a:ext uri="{FF2B5EF4-FFF2-40B4-BE49-F238E27FC236}">
-                <a16:creationId xmlns:a16="http://schemas.microsoft.com/office/drawing/2014/main" id="{5E3FAFD1-F66A-4105-A9B8-B9E8DFB043E3}"/>
+                <a16:creationId xmlns:a16="http://schemas.microsoft.com/office/drawing/2014/main" id="{3120810C-63D9-41CF-B7AA-CDA8120B2032}"/>
               </a:ext>
             </a:extLst>
           </p:cNvPr>
@@ -24598,7 +24606,7 @@
           <p:cNvPr id="4" name="">
             <a:extLst xmlns:a="http://schemas.openxmlformats.org/drawingml/2006/main">
               <a:ext uri="{FF2B5EF4-FFF2-40B4-BE49-F238E27FC236}">
-                <a16:creationId xmlns:a16="http://schemas.microsoft.com/office/drawing/2014/main" id="{A355C3E4-3B0A-45CF-A8D6-9B68620C35C1}"/>
+                <a16:creationId xmlns:a16="http://schemas.microsoft.com/office/drawing/2014/main" id="{C6CF4D49-3488-4BF0-B29E-F7208726C138}"/>
               </a:ext>
             </a:extLst>
           </p:cNvPr>
@@ -24655,7 +24663,7 @@
           <p:cNvPr id="5" name="">
             <a:extLst xmlns:a="http://schemas.openxmlformats.org/drawingml/2006/main">
               <a:ext uri="{FF2B5EF4-FFF2-40B4-BE49-F238E27FC236}">
-                <a16:creationId xmlns:a16="http://schemas.microsoft.com/office/drawing/2014/main" id="{EE5CCA38-2329-4A78-8969-005D2923FE35}"/>
+                <a16:creationId xmlns:a16="http://schemas.microsoft.com/office/drawing/2014/main" id="{92EDFA4C-B0AB-4B53-8A56-EE47138CD734}"/>
               </a:ext>
             </a:extLst>
           </p:cNvPr>
@@ -24688,7 +24696,7 @@
           <p:cNvPr id="6" name="">
             <a:extLst xmlns:a="http://schemas.openxmlformats.org/drawingml/2006/main">
               <a:ext uri="{FF2B5EF4-FFF2-40B4-BE49-F238E27FC236}">
-                <a16:creationId xmlns:a16="http://schemas.microsoft.com/office/drawing/2014/main" id="{24C0A383-1EC8-43AA-AF7D-88FDC56C55C7}"/>
+                <a16:creationId xmlns:a16="http://schemas.microsoft.com/office/drawing/2014/main" id="{B8398D1A-CAFF-40B8-A785-45E6AC0CAB66}"/>
               </a:ext>
             </a:extLst>
           </p:cNvPr>
@@ -24723,7 +24731,7 @@
           <p:cNvPr id="7" name="">
             <a:extLst xmlns:a="http://schemas.openxmlformats.org/drawingml/2006/main">
               <a:ext uri="{FF2B5EF4-FFF2-40B4-BE49-F238E27FC236}">
-                <a16:creationId xmlns:a16="http://schemas.microsoft.com/office/drawing/2014/main" id="{D5869453-C47A-44E6-A3EE-43421EDAAD49}"/>
+                <a16:creationId xmlns:a16="http://schemas.microsoft.com/office/drawing/2014/main" id="{5EE26E8C-1718-4866-9DB6-7DBC01C58288}"/>
               </a:ext>
             </a:extLst>
           </p:cNvPr>
@@ -24780,7 +24788,7 @@
           <p:cNvPr id="8" name="">
             <a:extLst xmlns:a="http://schemas.openxmlformats.org/drawingml/2006/main">
               <a:ext uri="{FF2B5EF4-FFF2-40B4-BE49-F238E27FC236}">
-                <a16:creationId xmlns:a16="http://schemas.microsoft.com/office/drawing/2014/main" id="{E3F25DCC-C1FF-4233-B134-B6A7353613FF}"/>
+                <a16:creationId xmlns:a16="http://schemas.microsoft.com/office/drawing/2014/main" id="{57C4701A-7508-43AD-8191-D6CED1EE6C45}"/>
               </a:ext>
             </a:extLst>
           </p:cNvPr>
@@ -24837,7 +24845,7 @@
           <p:cNvPr id="9" name="">
             <a:extLst xmlns:a="http://schemas.openxmlformats.org/drawingml/2006/main">
               <a:ext uri="{FF2B5EF4-FFF2-40B4-BE49-F238E27FC236}">
-                <a16:creationId xmlns:a16="http://schemas.microsoft.com/office/drawing/2014/main" id="{D60250B1-BCBE-4DA0-A8F8-452D9CA1326A}"/>
+                <a16:creationId xmlns:a16="http://schemas.microsoft.com/office/drawing/2014/main" id="{E71286FC-5F6F-46FE-BD8A-1FCEE3470E66}"/>
               </a:ext>
             </a:extLst>
           </p:cNvPr>
@@ -24894,7 +24902,7 @@
           <p:cNvPr id="10" name="">
             <a:extLst xmlns:a="http://schemas.openxmlformats.org/drawingml/2006/main">
               <a:ext uri="{FF2B5EF4-FFF2-40B4-BE49-F238E27FC236}">
-                <a16:creationId xmlns:a16="http://schemas.microsoft.com/office/drawing/2014/main" id="{BACC506A-33C0-413D-A624-0BD112F6BC37}"/>
+                <a16:creationId xmlns:a16="http://schemas.microsoft.com/office/drawing/2014/main" id="{D7A4DA58-55EE-4B1F-AD3A-85636498A250}"/>
               </a:ext>
             </a:extLst>
           </p:cNvPr>
@@ -24927,7 +24935,7 @@
           <p:cNvPr id="11" name="">
             <a:extLst xmlns:a="http://schemas.openxmlformats.org/drawingml/2006/main">
               <a:ext uri="{FF2B5EF4-FFF2-40B4-BE49-F238E27FC236}">
-                <a16:creationId xmlns:a16="http://schemas.microsoft.com/office/drawing/2014/main" id="{FDFC9CDB-A74C-4E29-96E8-AA47320C1959}"/>
+                <a16:creationId xmlns:a16="http://schemas.microsoft.com/office/drawing/2014/main" id="{6AB5E5D3-F721-4257-A353-4C119238A2A7}"/>
               </a:ext>
             </a:extLst>
           </p:cNvPr>
@@ -24962,7 +24970,7 @@
           <p:cNvPr id="12" name="">
             <a:extLst xmlns:a="http://schemas.openxmlformats.org/drawingml/2006/main">
               <a:ext uri="{FF2B5EF4-FFF2-40B4-BE49-F238E27FC236}">
-                <a16:creationId xmlns:a16="http://schemas.microsoft.com/office/drawing/2014/main" id="{AFF06EF0-E285-4A2B-B032-6AF035DBF485}"/>
+                <a16:creationId xmlns:a16="http://schemas.microsoft.com/office/drawing/2014/main" id="{DCEEC94F-4C17-42A5-A101-591BFB9B84D7}"/>
               </a:ext>
             </a:extLst>
           </p:cNvPr>
@@ -25019,7 +25027,7 @@
           <p:cNvPr id="13" name="">
             <a:extLst xmlns:a="http://schemas.openxmlformats.org/drawingml/2006/main">
               <a:ext uri="{FF2B5EF4-FFF2-40B4-BE49-F238E27FC236}">
-                <a16:creationId xmlns:a16="http://schemas.microsoft.com/office/drawing/2014/main" id="{DD19880A-4069-4677-B84D-02D13C5D4C09}"/>
+                <a16:creationId xmlns:a16="http://schemas.microsoft.com/office/drawing/2014/main" id="{420A0B8F-B24D-4810-AB31-890C3289A473}"/>
               </a:ext>
             </a:extLst>
           </p:cNvPr>
@@ -25076,7 +25084,7 @@
           <p:cNvPr id="14" name="">
             <a:extLst xmlns:a="http://schemas.openxmlformats.org/drawingml/2006/main">
               <a:ext uri="{FF2B5EF4-FFF2-40B4-BE49-F238E27FC236}">
-                <a16:creationId xmlns:a16="http://schemas.microsoft.com/office/drawing/2014/main" id="{7B69FC81-2934-4107-BBFA-ACEFBEA99DE6}"/>
+                <a16:creationId xmlns:a16="http://schemas.microsoft.com/office/drawing/2014/main" id="{DF7B2E48-9543-4622-AD08-63821A17F04A}"/>
               </a:ext>
             </a:extLst>
           </p:cNvPr>
@@ -25133,7 +25141,7 @@
           <p:cNvPr id="15" name="">
             <a:extLst xmlns:a="http://schemas.openxmlformats.org/drawingml/2006/main">
               <a:ext uri="{FF2B5EF4-FFF2-40B4-BE49-F238E27FC236}">
-                <a16:creationId xmlns:a16="http://schemas.microsoft.com/office/drawing/2014/main" id="{963F9338-9CBB-40FF-A730-875C4A87422A}"/>
+                <a16:creationId xmlns:a16="http://schemas.microsoft.com/office/drawing/2014/main" id="{475B457A-E8B3-4A0A-A502-1631F3247FAB}"/>
               </a:ext>
             </a:extLst>
           </p:cNvPr>
@@ -25166,7 +25174,7 @@
           <p:cNvPr id="16" name="">
             <a:extLst xmlns:a="http://schemas.openxmlformats.org/drawingml/2006/main">
               <a:ext uri="{FF2B5EF4-FFF2-40B4-BE49-F238E27FC236}">
-                <a16:creationId xmlns:a16="http://schemas.microsoft.com/office/drawing/2014/main" id="{6DB0ACEF-DD05-4D7A-9069-68A59BFB8612}"/>
+                <a16:creationId xmlns:a16="http://schemas.microsoft.com/office/drawing/2014/main" id="{3CC6A95F-ECEE-47CF-BCB7-BADAB59E5B62}"/>
               </a:ext>
             </a:extLst>
           </p:cNvPr>
@@ -25201,7 +25209,7 @@
           <p:cNvPr id="17" name="">
             <a:extLst xmlns:a="http://schemas.openxmlformats.org/drawingml/2006/main">
               <a:ext uri="{FF2B5EF4-FFF2-40B4-BE49-F238E27FC236}">
-                <a16:creationId xmlns:a16="http://schemas.microsoft.com/office/drawing/2014/main" id="{B2B57DE6-9AED-4DDA-B740-31D68B3B8320}"/>
+                <a16:creationId xmlns:a16="http://schemas.microsoft.com/office/drawing/2014/main" id="{F90CFC6A-5CBF-4568-BC61-3748EF526CA1}"/>
               </a:ext>
             </a:extLst>
           </p:cNvPr>
@@ -25258,7 +25266,7 @@
           <p:cNvPr id="18" name="">
             <a:extLst xmlns:a="http://schemas.openxmlformats.org/drawingml/2006/main">
               <a:ext uri="{FF2B5EF4-FFF2-40B4-BE49-F238E27FC236}">
-                <a16:creationId xmlns:a16="http://schemas.microsoft.com/office/drawing/2014/main" id="{DEB7B280-EA52-4BC7-9B69-3BCA38C85DC0}"/>
+                <a16:creationId xmlns:a16="http://schemas.microsoft.com/office/drawing/2014/main" id="{E52B820C-8DD0-4722-857D-965131EEE666}"/>
               </a:ext>
             </a:extLst>
           </p:cNvPr>
@@ -25315,7 +25323,7 @@
           <p:cNvPr id="19" name="">
             <a:extLst xmlns:a="http://schemas.openxmlformats.org/drawingml/2006/main">
               <a:ext uri="{FF2B5EF4-FFF2-40B4-BE49-F238E27FC236}">
-                <a16:creationId xmlns:a16="http://schemas.microsoft.com/office/drawing/2014/main" id="{8682B669-CE58-45E0-B977-0800996B73D2}"/>
+                <a16:creationId xmlns:a16="http://schemas.microsoft.com/office/drawing/2014/main" id="{5E244FF3-F760-48A8-9BF5-97F0A334DEC7}"/>
               </a:ext>
             </a:extLst>
           </p:cNvPr>
@@ -25372,7 +25380,7 @@
           <p:cNvPr id="20" name="">
             <a:extLst xmlns:a="http://schemas.openxmlformats.org/drawingml/2006/main">
               <a:ext uri="{FF2B5EF4-FFF2-40B4-BE49-F238E27FC236}">
-                <a16:creationId xmlns:a16="http://schemas.microsoft.com/office/drawing/2014/main" id="{2600F1E6-70FF-4EA4-91A3-50B87A52E1DC}"/>
+                <a16:creationId xmlns:a16="http://schemas.microsoft.com/office/drawing/2014/main" id="{4C0A8A43-CBFA-4E2B-A815-2D192532B368}"/>
               </a:ext>
             </a:extLst>
           </p:cNvPr>
@@ -25405,7 +25413,7 @@
           <p:cNvPr id="21" name="">
             <a:extLst xmlns:a="http://schemas.openxmlformats.org/drawingml/2006/main">
               <a:ext uri="{FF2B5EF4-FFF2-40B4-BE49-F238E27FC236}">
-                <a16:creationId xmlns:a16="http://schemas.microsoft.com/office/drawing/2014/main" id="{AB462B4A-CD31-45A1-B681-1E1B7D86CB38}"/>
+                <a16:creationId xmlns:a16="http://schemas.microsoft.com/office/drawing/2014/main" id="{9A3375D5-A610-4A60-965E-F0E109489809}"/>
               </a:ext>
             </a:extLst>
           </p:cNvPr>
@@ -25440,7 +25448,7 @@
           <p:cNvPr id="22" name="">
             <a:extLst xmlns:a="http://schemas.openxmlformats.org/drawingml/2006/main">
               <a:ext uri="{FF2B5EF4-FFF2-40B4-BE49-F238E27FC236}">
-                <a16:creationId xmlns:a16="http://schemas.microsoft.com/office/drawing/2014/main" id="{40657CB3-9002-4030-B3A8-218B0893D96E}"/>
+                <a16:creationId xmlns:a16="http://schemas.microsoft.com/office/drawing/2014/main" id="{78D07567-BD2F-48BC-97AB-8E166C840EC8}"/>
               </a:ext>
             </a:extLst>
           </p:cNvPr>
@@ -25497,7 +25505,7 @@
           <p:cNvPr id="23" name="">
             <a:extLst xmlns:a="http://schemas.openxmlformats.org/drawingml/2006/main">
               <a:ext uri="{FF2B5EF4-FFF2-40B4-BE49-F238E27FC236}">
-                <a16:creationId xmlns:a16="http://schemas.microsoft.com/office/drawing/2014/main" id="{565F6F2B-987B-4228-9305-74C609B2EC44}"/>
+                <a16:creationId xmlns:a16="http://schemas.microsoft.com/office/drawing/2014/main" id="{AD646DDB-0295-4067-8CC7-578D9D351FD2}"/>
               </a:ext>
             </a:extLst>
           </p:cNvPr>
@@ -25554,7 +25562,7 @@
           <p:cNvPr id="24" name="">
             <a:extLst xmlns:a="http://schemas.openxmlformats.org/drawingml/2006/main">
               <a:ext uri="{FF2B5EF4-FFF2-40B4-BE49-F238E27FC236}">
-                <a16:creationId xmlns:a16="http://schemas.microsoft.com/office/drawing/2014/main" id="{1EEA98BC-E137-448B-9376-5776F48EBA54}"/>
+                <a16:creationId xmlns:a16="http://schemas.microsoft.com/office/drawing/2014/main" id="{974ADF4F-FE23-4E75-8025-061F3AD3A5F8}"/>
               </a:ext>
             </a:extLst>
           </p:cNvPr>
@@ -25611,7 +25619,7 @@
           <p:cNvPr id="25" name="">
             <a:extLst xmlns:a="http://schemas.openxmlformats.org/drawingml/2006/main">
               <a:ext uri="{FF2B5EF4-FFF2-40B4-BE49-F238E27FC236}">
-                <a16:creationId xmlns:a16="http://schemas.microsoft.com/office/drawing/2014/main" id="{47B10010-A8A2-4B00-8D6B-ECF6111D3A7F}"/>
+                <a16:creationId xmlns:a16="http://schemas.microsoft.com/office/drawing/2014/main" id="{B7B7E177-E153-4167-A40E-CA82E7ED620C}"/>
               </a:ext>
             </a:extLst>
           </p:cNvPr>
@@ -25644,7 +25652,7 @@
           <p:cNvPr id="26" name="">
             <a:extLst xmlns:a="http://schemas.openxmlformats.org/drawingml/2006/main">
               <a:ext uri="{FF2B5EF4-FFF2-40B4-BE49-F238E27FC236}">
-                <a16:creationId xmlns:a16="http://schemas.microsoft.com/office/drawing/2014/main" id="{92CC7923-76A1-4F50-9238-D691E17017BC}"/>
+                <a16:creationId xmlns:a16="http://schemas.microsoft.com/office/drawing/2014/main" id="{CC06EAB7-53CC-42E2-A1D9-F42883EE0507}"/>
               </a:ext>
             </a:extLst>
           </p:cNvPr>
@@ -25679,7 +25687,7 @@
           <p:cNvPr id="27" name="">
             <a:extLst xmlns:a="http://schemas.openxmlformats.org/drawingml/2006/main">
               <a:ext uri="{FF2B5EF4-FFF2-40B4-BE49-F238E27FC236}">
-                <a16:creationId xmlns:a16="http://schemas.microsoft.com/office/drawing/2014/main" id="{2539D127-DA3F-4E5D-90CF-2D0921E0C771}"/>
+                <a16:creationId xmlns:a16="http://schemas.microsoft.com/office/drawing/2014/main" id="{683D588A-7156-44F2-97B7-6942C67FC91F}"/>
               </a:ext>
             </a:extLst>
           </p:cNvPr>
@@ -25736,7 +25744,7 @@
           <p:cNvPr id="28" name="">
             <a:extLst xmlns:a="http://schemas.openxmlformats.org/drawingml/2006/main">
               <a:ext uri="{FF2B5EF4-FFF2-40B4-BE49-F238E27FC236}">
-                <a16:creationId xmlns:a16="http://schemas.microsoft.com/office/drawing/2014/main" id="{F44038C3-F91D-4AB9-9421-C9530EDB7500}"/>
+                <a16:creationId xmlns:a16="http://schemas.microsoft.com/office/drawing/2014/main" id="{85D42C79-EA0F-4E44-807D-6E3B826C0098}"/>
               </a:ext>
             </a:extLst>
           </p:cNvPr>
@@ -25793,7 +25801,7 @@
           <p:cNvPr id="29" name="">
             <a:extLst xmlns:a="http://schemas.openxmlformats.org/drawingml/2006/main">
               <a:ext uri="{FF2B5EF4-FFF2-40B4-BE49-F238E27FC236}">
-                <a16:creationId xmlns:a16="http://schemas.microsoft.com/office/drawing/2014/main" id="{DC4C696B-0BCE-4768-8AF9-F0B20EB2645D}"/>
+                <a16:creationId xmlns:a16="http://schemas.microsoft.com/office/drawing/2014/main" id="{6B03F9F5-23AC-45A8-B7D1-1F987F2995C9}"/>
               </a:ext>
             </a:extLst>
           </p:cNvPr>
@@ -25850,7 +25858,7 @@
           <p:cNvPr id="30" name="">
             <a:extLst xmlns:a="http://schemas.openxmlformats.org/drawingml/2006/main">
               <a:ext uri="{FF2B5EF4-FFF2-40B4-BE49-F238E27FC236}">
-                <a16:creationId xmlns:a16="http://schemas.microsoft.com/office/drawing/2014/main" id="{8ED34DA5-8F86-4CE1-AAC4-DA389F85A210}"/>
+                <a16:creationId xmlns:a16="http://schemas.microsoft.com/office/drawing/2014/main" id="{AAFC0B48-220B-41A1-BFA0-6412D8994399}"/>
               </a:ext>
             </a:extLst>
           </p:cNvPr>
@@ -25907,7 +25915,7 @@
           <p:cNvPr id="31" name="">
             <a:extLst xmlns:a="http://schemas.openxmlformats.org/drawingml/2006/main">
               <a:ext uri="{FF2B5EF4-FFF2-40B4-BE49-F238E27FC236}">
-                <a16:creationId xmlns:a16="http://schemas.microsoft.com/office/drawing/2014/main" id="{BC510A5A-FE11-4301-81EE-FE09D919C37E}"/>
+                <a16:creationId xmlns:a16="http://schemas.microsoft.com/office/drawing/2014/main" id="{744F5461-A67E-4649-AE7F-62062507F119}"/>
               </a:ext>
             </a:extLst>
           </p:cNvPr>
@@ -25962,7 +25970,7 @@
     </p:spTree>
     <p:extLst>
       <p:ext uri="{BB962C8B-B14F-4D97-AF65-F5344CB8AC3E}">
-        <p14:creationId xmlns:p14="http://schemas.microsoft.com/office/powerpoint/2010/main" val="1679338517"/>
+        <p14:creationId xmlns:p14="http://schemas.microsoft.com/office/powerpoint/2010/main" val="1894481074"/>
       </p:ext>
     </p:extLst>
   </p:cSld>
@@ -25993,7 +26001,7 @@
           <p:cNvPr id="30" name="">
             <a:extLst xmlns:a="http://schemas.openxmlformats.org/drawingml/2006/main">
               <a:ext uri="{FF2B5EF4-FFF2-40B4-BE49-F238E27FC236}">
-                <a16:creationId xmlns:a16="http://schemas.microsoft.com/office/drawing/2014/main" id="{F98080BB-5D42-4011-B519-07E4368F64B7}"/>
+                <a16:creationId xmlns:a16="http://schemas.microsoft.com/office/drawing/2014/main" id="{025EF8A1-235C-4A4F-91D6-1E82F25EB6AE}"/>
               </a:ext>
             </a:extLst>
           </p:cNvPr>
@@ -26024,7 +26032,7 @@
           <p:cNvPr id="2" name="">
             <a:extLst xmlns:a="http://schemas.openxmlformats.org/drawingml/2006/main">
               <a:ext uri="{FF2B5EF4-FFF2-40B4-BE49-F238E27FC236}">
-                <a16:creationId xmlns:a16="http://schemas.microsoft.com/office/drawing/2014/main" id="{2E14D6BE-6586-471D-97D6-D866DA37034C}"/>
+                <a16:creationId xmlns:a16="http://schemas.microsoft.com/office/drawing/2014/main" id="{CF04F24B-1B40-4670-8D3B-654BB303ABB8}"/>
               </a:ext>
             </a:extLst>
           </p:cNvPr>
@@ -26055,7 +26063,7 @@
           <p:cNvPr id="3" name="">
             <a:extLst xmlns:a="http://schemas.openxmlformats.org/drawingml/2006/main">
               <a:ext uri="{FF2B5EF4-FFF2-40B4-BE49-F238E27FC236}">
-                <a16:creationId xmlns:a16="http://schemas.microsoft.com/office/drawing/2014/main" id="{A422E986-749C-4203-8139-6AEEA8B79DF3}"/>
+                <a16:creationId xmlns:a16="http://schemas.microsoft.com/office/drawing/2014/main" id="{32D1423D-17F7-4573-89C1-2837F888E638}"/>
               </a:ext>
             </a:extLst>
           </p:cNvPr>
@@ -26112,7 +26120,7 @@
           <p:cNvPr id="4" name="">
             <a:extLst xmlns:a="http://schemas.openxmlformats.org/drawingml/2006/main">
               <a:ext uri="{FF2B5EF4-FFF2-40B4-BE49-F238E27FC236}">
-                <a16:creationId xmlns:a16="http://schemas.microsoft.com/office/drawing/2014/main" id="{BE5E46D3-959B-44AD-B775-8FC218A6C801}"/>
+                <a16:creationId xmlns:a16="http://schemas.microsoft.com/office/drawing/2014/main" id="{86B86EC2-91F8-47D0-AF4C-3F9218AD440E}"/>
               </a:ext>
             </a:extLst>
           </p:cNvPr>
@@ -26169,7 +26177,7 @@
           <p:cNvPr id="5" name="">
             <a:extLst xmlns:a="http://schemas.openxmlformats.org/drawingml/2006/main">
               <a:ext uri="{FF2B5EF4-FFF2-40B4-BE49-F238E27FC236}">
-                <a16:creationId xmlns:a16="http://schemas.microsoft.com/office/drawing/2014/main" id="{8CD0CDF0-83D8-4902-ADEA-2EAC88349E90}"/>
+                <a16:creationId xmlns:a16="http://schemas.microsoft.com/office/drawing/2014/main" id="{48176D83-385B-4E49-9C1A-83D91D506A8F}"/>
               </a:ext>
             </a:extLst>
           </p:cNvPr>
@@ -26202,7 +26210,7 @@
           <p:cNvPr id="6" name="">
             <a:extLst xmlns:a="http://schemas.openxmlformats.org/drawingml/2006/main">
               <a:ext uri="{FF2B5EF4-FFF2-40B4-BE49-F238E27FC236}">
-                <a16:creationId xmlns:a16="http://schemas.microsoft.com/office/drawing/2014/main" id="{5F6FA034-6750-4D19-A977-E4115C2C70A5}"/>
+                <a16:creationId xmlns:a16="http://schemas.microsoft.com/office/drawing/2014/main" id="{600D380A-DC8A-4B02-B59D-84A14CFF61EA}"/>
               </a:ext>
             </a:extLst>
           </p:cNvPr>
@@ -26237,7 +26245,7 @@
           <p:cNvPr id="7" name="">
             <a:extLst xmlns:a="http://schemas.openxmlformats.org/drawingml/2006/main">
               <a:ext uri="{FF2B5EF4-FFF2-40B4-BE49-F238E27FC236}">
-                <a16:creationId xmlns:a16="http://schemas.microsoft.com/office/drawing/2014/main" id="{DDC0547A-5E97-4E02-872D-86C66D1E1AAB}"/>
+                <a16:creationId xmlns:a16="http://schemas.microsoft.com/office/drawing/2014/main" id="{48515710-CD26-42BB-B877-4E192EF418D4}"/>
               </a:ext>
             </a:extLst>
           </p:cNvPr>
@@ -26294,7 +26302,7 @@
           <p:cNvPr id="8" name="">
             <a:extLst xmlns:a="http://schemas.openxmlformats.org/drawingml/2006/main">
               <a:ext uri="{FF2B5EF4-FFF2-40B4-BE49-F238E27FC236}">
-                <a16:creationId xmlns:a16="http://schemas.microsoft.com/office/drawing/2014/main" id="{F7DF8B01-5EEB-45AB-ABB9-FDB06C5A87A4}"/>
+                <a16:creationId xmlns:a16="http://schemas.microsoft.com/office/drawing/2014/main" id="{D8F4D6D9-23D3-44B1-80EA-47CAA3FD8E8E}"/>
               </a:ext>
             </a:extLst>
           </p:cNvPr>
@@ -26351,7 +26359,7 @@
           <p:cNvPr id="9" name="">
             <a:extLst xmlns:a="http://schemas.openxmlformats.org/drawingml/2006/main">
               <a:ext uri="{FF2B5EF4-FFF2-40B4-BE49-F238E27FC236}">
-                <a16:creationId xmlns:a16="http://schemas.microsoft.com/office/drawing/2014/main" id="{CB92B5B8-14F6-4670-A99E-EC6ECE42891A}"/>
+                <a16:creationId xmlns:a16="http://schemas.microsoft.com/office/drawing/2014/main" id="{A70CEEC1-49DB-4248-9945-79682D0D60D2}"/>
               </a:ext>
             </a:extLst>
           </p:cNvPr>
@@ -26384,7 +26392,7 @@
           <p:cNvPr id="10" name="">
             <a:extLst xmlns:a="http://schemas.openxmlformats.org/drawingml/2006/main">
               <a:ext uri="{FF2B5EF4-FFF2-40B4-BE49-F238E27FC236}">
-                <a16:creationId xmlns:a16="http://schemas.microsoft.com/office/drawing/2014/main" id="{B1C1E765-5D79-46BB-B6DF-D6B95396EF0C}"/>
+                <a16:creationId xmlns:a16="http://schemas.microsoft.com/office/drawing/2014/main" id="{2829C878-8202-424C-9B67-5AF021C41C1E}"/>
               </a:ext>
             </a:extLst>
           </p:cNvPr>
@@ -26419,7 +26427,7 @@
           <p:cNvPr id="11" name="">
             <a:extLst xmlns:a="http://schemas.openxmlformats.org/drawingml/2006/main">
               <a:ext uri="{FF2B5EF4-FFF2-40B4-BE49-F238E27FC236}">
-                <a16:creationId xmlns:a16="http://schemas.microsoft.com/office/drawing/2014/main" id="{DD23C447-7D08-423A-AFDF-4EE83ADAA17E}"/>
+                <a16:creationId xmlns:a16="http://schemas.microsoft.com/office/drawing/2014/main" id="{1BB41DAF-DE55-4A92-A4D1-4243C58E02BC}"/>
               </a:ext>
             </a:extLst>
           </p:cNvPr>
@@ -26476,7 +26484,7 @@
           <p:cNvPr id="12" name="">
             <a:extLst xmlns:a="http://schemas.openxmlformats.org/drawingml/2006/main">
               <a:ext uri="{FF2B5EF4-FFF2-40B4-BE49-F238E27FC236}">
-                <a16:creationId xmlns:a16="http://schemas.microsoft.com/office/drawing/2014/main" id="{9A0391CA-C846-4EEA-9C37-F9164F388666}"/>
+                <a16:creationId xmlns:a16="http://schemas.microsoft.com/office/drawing/2014/main" id="{BE2CE23A-03D1-4420-91B7-EAD4F1E8660B}"/>
               </a:ext>
             </a:extLst>
           </p:cNvPr>
@@ -26533,7 +26541,7 @@
           <p:cNvPr id="13" name="">
             <a:extLst xmlns:a="http://schemas.openxmlformats.org/drawingml/2006/main">
               <a:ext uri="{FF2B5EF4-FFF2-40B4-BE49-F238E27FC236}">
-                <a16:creationId xmlns:a16="http://schemas.microsoft.com/office/drawing/2014/main" id="{7C0BAF63-9291-4B87-BF48-6A95FA64F760}"/>
+                <a16:creationId xmlns:a16="http://schemas.microsoft.com/office/drawing/2014/main" id="{68988D34-AF66-41CC-B33D-C5C77D20747C}"/>
               </a:ext>
             </a:extLst>
           </p:cNvPr>
@@ -26564,7 +26572,7 @@
           <p:cNvPr id="14" name="">
             <a:extLst xmlns:a="http://schemas.openxmlformats.org/drawingml/2006/main">
               <a:ext uri="{FF2B5EF4-FFF2-40B4-BE49-F238E27FC236}">
-                <a16:creationId xmlns:a16="http://schemas.microsoft.com/office/drawing/2014/main" id="{74EB8C93-3755-4B41-BCBB-99C67CADB7B7}"/>
+                <a16:creationId xmlns:a16="http://schemas.microsoft.com/office/drawing/2014/main" id="{5C49F1AA-A52F-4858-9220-7D14B830DEA3}"/>
               </a:ext>
             </a:extLst>
           </p:cNvPr>
@@ -26621,7 +26629,7 @@
           <p:cNvPr id="15" name="">
             <a:extLst xmlns:a="http://schemas.openxmlformats.org/drawingml/2006/main">
               <a:ext uri="{FF2B5EF4-FFF2-40B4-BE49-F238E27FC236}">
-                <a16:creationId xmlns:a16="http://schemas.microsoft.com/office/drawing/2014/main" id="{2BA4BF2D-4ED3-4560-83C2-519F0FE83A3F}"/>
+                <a16:creationId xmlns:a16="http://schemas.microsoft.com/office/drawing/2014/main" id="{44C20458-C15D-4EA9-928C-DDE1F1156DF2}"/>
               </a:ext>
             </a:extLst>
           </p:cNvPr>
@@ -26652,7 +26660,7 @@
           <p:cNvPr id="16" name="">
             <a:extLst xmlns:a="http://schemas.openxmlformats.org/drawingml/2006/main">
               <a:ext uri="{FF2B5EF4-FFF2-40B4-BE49-F238E27FC236}">
-                <a16:creationId xmlns:a16="http://schemas.microsoft.com/office/drawing/2014/main" id="{CD0D3CE5-8AF8-4FE0-9493-5C5193E764B4}"/>
+                <a16:creationId xmlns:a16="http://schemas.microsoft.com/office/drawing/2014/main" id="{8C7C2B24-AE19-4B93-96DC-786043A54324}"/>
               </a:ext>
             </a:extLst>
           </p:cNvPr>
@@ -26709,7 +26717,7 @@
           <p:cNvPr id="17" name="">
             <a:extLst xmlns:a="http://schemas.openxmlformats.org/drawingml/2006/main">
               <a:ext uri="{FF2B5EF4-FFF2-40B4-BE49-F238E27FC236}">
-                <a16:creationId xmlns:a16="http://schemas.microsoft.com/office/drawing/2014/main" id="{44BCD01B-BB61-49FB-8C55-EB4A8A1194F5}"/>
+                <a16:creationId xmlns:a16="http://schemas.microsoft.com/office/drawing/2014/main" id="{470B7ADF-E007-45CA-8586-4F73C72D9B5C}"/>
               </a:ext>
             </a:extLst>
           </p:cNvPr>
@@ -26740,7 +26748,7 @@
           <p:cNvPr id="18" name="">
             <a:extLst xmlns:a="http://schemas.openxmlformats.org/drawingml/2006/main">
               <a:ext uri="{FF2B5EF4-FFF2-40B4-BE49-F238E27FC236}">
-                <a16:creationId xmlns:a16="http://schemas.microsoft.com/office/drawing/2014/main" id="{89542936-37C1-4949-AE7C-CBC3583FCC3C}"/>
+                <a16:creationId xmlns:a16="http://schemas.microsoft.com/office/drawing/2014/main" id="{48B7ACF9-4D48-4728-BED5-83CD51C7A1C8}"/>
               </a:ext>
             </a:extLst>
           </p:cNvPr>
@@ -26797,7 +26805,7 @@
           <p:cNvPr id="19" name="">
             <a:extLst xmlns:a="http://schemas.openxmlformats.org/drawingml/2006/main">
               <a:ext uri="{FF2B5EF4-FFF2-40B4-BE49-F238E27FC236}">
-                <a16:creationId xmlns:a16="http://schemas.microsoft.com/office/drawing/2014/main" id="{57509B35-7168-4E5A-A9FE-F22112B870E3}"/>
+                <a16:creationId xmlns:a16="http://schemas.microsoft.com/office/drawing/2014/main" id="{CD516839-B32A-4E09-8CF4-863B845049DB}"/>
               </a:ext>
             </a:extLst>
           </p:cNvPr>
@@ -26828,7 +26836,7 @@
           <p:cNvPr id="20" name="">
             <a:extLst xmlns:a="http://schemas.openxmlformats.org/drawingml/2006/main">
               <a:ext uri="{FF2B5EF4-FFF2-40B4-BE49-F238E27FC236}">
-                <a16:creationId xmlns:a16="http://schemas.microsoft.com/office/drawing/2014/main" id="{2477CD9B-4E1F-4297-A1A8-7933FB0789A9}"/>
+                <a16:creationId xmlns:a16="http://schemas.microsoft.com/office/drawing/2014/main" id="{D0BDA7B7-BCD1-41CC-B3DF-D67690CD357C}"/>
               </a:ext>
             </a:extLst>
           </p:cNvPr>
@@ -26885,7 +26893,7 @@
           <p:cNvPr id="21" name="">
             <a:extLst xmlns:a="http://schemas.openxmlformats.org/drawingml/2006/main">
               <a:ext uri="{FF2B5EF4-FFF2-40B4-BE49-F238E27FC236}">
-                <a16:creationId xmlns:a16="http://schemas.microsoft.com/office/drawing/2014/main" id="{C2193D8D-57B2-48B4-A619-A52AF1B2738A}"/>
+                <a16:creationId xmlns:a16="http://schemas.microsoft.com/office/drawing/2014/main" id="{ADAE8CCA-6DF9-4B92-99D1-7540BADB717E}"/>
               </a:ext>
             </a:extLst>
           </p:cNvPr>
@@ -26916,7 +26924,7 @@
           <p:cNvPr id="22" name="">
             <a:extLst xmlns:a="http://schemas.openxmlformats.org/drawingml/2006/main">
               <a:ext uri="{FF2B5EF4-FFF2-40B4-BE49-F238E27FC236}">
-                <a16:creationId xmlns:a16="http://schemas.microsoft.com/office/drawing/2014/main" id="{BD42277A-FE41-4FAF-BA8F-D6ED803BFA46}"/>
+                <a16:creationId xmlns:a16="http://schemas.microsoft.com/office/drawing/2014/main" id="{CFF54655-C9EC-4554-8E14-4BE787379AD1}"/>
               </a:ext>
             </a:extLst>
           </p:cNvPr>
@@ -26973,7 +26981,7 @@
           <p:cNvPr id="23" name="">
             <a:extLst xmlns:a="http://schemas.openxmlformats.org/drawingml/2006/main">
               <a:ext uri="{FF2B5EF4-FFF2-40B4-BE49-F238E27FC236}">
-                <a16:creationId xmlns:a16="http://schemas.microsoft.com/office/drawing/2014/main" id="{015BFDD1-93E3-4A55-9DF4-6CF2C113D5E4}"/>
+                <a16:creationId xmlns:a16="http://schemas.microsoft.com/office/drawing/2014/main" id="{DE14D2C0-D3AB-4B4C-B85A-53F147B049CC}"/>
               </a:ext>
             </a:extLst>
           </p:cNvPr>
@@ -27004,7 +27012,7 @@
           <p:cNvPr id="24" name="">
             <a:extLst xmlns:a="http://schemas.openxmlformats.org/drawingml/2006/main">
               <a:ext uri="{FF2B5EF4-FFF2-40B4-BE49-F238E27FC236}">
-                <a16:creationId xmlns:a16="http://schemas.microsoft.com/office/drawing/2014/main" id="{DABF0724-0007-410B-828A-95AE9C9FA9E2}"/>
+                <a16:creationId xmlns:a16="http://schemas.microsoft.com/office/drawing/2014/main" id="{4899E7FB-4884-45F7-9BF5-76AFA2934831}"/>
               </a:ext>
             </a:extLst>
           </p:cNvPr>
@@ -27061,7 +27069,7 @@
           <p:cNvPr id="25" name="">
             <a:extLst xmlns:a="http://schemas.openxmlformats.org/drawingml/2006/main">
               <a:ext uri="{FF2B5EF4-FFF2-40B4-BE49-F238E27FC236}">
-                <a16:creationId xmlns:a16="http://schemas.microsoft.com/office/drawing/2014/main" id="{386BFE90-CCC3-4CF1-9866-94E6FAE361F4}"/>
+                <a16:creationId xmlns:a16="http://schemas.microsoft.com/office/drawing/2014/main" id="{BF9A6073-5FA8-4312-95DA-263302E503F5}"/>
               </a:ext>
             </a:extLst>
           </p:cNvPr>
@@ -27092,7 +27100,7 @@
           <p:cNvPr id="26" name="">
             <a:extLst xmlns:a="http://schemas.openxmlformats.org/drawingml/2006/main">
               <a:ext uri="{FF2B5EF4-FFF2-40B4-BE49-F238E27FC236}">
-                <a16:creationId xmlns:a16="http://schemas.microsoft.com/office/drawing/2014/main" id="{EA49F275-FD58-40AB-BD99-7347B24EF557}"/>
+                <a16:creationId xmlns:a16="http://schemas.microsoft.com/office/drawing/2014/main" id="{B8708FB8-A76B-405A-A7A8-9E5C5342DF28}"/>
               </a:ext>
             </a:extLst>
           </p:cNvPr>
@@ -27149,7 +27157,7 @@
           <p:cNvPr id="27" name="">
             <a:extLst xmlns:a="http://schemas.openxmlformats.org/drawingml/2006/main">
               <a:ext uri="{FF2B5EF4-FFF2-40B4-BE49-F238E27FC236}">
-                <a16:creationId xmlns:a16="http://schemas.microsoft.com/office/drawing/2014/main" id="{E7D7498B-D23F-4E59-9EF6-9FA6FDB9E263}"/>
+                <a16:creationId xmlns:a16="http://schemas.microsoft.com/office/drawing/2014/main" id="{BA98470A-79BC-43D3-8E1F-0C9DE7A7BADC}"/>
               </a:ext>
             </a:extLst>
           </p:cNvPr>
@@ -27180,7 +27188,7 @@
           <p:cNvPr id="28" name="">
             <a:extLst xmlns:a="http://schemas.openxmlformats.org/drawingml/2006/main">
               <a:ext uri="{FF2B5EF4-FFF2-40B4-BE49-F238E27FC236}">
-                <a16:creationId xmlns:a16="http://schemas.microsoft.com/office/drawing/2014/main" id="{330EBFEF-7249-46B0-A82F-AF92BE1CC1B5}"/>
+                <a16:creationId xmlns:a16="http://schemas.microsoft.com/office/drawing/2014/main" id="{BC9DD0D6-467C-4F10-A25F-15DDF4F63F81}"/>
               </a:ext>
             </a:extLst>
           </p:cNvPr>
@@ -27237,7 +27245,7 @@
           <p:cNvPr id="29" name="">
             <a:extLst xmlns:a="http://schemas.openxmlformats.org/drawingml/2006/main">
               <a:ext uri="{FF2B5EF4-FFF2-40B4-BE49-F238E27FC236}">
-                <a16:creationId xmlns:a16="http://schemas.microsoft.com/office/drawing/2014/main" id="{109B4252-4B5B-439B-A260-82A1280B9A1C}"/>
+                <a16:creationId xmlns:a16="http://schemas.microsoft.com/office/drawing/2014/main" id="{2446A274-4D06-4524-AA00-4E922A220F74}"/>
               </a:ext>
             </a:extLst>
           </p:cNvPr>
@@ -27292,7 +27300,7 @@
     </p:spTree>
     <p:extLst>
       <p:ext uri="{BB962C8B-B14F-4D97-AF65-F5344CB8AC3E}">
-        <p14:creationId xmlns:p14="http://schemas.microsoft.com/office/powerpoint/2010/main" val="1254468718"/>
+        <p14:creationId xmlns:p14="http://schemas.microsoft.com/office/powerpoint/2010/main" val="1009836421"/>
       </p:ext>
     </p:extLst>
   </p:cSld>

</xml_diff>